<commit_message>
Update research materials with author details and enhance documentation
</commit_message>
<xml_diff>
--- a/docs/submission/research_presentation.pptx
+++ b/docs/submission/research_presentation.pptx
@@ -2,35 +2,35 @@
 <file path=ppt/presentation.xml><?xml version="1.0" encoding="utf-8"?>
 <p:presentation xmlns:p="http://schemas.openxmlformats.org/presentationml/2006/main">
   <p:sldMasterIdLst>
-    <p:sldMasterId xmlns:r="http://schemas.openxmlformats.org/officeDocument/2006/relationships" id="2147483648" r:id="R63634f390ca4494e"/>
+    <p:sldMasterId xmlns:r="http://schemas.openxmlformats.org/officeDocument/2006/relationships" id="2147483648" r:id="R9c6c356a00c24216"/>
   </p:sldMasterIdLst>
   <p:notesMasterIdLst>
-    <p:notesMasterId xmlns:r="http://schemas.openxmlformats.org/officeDocument/2006/relationships" r:id="Rb81dd164ebb945dd"/>
+    <p:notesMasterId xmlns:r="http://schemas.openxmlformats.org/officeDocument/2006/relationships" r:id="Rf62b88b3174744a2"/>
   </p:notesMasterIdLst>
   <p:sldIdLst>
-    <p:sldId xmlns:r="http://schemas.openxmlformats.org/officeDocument/2006/relationships" id="256" r:id="R453ea573088d408b"/>
-    <p:sldId xmlns:r="http://schemas.openxmlformats.org/officeDocument/2006/relationships" id="257" r:id="R7d6e75998f1e4470"/>
-    <p:sldId xmlns:r="http://schemas.openxmlformats.org/officeDocument/2006/relationships" id="258" r:id="Raca049433bbe4635"/>
-    <p:sldId xmlns:r="http://schemas.openxmlformats.org/officeDocument/2006/relationships" id="259" r:id="Rad00815cb4414748"/>
-    <p:sldId xmlns:r="http://schemas.openxmlformats.org/officeDocument/2006/relationships" id="260" r:id="Rbb214b806e7b4012"/>
-    <p:sldId xmlns:r="http://schemas.openxmlformats.org/officeDocument/2006/relationships" id="261" r:id="R89f127f1278e44bf"/>
-    <p:sldId xmlns:r="http://schemas.openxmlformats.org/officeDocument/2006/relationships" id="262" r:id="R1742d71165944e43"/>
-    <p:sldId xmlns:r="http://schemas.openxmlformats.org/officeDocument/2006/relationships" id="263" r:id="R24b6832e62594990"/>
-    <p:sldId xmlns:r="http://schemas.openxmlformats.org/officeDocument/2006/relationships" id="264" r:id="Rb0ff976b4ba04c66"/>
-    <p:sldId xmlns:r="http://schemas.openxmlformats.org/officeDocument/2006/relationships" id="265" r:id="R2974c5ee6766408d"/>
-    <p:sldId xmlns:r="http://schemas.openxmlformats.org/officeDocument/2006/relationships" id="266" r:id="Rddebd204c0fd43cd"/>
-    <p:sldId xmlns:r="http://schemas.openxmlformats.org/officeDocument/2006/relationships" id="267" r:id="R1b477d91f2f04b8b"/>
-    <p:sldId xmlns:r="http://schemas.openxmlformats.org/officeDocument/2006/relationships" id="268" r:id="Rc0d5390f96b3463d"/>
-    <p:sldId xmlns:r="http://schemas.openxmlformats.org/officeDocument/2006/relationships" id="269" r:id="R7a95a27dada24ece"/>
-    <p:sldId xmlns:r="http://schemas.openxmlformats.org/officeDocument/2006/relationships" id="270" r:id="Ra5d3d67ef4b54c96"/>
-    <p:sldId xmlns:r="http://schemas.openxmlformats.org/officeDocument/2006/relationships" id="271" r:id="R4f76ab7ff8524ee5"/>
-    <p:sldId xmlns:r="http://schemas.openxmlformats.org/officeDocument/2006/relationships" id="272" r:id="Rd38fb51728f1442b"/>
-    <p:sldId xmlns:r="http://schemas.openxmlformats.org/officeDocument/2006/relationships" id="273" r:id="Rfa3b8f8c71444387"/>
-    <p:sldId xmlns:r="http://schemas.openxmlformats.org/officeDocument/2006/relationships" id="274" r:id="Rd5d08431279e410c"/>
-    <p:sldId xmlns:r="http://schemas.openxmlformats.org/officeDocument/2006/relationships" id="275" r:id="R80ce4b27bc0b4bda"/>
-    <p:sldId xmlns:r="http://schemas.openxmlformats.org/officeDocument/2006/relationships" id="276" r:id="R2364c9b0960e4879"/>
-    <p:sldId xmlns:r="http://schemas.openxmlformats.org/officeDocument/2006/relationships" id="277" r:id="Rf5d74867f9b84e0e"/>
-    <p:sldId xmlns:r="http://schemas.openxmlformats.org/officeDocument/2006/relationships" id="278" r:id="Rbb2cc076934a4544"/>
+    <p:sldId xmlns:r="http://schemas.openxmlformats.org/officeDocument/2006/relationships" id="256" r:id="R6cb99e5e24044e9c"/>
+    <p:sldId xmlns:r="http://schemas.openxmlformats.org/officeDocument/2006/relationships" id="257" r:id="R683cc98eba194053"/>
+    <p:sldId xmlns:r="http://schemas.openxmlformats.org/officeDocument/2006/relationships" id="258" r:id="R99a7462c99c3494d"/>
+    <p:sldId xmlns:r="http://schemas.openxmlformats.org/officeDocument/2006/relationships" id="259" r:id="R59517a990ce546c1"/>
+    <p:sldId xmlns:r="http://schemas.openxmlformats.org/officeDocument/2006/relationships" id="260" r:id="R203626b09bfe4434"/>
+    <p:sldId xmlns:r="http://schemas.openxmlformats.org/officeDocument/2006/relationships" id="261" r:id="Ra549c2b0f0cd420b"/>
+    <p:sldId xmlns:r="http://schemas.openxmlformats.org/officeDocument/2006/relationships" id="262" r:id="Rda5e393662cc4118"/>
+    <p:sldId xmlns:r="http://schemas.openxmlformats.org/officeDocument/2006/relationships" id="263" r:id="R4049471c62284674"/>
+    <p:sldId xmlns:r="http://schemas.openxmlformats.org/officeDocument/2006/relationships" id="264" r:id="R448186e904ed4b4c"/>
+    <p:sldId xmlns:r="http://schemas.openxmlformats.org/officeDocument/2006/relationships" id="265" r:id="Rd3ee439cbc9d4f46"/>
+    <p:sldId xmlns:r="http://schemas.openxmlformats.org/officeDocument/2006/relationships" id="266" r:id="Rae8e191268054114"/>
+    <p:sldId xmlns:r="http://schemas.openxmlformats.org/officeDocument/2006/relationships" id="267" r:id="R92ef950385e2427b"/>
+    <p:sldId xmlns:r="http://schemas.openxmlformats.org/officeDocument/2006/relationships" id="268" r:id="R7a32e770adea4af9"/>
+    <p:sldId xmlns:r="http://schemas.openxmlformats.org/officeDocument/2006/relationships" id="269" r:id="Rd639337330ab4c78"/>
+    <p:sldId xmlns:r="http://schemas.openxmlformats.org/officeDocument/2006/relationships" id="270" r:id="R7bbdc004b7cc4c62"/>
+    <p:sldId xmlns:r="http://schemas.openxmlformats.org/officeDocument/2006/relationships" id="271" r:id="Rddf6081a3d194d35"/>
+    <p:sldId xmlns:r="http://schemas.openxmlformats.org/officeDocument/2006/relationships" id="272" r:id="R9eaec823b0134e4c"/>
+    <p:sldId xmlns:r="http://schemas.openxmlformats.org/officeDocument/2006/relationships" id="273" r:id="R3a043eb3ce8f41e1"/>
+    <p:sldId xmlns:r="http://schemas.openxmlformats.org/officeDocument/2006/relationships" id="274" r:id="R5f44069003674a11"/>
+    <p:sldId xmlns:r="http://schemas.openxmlformats.org/officeDocument/2006/relationships" id="275" r:id="R6a37f5f1d7734e3f"/>
+    <p:sldId xmlns:r="http://schemas.openxmlformats.org/officeDocument/2006/relationships" id="276" r:id="R2a3391cb63554041"/>
+    <p:sldId xmlns:r="http://schemas.openxmlformats.org/officeDocument/2006/relationships" id="277" r:id="Rc68e90da0254457c"/>
+    <p:sldId xmlns:r="http://schemas.openxmlformats.org/officeDocument/2006/relationships" id="278" r:id="R928662f164a0486f"/>
   </p:sldIdLst>
   <p:sldSz cx="12192000" cy="6858000"/>
   <p:notesSz cx="6858000" cy="9144000"/>
@@ -2081,7 +2081,7 @@
           <p:cNvPr id="3" name="Title">
             <a:extLst xmlns:a="http://schemas.openxmlformats.org/drawingml/2006/main">
               <a:ext uri="{FF2B5EF4-FFF2-40B4-BE49-F238E27FC236}">
-                <a16:creationId xmlns:a16="http://schemas.microsoft.com/office/drawing/2014/main" id="{D5060B59-9CF4-43A8-9ED8-0111439C0733}"/>
+                <a16:creationId xmlns:a16="http://schemas.microsoft.com/office/drawing/2014/main" id="{447D57F2-0EB2-4257-B43D-9A092395016A}"/>
               </a:ext>
             </a:extLst>
           </p:cNvPr>
@@ -2238,7 +2238,7 @@
           <p:cNvPr id="2" name="Subtitle">
             <a:extLst xmlns:a="http://schemas.openxmlformats.org/drawingml/2006/main">
               <a:ext uri="{FF2B5EF4-FFF2-40B4-BE49-F238E27FC236}">
-                <a16:creationId xmlns:a16="http://schemas.microsoft.com/office/drawing/2014/main" id="{E63B43F1-B496-444C-B272-EAB682069AAE}"/>
+                <a16:creationId xmlns:a16="http://schemas.microsoft.com/office/drawing/2014/main" id="{0919F2FD-37B5-4D8D-B944-415337289286}"/>
               </a:ext>
             </a:extLst>
           </p:cNvPr>
@@ -2412,7 +2412,7 @@
           <p:cNvPr id="2" name="Section title">
             <a:extLst xmlns:a="http://schemas.openxmlformats.org/drawingml/2006/main">
               <a:ext uri="{FF2B5EF4-FFF2-40B4-BE49-F238E27FC236}">
-                <a16:creationId xmlns:a16="http://schemas.microsoft.com/office/drawing/2014/main" id="{93C8A6BC-84CA-48DB-931C-7E3B57B72D7B}"/>
+                <a16:creationId xmlns:a16="http://schemas.microsoft.com/office/drawing/2014/main" id="{4CE11F3D-232D-49F5-8E75-0045CED98AC6}"/>
               </a:ext>
             </a:extLst>
           </p:cNvPr>
@@ -2586,7 +2586,7 @@
           <p:cNvPr id="3" name="Title">
             <a:extLst xmlns:a="http://schemas.openxmlformats.org/drawingml/2006/main">
               <a:ext uri="{FF2B5EF4-FFF2-40B4-BE49-F238E27FC236}">
-                <a16:creationId xmlns:a16="http://schemas.microsoft.com/office/drawing/2014/main" id="{3CBFBD64-9239-471E-98C6-82DF9EA18AC7}"/>
+                <a16:creationId xmlns:a16="http://schemas.microsoft.com/office/drawing/2014/main" id="{DD4D0A99-2C6A-41CD-8154-8EC66181129F}"/>
               </a:ext>
             </a:extLst>
           </p:cNvPr>
@@ -2743,7 +2743,7 @@
           <p:cNvPr id="2" name="Body">
             <a:extLst xmlns:a="http://schemas.openxmlformats.org/drawingml/2006/main">
               <a:ext uri="{FF2B5EF4-FFF2-40B4-BE49-F238E27FC236}">
-                <a16:creationId xmlns:a16="http://schemas.microsoft.com/office/drawing/2014/main" id="{D5C1E844-C7BE-466C-81AD-B9C0CAC869FA}"/>
+                <a16:creationId xmlns:a16="http://schemas.microsoft.com/office/drawing/2014/main" id="{F75F5044-207D-4F85-93DF-BCEEB2878C5B}"/>
               </a:ext>
             </a:extLst>
           </p:cNvPr>
@@ -2917,7 +2917,7 @@
           <p:cNvPr id="4" name="Title">
             <a:extLst xmlns:a="http://schemas.openxmlformats.org/drawingml/2006/main">
               <a:ext uri="{FF2B5EF4-FFF2-40B4-BE49-F238E27FC236}">
-                <a16:creationId xmlns:a16="http://schemas.microsoft.com/office/drawing/2014/main" id="{AF991F26-33E5-4CAF-BAA5-83DE11B28738}"/>
+                <a16:creationId xmlns:a16="http://schemas.microsoft.com/office/drawing/2014/main" id="{2D191EF2-BCE6-46F5-8AA0-436EDC9BB60C}"/>
               </a:ext>
             </a:extLst>
           </p:cNvPr>
@@ -3074,7 +3074,7 @@
           <p:cNvPr id="2" name="Left column">
             <a:extLst xmlns:a="http://schemas.openxmlformats.org/drawingml/2006/main">
               <a:ext uri="{FF2B5EF4-FFF2-40B4-BE49-F238E27FC236}">
-                <a16:creationId xmlns:a16="http://schemas.microsoft.com/office/drawing/2014/main" id="{CB6BFC6A-AB2A-40BC-9B5F-AAC92F0FA05D}"/>
+                <a16:creationId xmlns:a16="http://schemas.microsoft.com/office/drawing/2014/main" id="{28367350-2BC3-4EE1-8C2C-2F42AAA44F31}"/>
               </a:ext>
             </a:extLst>
           </p:cNvPr>
@@ -3231,7 +3231,7 @@
           <p:cNvPr id="3" name="Right column">
             <a:extLst xmlns:a="http://schemas.openxmlformats.org/drawingml/2006/main">
               <a:ext uri="{FF2B5EF4-FFF2-40B4-BE49-F238E27FC236}">
-                <a16:creationId xmlns:a16="http://schemas.microsoft.com/office/drawing/2014/main" id="{17DDBC5A-77F2-4CC4-8E66-25465498D120}"/>
+                <a16:creationId xmlns:a16="http://schemas.microsoft.com/office/drawing/2014/main" id="{D53E00B6-69D3-482D-B28E-59A569D418C1}"/>
               </a:ext>
             </a:extLst>
           </p:cNvPr>
@@ -3405,7 +3405,7 @@
           <p:cNvPr id="3" name="Title">
             <a:extLst xmlns:a="http://schemas.openxmlformats.org/drawingml/2006/main">
               <a:ext uri="{FF2B5EF4-FFF2-40B4-BE49-F238E27FC236}">
-                <a16:creationId xmlns:a16="http://schemas.microsoft.com/office/drawing/2014/main" id="{D6D19B5F-EA7E-49F2-8C22-CF9C4A7D89F5}"/>
+                <a16:creationId xmlns:a16="http://schemas.microsoft.com/office/drawing/2014/main" id="{331DCDEF-D467-48CD-B709-4662A37DA214}"/>
               </a:ext>
             </a:extLst>
           </p:cNvPr>
@@ -3562,7 +3562,7 @@
           <p:cNvPr id="2" name="Left column">
             <a:extLst xmlns:a="http://schemas.openxmlformats.org/drawingml/2006/main">
               <a:ext uri="{FF2B5EF4-FFF2-40B4-BE49-F238E27FC236}">
-                <a16:creationId xmlns:a16="http://schemas.microsoft.com/office/drawing/2014/main" id="{F26967D8-ED80-479E-B106-8C7D90D22869}"/>
+                <a16:creationId xmlns:a16="http://schemas.microsoft.com/office/drawing/2014/main" id="{F3D2301E-8EFD-4652-AEDC-557CB212A7C8}"/>
               </a:ext>
             </a:extLst>
           </p:cNvPr>
@@ -3757,12 +3757,12 @@
   </p:cSld>
   <p:clrMap bg1="lt1" tx1="dk1" bg2="lt2" tx2="dk2" accent1="accent1" accent2="accent2" accent3="accent3" accent4="accent4" accent5="accent5" accent6="accent6" hlink="hlink" folHlink="folHlink"/>
   <p:sldLayoutIdLst>
-    <p:sldLayoutId xmlns:r="http://schemas.openxmlformats.org/officeDocument/2006/relationships" id="2147483649" r:id="Rdae4de29b5704b84"/>
-    <p:sldLayoutId xmlns:r="http://schemas.openxmlformats.org/officeDocument/2006/relationships" id="2147483650" r:id="R7f278d90a9284226"/>
-    <p:sldLayoutId xmlns:r="http://schemas.openxmlformats.org/officeDocument/2006/relationships" id="2147483651" r:id="R1eabf8aabe75417b"/>
-    <p:sldLayoutId xmlns:r="http://schemas.openxmlformats.org/officeDocument/2006/relationships" id="2147483652" r:id="R42c33a40bd324def"/>
-    <p:sldLayoutId xmlns:r="http://schemas.openxmlformats.org/officeDocument/2006/relationships" id="2147483653" r:id="Rbe6e8d0e06864e7b"/>
-    <p:sldLayoutId xmlns:r="http://schemas.openxmlformats.org/officeDocument/2006/relationships" id="2147483654" r:id="R0a4897e22e484c5b"/>
+    <p:sldLayoutId xmlns:r="http://schemas.openxmlformats.org/officeDocument/2006/relationships" id="2147483649" r:id="R2e0edd4e3cd04fda"/>
+    <p:sldLayoutId xmlns:r="http://schemas.openxmlformats.org/officeDocument/2006/relationships" id="2147483650" r:id="R2c8b26480ccf46f4"/>
+    <p:sldLayoutId xmlns:r="http://schemas.openxmlformats.org/officeDocument/2006/relationships" id="2147483651" r:id="Rf1535c47096c474e"/>
+    <p:sldLayoutId xmlns:r="http://schemas.openxmlformats.org/officeDocument/2006/relationships" id="2147483652" r:id="R3b4c1fee34b344cd"/>
+    <p:sldLayoutId xmlns:r="http://schemas.openxmlformats.org/officeDocument/2006/relationships" id="2147483653" r:id="R0cca37785f724de7"/>
+    <p:sldLayoutId xmlns:r="http://schemas.openxmlformats.org/officeDocument/2006/relationships" id="2147483654" r:id="R02b02aa8e2434641"/>
   </p:sldLayoutIdLst>
   <p:txStyles>
     <p:titleStyle>
@@ -4714,10 +4714,10 @@
       </p:grpSpPr>
       <p:sp>
         <p:nvSpPr>
-          <p:cNvPr id="6" name="">
+          <p:cNvPr id="8" name="">
             <a:extLst xmlns:a="http://schemas.openxmlformats.org/drawingml/2006/main">
               <a:ext uri="{FF2B5EF4-FFF2-40B4-BE49-F238E27FC236}">
-                <a16:creationId xmlns:a16="http://schemas.microsoft.com/office/drawing/2014/main" id="{13833D81-566F-426B-96A5-2D13FB3ED264}"/>
+                <a16:creationId xmlns:a16="http://schemas.microsoft.com/office/drawing/2014/main" id="{C66C6C70-269E-4929-A9D7-FB7DD73CF30C}"/>
               </a:ext>
             </a:extLst>
           </p:cNvPr>
@@ -4785,7 +4785,7 @@
           <p:cNvPr id="2" name="">
             <a:extLst xmlns:a="http://schemas.openxmlformats.org/drawingml/2006/main">
               <a:ext uri="{FF2B5EF4-FFF2-40B4-BE49-F238E27FC236}">
-                <a16:creationId xmlns:a16="http://schemas.microsoft.com/office/drawing/2014/main" id="{44D3191D-E3DE-4133-A52F-7E2C499B330C}"/>
+                <a16:creationId xmlns:a16="http://schemas.microsoft.com/office/drawing/2014/main" id="{F825BFEA-EEC1-40D9-A3E1-0FDA22EC2FC5}"/>
               </a:ext>
             </a:extLst>
           </p:cNvPr>
@@ -4876,7 +4876,7 @@
           <p:cNvPr id="3" name="">
             <a:extLst xmlns:a="http://schemas.openxmlformats.org/drawingml/2006/main">
               <a:ext uri="{FF2B5EF4-FFF2-40B4-BE49-F238E27FC236}">
-                <a16:creationId xmlns:a16="http://schemas.microsoft.com/office/drawing/2014/main" id="{EB212098-33D8-43AE-9184-D54C8F2BA65F}"/>
+                <a16:creationId xmlns:a16="http://schemas.microsoft.com/office/drawing/2014/main" id="{A18A9D4D-27B9-404D-BAEA-ADDD70716812}"/>
               </a:ext>
             </a:extLst>
           </p:cNvPr>
@@ -4944,7 +4944,7 @@
           <p:cNvPr id="4" name="">
             <a:extLst xmlns:a="http://schemas.openxmlformats.org/drawingml/2006/main">
               <a:ext uri="{FF2B5EF4-FFF2-40B4-BE49-F238E27FC236}">
-                <a16:creationId xmlns:a16="http://schemas.microsoft.com/office/drawing/2014/main" id="{AB6B0B7A-6C3F-483A-89DE-B0DBA0C8086F}"/>
+                <a16:creationId xmlns:a16="http://schemas.microsoft.com/office/drawing/2014/main" id="{197FFEA0-8602-4324-99B7-9483EFCA7406}"/>
               </a:ext>
             </a:extLst>
           </p:cNvPr>
@@ -5012,7 +5012,7 @@
           <p:cNvPr id="5" name="">
             <a:extLst xmlns:a="http://schemas.openxmlformats.org/drawingml/2006/main">
               <a:ext uri="{FF2B5EF4-FFF2-40B4-BE49-F238E27FC236}">
-                <a16:creationId xmlns:a16="http://schemas.microsoft.com/office/drawing/2014/main" id="{66FD0C74-1542-46C1-B856-91734B1E1762}"/>
+                <a16:creationId xmlns:a16="http://schemas.microsoft.com/office/drawing/2014/main" id="{0FA5B03D-EAD5-4123-A5A9-F7F137F8DB5A}"/>
               </a:ext>
             </a:extLst>
           </p:cNvPr>
@@ -5023,8 +5023,8 @@
         </p:nvSpPr>
         <p:spPr>
           <a:xfrm xmlns:a="http://schemas.openxmlformats.org/drawingml/2006/main">
-            <a:off x="647700" y="5800725"/>
-            <a:ext cx="10001250" cy="323850"/>
+            <a:off x="647700" y="5143500"/>
+            <a:ext cx="10668000" cy="304800"/>
           </a:xfrm>
           <a:prstGeom xmlns:a="http://schemas.openxmlformats.org/drawingml/2006/main" prst="rect">
             <a:avLst/>
@@ -5040,9 +5040,9 @@
           </a:bodyPr>
           <a:lstStyle xmlns:a="http://schemas.openxmlformats.org/drawingml/2006/main">
             <a:defPPr algn="l">
-              <a:defRPr sz="1650" b="0">
-                <a:solidFill>
-                  <a:srgbClr val="535C5B"/>
+              <a:defRPr sz="1725" b="0">
+                <a:solidFill>
+                  <a:srgbClr val="242B2B"/>
                 </a:solidFill>
                 <a:latin typeface="IBM Plex Sans"/>
                 <a:ea typeface="IBM Plex Sans"/>
@@ -5052,9 +5052,9 @@
           </a:lstStyle>
           <a:p xmlns:a="http://schemas.openxmlformats.org/drawingml/2006/main">
             <a:pPr algn="l">
-              <a:defRPr sz="1650" b="0">
-                <a:solidFill>
-                  <a:srgbClr val="535C5B"/>
+              <a:defRPr sz="1725" b="0">
+                <a:solidFill>
+                  <a:srgbClr val="242B2B"/>
                 </a:solidFill>
                 <a:latin typeface="IBM Plex Sans"/>
                 <a:ea typeface="IBM Plex Sans"/>
@@ -5062,7 +5062,143 @@
               </a:defRPr>
             </a:pPr>
             <a:r>
-              <a:rPr sz="1650" b="0">
+              <a:rPr sz="1725" b="0">
+                <a:solidFill>
+                  <a:srgbClr val="242B2B"/>
+                </a:solidFill>
+                <a:latin typeface="IBM Plex Sans"/>
+                <a:ea typeface="IBM Plex Sans"/>
+                <a:cs typeface="IBM Plex Sans"/>
+              </a:rPr>
+              <a:t>Ali Omar · Abdallah Mestrah · Abbas Yazbek</a:t>
+            </a:r>
+          </a:p>
+        </p:txBody>
+      </p:sp>
+      <p:sp>
+        <p:nvSpPr>
+          <p:cNvPr id="6" name="">
+            <a:extLst xmlns:a="http://schemas.openxmlformats.org/drawingml/2006/main">
+              <a:ext uri="{FF2B5EF4-FFF2-40B4-BE49-F238E27FC236}">
+                <a16:creationId xmlns:a16="http://schemas.microsoft.com/office/drawing/2014/main" id="{07DB673F-AAD9-488E-B7C4-7C579F1DCDD6}"/>
+              </a:ext>
+            </a:extLst>
+          </p:cNvPr>
+          <p:cNvSpPr>
+            <a:spLocks xmlns:a="http://schemas.openxmlformats.org/drawingml/2006/main" noGrp="1"/>
+          </p:cNvSpPr>
+          <p:nvPr/>
+        </p:nvSpPr>
+        <p:spPr>
+          <a:xfrm xmlns:a="http://schemas.openxmlformats.org/drawingml/2006/main">
+            <a:off x="647700" y="5476875"/>
+            <a:ext cx="10668000" cy="285750"/>
+          </a:xfrm>
+          <a:prstGeom xmlns:a="http://schemas.openxmlformats.org/drawingml/2006/main" prst="rect">
+            <a:avLst/>
+          </a:prstGeom>
+          <a:noFill xmlns:a="http://schemas.openxmlformats.org/drawingml/2006/main"/>
+          <a:ln xmlns:a="http://schemas.openxmlformats.org/drawingml/2006/main" w="0">
+            <a:noFill/>
+          </a:ln>
+        </p:spPr>
+        <p:txBody>
+          <a:bodyPr xmlns:a="http://schemas.openxmlformats.org/drawingml/2006/main" wrap="square" lIns="0" tIns="0" rIns="0" bIns="0" anchor="t">
+            <a:noAutofit/>
+          </a:bodyPr>
+          <a:lstStyle xmlns:a="http://schemas.openxmlformats.org/drawingml/2006/main">
+            <a:defPPr algn="l">
+              <a:defRPr sz="1575" b="0">
+                <a:solidFill>
+                  <a:srgbClr val="535C5B"/>
+                </a:solidFill>
+                <a:latin typeface="IBM Plex Sans"/>
+                <a:ea typeface="IBM Plex Sans"/>
+                <a:cs typeface="IBM Plex Sans"/>
+              </a:defRPr>
+            </a:defPPr>
+          </a:lstStyle>
+          <a:p xmlns:a="http://schemas.openxmlformats.org/drawingml/2006/main">
+            <a:pPr algn="l">
+              <a:defRPr sz="1575" b="0">
+                <a:solidFill>
+                  <a:srgbClr val="535C5B"/>
+                </a:solidFill>
+                <a:latin typeface="IBM Plex Sans"/>
+                <a:ea typeface="IBM Plex Sans"/>
+                <a:cs typeface="IBM Plex Sans"/>
+              </a:defRPr>
+            </a:pPr>
+            <a:r>
+              <a:rPr sz="1575" b="0">
+                <a:solidFill>
+                  <a:srgbClr val="535C5B"/>
+                </a:solidFill>
+                <a:latin typeface="IBM Plex Sans"/>
+                <a:ea typeface="IBM Plex Sans"/>
+                <a:cs typeface="IBM Plex Sans"/>
+              </a:rPr>
+              <a:t>Supervisor: Dr. Ahmad Abboud · Lebanese University</a:t>
+            </a:r>
+          </a:p>
+        </p:txBody>
+      </p:sp>
+      <p:sp>
+        <p:nvSpPr>
+          <p:cNvPr id="7" name="">
+            <a:extLst xmlns:a="http://schemas.openxmlformats.org/drawingml/2006/main">
+              <a:ext uri="{FF2B5EF4-FFF2-40B4-BE49-F238E27FC236}">
+                <a16:creationId xmlns:a16="http://schemas.microsoft.com/office/drawing/2014/main" id="{75ACF59C-E1BD-4B46-A2F4-BFDEA34E991C}"/>
+              </a:ext>
+            </a:extLst>
+          </p:cNvPr>
+          <p:cNvSpPr>
+            <a:spLocks xmlns:a="http://schemas.openxmlformats.org/drawingml/2006/main" noGrp="1"/>
+          </p:cNvSpPr>
+          <p:nvPr/>
+        </p:nvSpPr>
+        <p:spPr>
+          <a:xfrm xmlns:a="http://schemas.openxmlformats.org/drawingml/2006/main">
+            <a:off x="647700" y="6019800"/>
+            <a:ext cx="10001250" cy="285750"/>
+          </a:xfrm>
+          <a:prstGeom xmlns:a="http://schemas.openxmlformats.org/drawingml/2006/main" prst="rect">
+            <a:avLst/>
+          </a:prstGeom>
+          <a:noFill xmlns:a="http://schemas.openxmlformats.org/drawingml/2006/main"/>
+          <a:ln xmlns:a="http://schemas.openxmlformats.org/drawingml/2006/main" w="0">
+            <a:noFill/>
+          </a:ln>
+        </p:spPr>
+        <p:txBody>
+          <a:bodyPr xmlns:a="http://schemas.openxmlformats.org/drawingml/2006/main" wrap="square" lIns="0" tIns="0" rIns="0" bIns="0" anchor="t">
+            <a:noAutofit/>
+          </a:bodyPr>
+          <a:lstStyle xmlns:a="http://schemas.openxmlformats.org/drawingml/2006/main">
+            <a:defPPr algn="l">
+              <a:defRPr sz="1500" b="0">
+                <a:solidFill>
+                  <a:srgbClr val="535C5B"/>
+                </a:solidFill>
+                <a:latin typeface="IBM Plex Sans"/>
+                <a:ea typeface="IBM Plex Sans"/>
+                <a:cs typeface="IBM Plex Sans"/>
+              </a:defRPr>
+            </a:defPPr>
+          </a:lstStyle>
+          <a:p xmlns:a="http://schemas.openxmlformats.org/drawingml/2006/main">
+            <a:pPr algn="l">
+              <a:defRPr sz="1500" b="0">
+                <a:solidFill>
+                  <a:srgbClr val="535C5B"/>
+                </a:solidFill>
+                <a:latin typeface="IBM Plex Sans"/>
+                <a:ea typeface="IBM Plex Sans"/>
+                <a:cs typeface="IBM Plex Sans"/>
+              </a:defRPr>
+            </a:pPr>
+            <a:r>
+              <a:rPr sz="1500" b="0">
                 <a:solidFill>
                   <a:srgbClr val="535C5B"/>
                 </a:solidFill>
@@ -5078,7 +5214,7 @@
     </p:spTree>
     <p:extLst>
       <p:ext uri="{BB962C8B-B14F-4D97-AF65-F5344CB8AC3E}">
-        <p14:creationId xmlns:p14="http://schemas.microsoft.com/office/powerpoint/2010/main" val="1685021517"/>
+        <p14:creationId xmlns:p14="http://schemas.microsoft.com/office/powerpoint/2010/main" val="533043133"/>
       </p:ext>
     </p:extLst>
   </p:cSld>
@@ -5109,7 +5245,7 @@
           <p:cNvPr id="9" name="">
             <a:extLst xmlns:a="http://schemas.openxmlformats.org/drawingml/2006/main">
               <a:ext uri="{FF2B5EF4-FFF2-40B4-BE49-F238E27FC236}">
-                <a16:creationId xmlns:a16="http://schemas.microsoft.com/office/drawing/2014/main" id="{402D5D5C-175F-4111-8FA6-2FE9660AEEDC}"/>
+                <a16:creationId xmlns:a16="http://schemas.microsoft.com/office/drawing/2014/main" id="{C9ABCA35-AF64-4070-99DE-297649924C2E}"/>
               </a:ext>
             </a:extLst>
           </p:cNvPr>
@@ -5177,7 +5313,7 @@
           <p:cNvPr id="2" name="">
             <a:extLst xmlns:a="http://schemas.openxmlformats.org/drawingml/2006/main">
               <a:ext uri="{FF2B5EF4-FFF2-40B4-BE49-F238E27FC236}">
-                <a16:creationId xmlns:a16="http://schemas.microsoft.com/office/drawing/2014/main" id="{7DA46A3D-B371-4457-BD5D-6B8164B97C73}"/>
+                <a16:creationId xmlns:a16="http://schemas.microsoft.com/office/drawing/2014/main" id="{DDA8A9B2-F113-415F-BAAC-492B5B105F26}"/>
               </a:ext>
             </a:extLst>
           </p:cNvPr>
@@ -5245,7 +5381,7 @@
           <p:cNvPr id="3" name="">
             <a:extLst xmlns:a="http://schemas.openxmlformats.org/drawingml/2006/main">
               <a:ext uri="{FF2B5EF4-FFF2-40B4-BE49-F238E27FC236}">
-                <a16:creationId xmlns:a16="http://schemas.microsoft.com/office/drawing/2014/main" id="{AEDC0F9F-796A-482B-80A3-D9EB12E59D20}"/>
+                <a16:creationId xmlns:a16="http://schemas.microsoft.com/office/drawing/2014/main" id="{456E956E-38EB-4E32-82A4-02B833C5B627}"/>
               </a:ext>
             </a:extLst>
           </p:cNvPr>
@@ -5313,7 +5449,7 @@
           <p:cNvPr id="4" name="">
             <a:extLst xmlns:a="http://schemas.openxmlformats.org/drawingml/2006/main">
               <a:ext uri="{FF2B5EF4-FFF2-40B4-BE49-F238E27FC236}">
-                <a16:creationId xmlns:a16="http://schemas.microsoft.com/office/drawing/2014/main" id="{EEA17B8F-30C2-4676-93BA-B5B729A9DABD}"/>
+                <a16:creationId xmlns:a16="http://schemas.microsoft.com/office/drawing/2014/main" id="{5E07FD11-A0EB-4CF9-86D1-98734344C579}"/>
               </a:ext>
             </a:extLst>
           </p:cNvPr>
@@ -5381,7 +5517,7 @@
           <p:cNvPr id="5" name="">
             <a:extLst xmlns:a="http://schemas.openxmlformats.org/drawingml/2006/main">
               <a:ext uri="{FF2B5EF4-FFF2-40B4-BE49-F238E27FC236}">
-                <a16:creationId xmlns:a16="http://schemas.microsoft.com/office/drawing/2014/main" id="{225B6102-D3E7-42B0-9E04-D4DD6BF31B9F}"/>
+                <a16:creationId xmlns:a16="http://schemas.microsoft.com/office/drawing/2014/main" id="{A2977B1D-0F8B-406D-8AEF-F9921B77628B}"/>
               </a:ext>
             </a:extLst>
           </p:cNvPr>
@@ -5449,7 +5585,7 @@
           <p:cNvPr id="6" name="">
             <a:extLst xmlns:a="http://schemas.openxmlformats.org/drawingml/2006/main">
               <a:ext uri="{FF2B5EF4-FFF2-40B4-BE49-F238E27FC236}">
-                <a16:creationId xmlns:a16="http://schemas.microsoft.com/office/drawing/2014/main" id="{F900DD52-4FCC-4C5D-B931-22EAC1E74967}"/>
+                <a16:creationId xmlns:a16="http://schemas.microsoft.com/office/drawing/2014/main" id="{63A5493E-AECB-4134-B06A-6D5BCAB7D47E}"/>
               </a:ext>
             </a:extLst>
           </p:cNvPr>
@@ -5517,7 +5653,7 @@
           <p:cNvPr id="7" name="">
             <a:extLst xmlns:a="http://schemas.openxmlformats.org/drawingml/2006/main">
               <a:ext uri="{FF2B5EF4-FFF2-40B4-BE49-F238E27FC236}">
-                <a16:creationId xmlns:a16="http://schemas.microsoft.com/office/drawing/2014/main" id="{B2DB6FBD-2635-4F61-AA84-28769E8824E9}"/>
+                <a16:creationId xmlns:a16="http://schemas.microsoft.com/office/drawing/2014/main" id="{74C3BDCD-EDCE-4AC8-BAE1-965E5E1D3E86}"/>
               </a:ext>
             </a:extLst>
           </p:cNvPr>
@@ -5585,7 +5721,7 @@
           <p:cNvPr id="8" name="">
             <a:extLst xmlns:a="http://schemas.openxmlformats.org/drawingml/2006/main">
               <a:ext uri="{FF2B5EF4-FFF2-40B4-BE49-F238E27FC236}">
-                <a16:creationId xmlns:a16="http://schemas.microsoft.com/office/drawing/2014/main" id="{011E6CAE-E81E-4F12-9CF2-B3C60922E1B5}"/>
+                <a16:creationId xmlns:a16="http://schemas.microsoft.com/office/drawing/2014/main" id="{DEECF162-A71D-4CC9-8442-5394E372295D}"/>
               </a:ext>
             </a:extLst>
           </p:cNvPr>
@@ -5651,7 +5787,7 @@
     </p:spTree>
     <p:extLst>
       <p:ext uri="{BB962C8B-B14F-4D97-AF65-F5344CB8AC3E}">
-        <p14:creationId xmlns:p14="http://schemas.microsoft.com/office/powerpoint/2010/main" val="952472436"/>
+        <p14:creationId xmlns:p14="http://schemas.microsoft.com/office/powerpoint/2010/main" val="278882281"/>
       </p:ext>
     </p:extLst>
   </p:cSld>
@@ -5682,7 +5818,7 @@
           <p:cNvPr id="5" name="">
             <a:extLst xmlns:a="http://schemas.openxmlformats.org/drawingml/2006/main">
               <a:ext uri="{FF2B5EF4-FFF2-40B4-BE49-F238E27FC236}">
-                <a16:creationId xmlns:a16="http://schemas.microsoft.com/office/drawing/2014/main" id="{022718E8-09A0-4297-B5C2-3BBE6BBF29F5}"/>
+                <a16:creationId xmlns:a16="http://schemas.microsoft.com/office/drawing/2014/main" id="{AB79319C-4540-4942-9D4C-C1828BDF331D}"/>
               </a:ext>
             </a:extLst>
           </p:cNvPr>
@@ -5750,7 +5886,7 @@
           <p:cNvPr id="2" name="">
             <a:extLst xmlns:a="http://schemas.openxmlformats.org/drawingml/2006/main">
               <a:ext uri="{FF2B5EF4-FFF2-40B4-BE49-F238E27FC236}">
-                <a16:creationId xmlns:a16="http://schemas.microsoft.com/office/drawing/2014/main" id="{45D72F0E-D317-4A64-B309-2CFCFBCAAF94}"/>
+                <a16:creationId xmlns:a16="http://schemas.microsoft.com/office/drawing/2014/main" id="{A24C464E-5EA9-4631-99D1-05BF572CDBEE}"/>
               </a:ext>
             </a:extLst>
           </p:cNvPr>
@@ -5818,7 +5954,7 @@
           <p:cNvPr id="3" name="">
             <a:extLst xmlns:a="http://schemas.openxmlformats.org/drawingml/2006/main">
               <a:ext uri="{FF2B5EF4-FFF2-40B4-BE49-F238E27FC236}">
-                <a16:creationId xmlns:a16="http://schemas.microsoft.com/office/drawing/2014/main" id="{218D5CA6-E47B-413E-BCEE-AB2E7053CD6A}"/>
+                <a16:creationId xmlns:a16="http://schemas.microsoft.com/office/drawing/2014/main" id="{5C0FFB3F-21EC-4F16-90F6-5306CB46B37B}"/>
               </a:ext>
             </a:extLst>
           </p:cNvPr>
@@ -6798,7 +6934,7 @@
           <p:cNvPr id="4" name="">
             <a:extLst xmlns:a="http://schemas.openxmlformats.org/drawingml/2006/main">
               <a:ext uri="{FF2B5EF4-FFF2-40B4-BE49-F238E27FC236}">
-                <a16:creationId xmlns:a16="http://schemas.microsoft.com/office/drawing/2014/main" id="{30D22038-C81C-4D3A-87EF-51D8CA44EA98}"/>
+                <a16:creationId xmlns:a16="http://schemas.microsoft.com/office/drawing/2014/main" id="{5081FD98-9268-4270-8340-9EDF8D1060EF}"/>
               </a:ext>
             </a:extLst>
           </p:cNvPr>
@@ -6864,7 +7000,7 @@
     </p:spTree>
     <p:extLst>
       <p:ext uri="{BB962C8B-B14F-4D97-AF65-F5344CB8AC3E}">
-        <p14:creationId xmlns:p14="http://schemas.microsoft.com/office/powerpoint/2010/main" val="727574286"/>
+        <p14:creationId xmlns:p14="http://schemas.microsoft.com/office/powerpoint/2010/main" val="904352364"/>
       </p:ext>
     </p:extLst>
   </p:cSld>
@@ -6895,7 +7031,7 @@
           <p:cNvPr id="5" name="">
             <a:extLst xmlns:a="http://schemas.openxmlformats.org/drawingml/2006/main">
               <a:ext uri="{FF2B5EF4-FFF2-40B4-BE49-F238E27FC236}">
-                <a16:creationId xmlns:a16="http://schemas.microsoft.com/office/drawing/2014/main" id="{FBBA3C90-112C-44EA-8E9E-27159A63ACE3}"/>
+                <a16:creationId xmlns:a16="http://schemas.microsoft.com/office/drawing/2014/main" id="{15C111A4-4457-4868-9714-29EAAA310AC4}"/>
               </a:ext>
             </a:extLst>
           </p:cNvPr>
@@ -6963,7 +7099,7 @@
           <p:cNvPr id="2" name="">
             <a:extLst xmlns:a="http://schemas.openxmlformats.org/drawingml/2006/main">
               <a:ext uri="{FF2B5EF4-FFF2-40B4-BE49-F238E27FC236}">
-                <a16:creationId xmlns:a16="http://schemas.microsoft.com/office/drawing/2014/main" id="{E6134652-04ED-437D-A1D4-5927AF9E7052}"/>
+                <a16:creationId xmlns:a16="http://schemas.microsoft.com/office/drawing/2014/main" id="{BF96F369-00E7-4D8B-A643-17016E9C1311}"/>
               </a:ext>
             </a:extLst>
           </p:cNvPr>
@@ -7031,7 +7167,7 @@
           <p:cNvPr id="3" name="Chart">
             <a:extLst xmlns:a="http://schemas.openxmlformats.org/drawingml/2006/main">
               <a:ext uri="{FF2B5EF4-FFF2-40B4-BE49-F238E27FC236}">
-                <a16:creationId xmlns:a16="http://schemas.microsoft.com/office/drawing/2014/main" id="{3D8C35B4-E071-4127-A907-1098FBACAFBC}"/>
+                <a16:creationId xmlns:a16="http://schemas.microsoft.com/office/drawing/2014/main" id="{9E902B3E-48F5-4E53-AE7F-FF57B1B8C49C}"/>
               </a:ext>
             </a:extLst>
           </p:cNvPr>
@@ -7044,7 +7180,7 @@
         </p:xfrm>
         <a:graphic xmlns:a="http://schemas.openxmlformats.org/drawingml/2006/main">
           <a:graphicData uri="http://schemas.openxmlformats.org/drawingml/2006/chart">
-            <c:chart xmlns:r="http://schemas.openxmlformats.org/officeDocument/2006/relationships" xmlns:c="http://schemas.openxmlformats.org/drawingml/2006/chart" r:id="R19aa1337d5744d6d"/>
+            <c:chart xmlns:r="http://schemas.openxmlformats.org/officeDocument/2006/relationships" xmlns:c="http://schemas.openxmlformats.org/drawingml/2006/chart" r:id="R386281dde9054383"/>
           </a:graphicData>
         </a:graphic>
       </p:graphicFrame>
@@ -7053,7 +7189,7 @@
           <p:cNvPr id="4" name="">
             <a:extLst xmlns:a="http://schemas.openxmlformats.org/drawingml/2006/main">
               <a:ext uri="{FF2B5EF4-FFF2-40B4-BE49-F238E27FC236}">
-                <a16:creationId xmlns:a16="http://schemas.microsoft.com/office/drawing/2014/main" id="{4C8E59C3-2B70-467A-8AE0-379F86DEBEDB}"/>
+                <a16:creationId xmlns:a16="http://schemas.microsoft.com/office/drawing/2014/main" id="{F1FD1D07-5228-4363-A42A-565EAE7C8324}"/>
               </a:ext>
             </a:extLst>
           </p:cNvPr>
@@ -7119,7 +7255,7 @@
     </p:spTree>
     <p:extLst>
       <p:ext uri="{BB962C8B-B14F-4D97-AF65-F5344CB8AC3E}">
-        <p14:creationId xmlns:p14="http://schemas.microsoft.com/office/powerpoint/2010/main" val="974320210"/>
+        <p14:creationId xmlns:p14="http://schemas.microsoft.com/office/powerpoint/2010/main" val="2085511345"/>
       </p:ext>
     </p:extLst>
   </p:cSld>
@@ -7150,7 +7286,7 @@
           <p:cNvPr id="5" name="">
             <a:extLst xmlns:a="http://schemas.openxmlformats.org/drawingml/2006/main">
               <a:ext uri="{FF2B5EF4-FFF2-40B4-BE49-F238E27FC236}">
-                <a16:creationId xmlns:a16="http://schemas.microsoft.com/office/drawing/2014/main" id="{BF2A3E95-E731-4BFE-BD1B-727359543F52}"/>
+                <a16:creationId xmlns:a16="http://schemas.microsoft.com/office/drawing/2014/main" id="{55A3C662-6FDA-4718-8FCE-6AFBE368317F}"/>
               </a:ext>
             </a:extLst>
           </p:cNvPr>
@@ -7218,7 +7354,7 @@
           <p:cNvPr id="2" name="">
             <a:extLst xmlns:a="http://schemas.openxmlformats.org/drawingml/2006/main">
               <a:ext uri="{FF2B5EF4-FFF2-40B4-BE49-F238E27FC236}">
-                <a16:creationId xmlns:a16="http://schemas.microsoft.com/office/drawing/2014/main" id="{F69F7521-5D1B-4B31-9ACF-E64D0DC16C87}"/>
+                <a16:creationId xmlns:a16="http://schemas.microsoft.com/office/drawing/2014/main" id="{A7B54F30-34C9-4F2B-A7A0-792232CF002A}"/>
               </a:ext>
             </a:extLst>
           </p:cNvPr>
@@ -7286,7 +7422,7 @@
           <p:cNvPr id="3" name="Chart">
             <a:extLst xmlns:a="http://schemas.openxmlformats.org/drawingml/2006/main">
               <a:ext uri="{FF2B5EF4-FFF2-40B4-BE49-F238E27FC236}">
-                <a16:creationId xmlns:a16="http://schemas.microsoft.com/office/drawing/2014/main" id="{DA5D64FA-F363-49EA-9CDB-548AD100940A}"/>
+                <a16:creationId xmlns:a16="http://schemas.microsoft.com/office/drawing/2014/main" id="{45EEA2BC-C6CD-4D52-9538-84428C2B213A}"/>
               </a:ext>
             </a:extLst>
           </p:cNvPr>
@@ -7299,7 +7435,7 @@
         </p:xfrm>
         <a:graphic xmlns:a="http://schemas.openxmlformats.org/drawingml/2006/main">
           <a:graphicData uri="http://schemas.openxmlformats.org/drawingml/2006/chart">
-            <c:chart xmlns:r="http://schemas.openxmlformats.org/officeDocument/2006/relationships" xmlns:c="http://schemas.openxmlformats.org/drawingml/2006/chart" r:id="R80a3d6e0e92b4bcb"/>
+            <c:chart xmlns:r="http://schemas.openxmlformats.org/officeDocument/2006/relationships" xmlns:c="http://schemas.openxmlformats.org/drawingml/2006/chart" r:id="R2c1e484c7dbb4074"/>
           </a:graphicData>
         </a:graphic>
       </p:graphicFrame>
@@ -7308,7 +7444,7 @@
           <p:cNvPr id="4" name="">
             <a:extLst xmlns:a="http://schemas.openxmlformats.org/drawingml/2006/main">
               <a:ext uri="{FF2B5EF4-FFF2-40B4-BE49-F238E27FC236}">
-                <a16:creationId xmlns:a16="http://schemas.microsoft.com/office/drawing/2014/main" id="{548139C5-43C4-4D3F-A103-36342AEF90B1}"/>
+                <a16:creationId xmlns:a16="http://schemas.microsoft.com/office/drawing/2014/main" id="{9FAA9A31-7657-41A4-940C-1AFF265B02AC}"/>
               </a:ext>
             </a:extLst>
           </p:cNvPr>
@@ -7374,7 +7510,7 @@
     </p:spTree>
     <p:extLst>
       <p:ext uri="{BB962C8B-B14F-4D97-AF65-F5344CB8AC3E}">
-        <p14:creationId xmlns:p14="http://schemas.microsoft.com/office/powerpoint/2010/main" val="1298209719"/>
+        <p14:creationId xmlns:p14="http://schemas.microsoft.com/office/powerpoint/2010/main" val="1115149335"/>
       </p:ext>
     </p:extLst>
   </p:cSld>
@@ -7405,7 +7541,7 @@
           <p:cNvPr id="8" name="">
             <a:extLst xmlns:a="http://schemas.openxmlformats.org/drawingml/2006/main">
               <a:ext uri="{FF2B5EF4-FFF2-40B4-BE49-F238E27FC236}">
-                <a16:creationId xmlns:a16="http://schemas.microsoft.com/office/drawing/2014/main" id="{550D818F-7010-4A4D-9EBD-739245D4D5B7}"/>
+                <a16:creationId xmlns:a16="http://schemas.microsoft.com/office/drawing/2014/main" id="{7B44E571-003A-421D-96D4-21C9DDFE2735}"/>
               </a:ext>
             </a:extLst>
           </p:cNvPr>
@@ -7473,7 +7609,7 @@
           <p:cNvPr id="2" name="">
             <a:extLst xmlns:a="http://schemas.openxmlformats.org/drawingml/2006/main">
               <a:ext uri="{FF2B5EF4-FFF2-40B4-BE49-F238E27FC236}">
-                <a16:creationId xmlns:a16="http://schemas.microsoft.com/office/drawing/2014/main" id="{2A0FA236-3907-4FBB-A044-E85B7A3402B1}"/>
+                <a16:creationId xmlns:a16="http://schemas.microsoft.com/office/drawing/2014/main" id="{7D7D2454-0CED-473D-AEF4-8CB04F49F878}"/>
               </a:ext>
             </a:extLst>
           </p:cNvPr>
@@ -7541,7 +7677,7 @@
           <p:cNvPr id="3" name="">
             <a:extLst xmlns:a="http://schemas.openxmlformats.org/drawingml/2006/main">
               <a:ext uri="{FF2B5EF4-FFF2-40B4-BE49-F238E27FC236}">
-                <a16:creationId xmlns:a16="http://schemas.microsoft.com/office/drawing/2014/main" id="{FEE956B6-3989-4CBF-B4FB-85521330F419}"/>
+                <a16:creationId xmlns:a16="http://schemas.microsoft.com/office/drawing/2014/main" id="{122E954F-7E60-4E06-9C85-019CE73B908D}"/>
               </a:ext>
             </a:extLst>
           </p:cNvPr>
@@ -7609,7 +7745,7 @@
           <p:cNvPr id="4" name="">
             <a:extLst xmlns:a="http://schemas.openxmlformats.org/drawingml/2006/main">
               <a:ext uri="{FF2B5EF4-FFF2-40B4-BE49-F238E27FC236}">
-                <a16:creationId xmlns:a16="http://schemas.microsoft.com/office/drawing/2014/main" id="{C3F8D483-6964-4FDC-9405-445B46E8B5D9}"/>
+                <a16:creationId xmlns:a16="http://schemas.microsoft.com/office/drawing/2014/main" id="{A4D85A45-DCFA-49D8-9543-37E3286C0AF2}"/>
               </a:ext>
             </a:extLst>
           </p:cNvPr>
@@ -7677,7 +7813,7 @@
           <p:cNvPr id="5" name="">
             <a:extLst xmlns:a="http://schemas.openxmlformats.org/drawingml/2006/main">
               <a:ext uri="{FF2B5EF4-FFF2-40B4-BE49-F238E27FC236}">
-                <a16:creationId xmlns:a16="http://schemas.microsoft.com/office/drawing/2014/main" id="{449FB534-7F74-4A36-AC07-A2CE5785F88F}"/>
+                <a16:creationId xmlns:a16="http://schemas.microsoft.com/office/drawing/2014/main" id="{4450A49E-B849-4165-B899-7AE8689595D4}"/>
               </a:ext>
             </a:extLst>
           </p:cNvPr>
@@ -8311,7 +8447,7 @@
           <p:cNvPr id="6" name="">
             <a:extLst xmlns:a="http://schemas.openxmlformats.org/drawingml/2006/main">
               <a:ext uri="{FF2B5EF4-FFF2-40B4-BE49-F238E27FC236}">
-                <a16:creationId xmlns:a16="http://schemas.microsoft.com/office/drawing/2014/main" id="{AA39710A-7FEB-4F83-8857-8AD7F11E3453}"/>
+                <a16:creationId xmlns:a16="http://schemas.microsoft.com/office/drawing/2014/main" id="{DBA37316-886C-49F7-BBC2-5CA02B65B4E4}"/>
               </a:ext>
             </a:extLst>
           </p:cNvPr>
@@ -8945,7 +9081,7 @@
           <p:cNvPr id="7" name="">
             <a:extLst xmlns:a="http://schemas.openxmlformats.org/drawingml/2006/main">
               <a:ext uri="{FF2B5EF4-FFF2-40B4-BE49-F238E27FC236}">
-                <a16:creationId xmlns:a16="http://schemas.microsoft.com/office/drawing/2014/main" id="{8412FE1D-D5DC-4527-A112-C40A8DAE7C2A}"/>
+                <a16:creationId xmlns:a16="http://schemas.microsoft.com/office/drawing/2014/main" id="{A3BD5A92-3646-4D38-B61B-AC372FC5E718}"/>
               </a:ext>
             </a:extLst>
           </p:cNvPr>
@@ -9011,7 +9147,7 @@
     </p:spTree>
     <p:extLst>
       <p:ext uri="{BB962C8B-B14F-4D97-AF65-F5344CB8AC3E}">
-        <p14:creationId xmlns:p14="http://schemas.microsoft.com/office/powerpoint/2010/main" val="43469035"/>
+        <p14:creationId xmlns:p14="http://schemas.microsoft.com/office/powerpoint/2010/main" val="1519951560"/>
       </p:ext>
     </p:extLst>
   </p:cSld>
@@ -9042,7 +9178,7 @@
           <p:cNvPr id="5" name="">
             <a:extLst xmlns:a="http://schemas.openxmlformats.org/drawingml/2006/main">
               <a:ext uri="{FF2B5EF4-FFF2-40B4-BE49-F238E27FC236}">
-                <a16:creationId xmlns:a16="http://schemas.microsoft.com/office/drawing/2014/main" id="{9D423194-61F3-4916-AC48-D9A3C362AD8A}"/>
+                <a16:creationId xmlns:a16="http://schemas.microsoft.com/office/drawing/2014/main" id="{85AA4FD2-36CA-4E93-9629-66C7EB44A88A}"/>
               </a:ext>
             </a:extLst>
           </p:cNvPr>
@@ -9110,7 +9246,7 @@
           <p:cNvPr id="2" name="">
             <a:extLst xmlns:a="http://schemas.openxmlformats.org/drawingml/2006/main">
               <a:ext uri="{FF2B5EF4-FFF2-40B4-BE49-F238E27FC236}">
-                <a16:creationId xmlns:a16="http://schemas.microsoft.com/office/drawing/2014/main" id="{C68BBAFD-9FE6-42E9-88A6-8480CF9B43FD}"/>
+                <a16:creationId xmlns:a16="http://schemas.microsoft.com/office/drawing/2014/main" id="{65870EA5-001C-40B7-AD88-0A325D4A4DE3}"/>
               </a:ext>
             </a:extLst>
           </p:cNvPr>
@@ -9178,7 +9314,7 @@
           <p:cNvPr id="3" name="">
             <a:extLst xmlns:a="http://schemas.openxmlformats.org/drawingml/2006/main">
               <a:ext uri="{FF2B5EF4-FFF2-40B4-BE49-F238E27FC236}">
-                <a16:creationId xmlns:a16="http://schemas.microsoft.com/office/drawing/2014/main" id="{68ADBAA1-7F76-4F68-9834-9B528F80D0F9}"/>
+                <a16:creationId xmlns:a16="http://schemas.microsoft.com/office/drawing/2014/main" id="{7DB80955-5DD3-4EE2-8FFD-E0E715B21E78}"/>
               </a:ext>
             </a:extLst>
           </p:cNvPr>
@@ -10003,7 +10139,7 @@
           <p:cNvPr id="4" name="">
             <a:extLst xmlns:a="http://schemas.openxmlformats.org/drawingml/2006/main">
               <a:ext uri="{FF2B5EF4-FFF2-40B4-BE49-F238E27FC236}">
-                <a16:creationId xmlns:a16="http://schemas.microsoft.com/office/drawing/2014/main" id="{40FE5EBE-08A1-4AF0-941D-F36D964F0126}"/>
+                <a16:creationId xmlns:a16="http://schemas.microsoft.com/office/drawing/2014/main" id="{D31B2DBF-F181-4B67-AC5F-31864C3ACA44}"/>
               </a:ext>
             </a:extLst>
           </p:cNvPr>
@@ -10069,7 +10205,7 @@
     </p:spTree>
     <p:extLst>
       <p:ext uri="{BB962C8B-B14F-4D97-AF65-F5344CB8AC3E}">
-        <p14:creationId xmlns:p14="http://schemas.microsoft.com/office/powerpoint/2010/main" val="1732717392"/>
+        <p14:creationId xmlns:p14="http://schemas.microsoft.com/office/powerpoint/2010/main" val="1697517050"/>
       </p:ext>
     </p:extLst>
   </p:cSld>
@@ -10100,7 +10236,7 @@
           <p:cNvPr id="9" name="">
             <a:extLst xmlns:a="http://schemas.openxmlformats.org/drawingml/2006/main">
               <a:ext uri="{FF2B5EF4-FFF2-40B4-BE49-F238E27FC236}">
-                <a16:creationId xmlns:a16="http://schemas.microsoft.com/office/drawing/2014/main" id="{FE19DFC0-A889-4414-A620-C490C9FAF993}"/>
+                <a16:creationId xmlns:a16="http://schemas.microsoft.com/office/drawing/2014/main" id="{61307981-1B70-499E-B842-E09323CEDB9B}"/>
               </a:ext>
             </a:extLst>
           </p:cNvPr>
@@ -10168,7 +10304,7 @@
           <p:cNvPr id="2" name="">
             <a:extLst xmlns:a="http://schemas.openxmlformats.org/drawingml/2006/main">
               <a:ext uri="{FF2B5EF4-FFF2-40B4-BE49-F238E27FC236}">
-                <a16:creationId xmlns:a16="http://schemas.microsoft.com/office/drawing/2014/main" id="{B2F6FC79-20A2-4777-8D61-C28D68E122F7}"/>
+                <a16:creationId xmlns:a16="http://schemas.microsoft.com/office/drawing/2014/main" id="{267CA827-18E3-4814-99D3-03726E1B8C15}"/>
               </a:ext>
             </a:extLst>
           </p:cNvPr>
@@ -10236,7 +10372,7 @@
           <p:cNvPr id="3" name="">
             <a:extLst xmlns:a="http://schemas.openxmlformats.org/drawingml/2006/main">
               <a:ext uri="{FF2B5EF4-FFF2-40B4-BE49-F238E27FC236}">
-                <a16:creationId xmlns:a16="http://schemas.microsoft.com/office/drawing/2014/main" id="{8E6E14C7-50F8-43FA-8400-7D74D578663B}"/>
+                <a16:creationId xmlns:a16="http://schemas.microsoft.com/office/drawing/2014/main" id="{9CCF612E-A72D-4081-AB4F-38725C9F57F7}"/>
               </a:ext>
             </a:extLst>
           </p:cNvPr>
@@ -10304,7 +10440,7 @@
           <p:cNvPr id="4" name="">
             <a:extLst xmlns:a="http://schemas.openxmlformats.org/drawingml/2006/main">
               <a:ext uri="{FF2B5EF4-FFF2-40B4-BE49-F238E27FC236}">
-                <a16:creationId xmlns:a16="http://schemas.microsoft.com/office/drawing/2014/main" id="{B7F20E9D-687E-45BF-AA1B-F50B75D3F08D}"/>
+                <a16:creationId xmlns:a16="http://schemas.microsoft.com/office/drawing/2014/main" id="{C543EE8A-3D72-438A-B177-8B945E26724D}"/>
               </a:ext>
             </a:extLst>
           </p:cNvPr>
@@ -10372,7 +10508,7 @@
           <p:cNvPr id="5" name="">
             <a:extLst xmlns:a="http://schemas.openxmlformats.org/drawingml/2006/main">
               <a:ext uri="{FF2B5EF4-FFF2-40B4-BE49-F238E27FC236}">
-                <a16:creationId xmlns:a16="http://schemas.microsoft.com/office/drawing/2014/main" id="{B0AE553A-1F77-44C2-AFF0-1776C7767E2B}"/>
+                <a16:creationId xmlns:a16="http://schemas.microsoft.com/office/drawing/2014/main" id="{A6243356-3ACA-40DB-8275-047DF75F0412}"/>
               </a:ext>
             </a:extLst>
           </p:cNvPr>
@@ -10440,7 +10576,7 @@
           <p:cNvPr id="6" name="">
             <a:extLst xmlns:a="http://schemas.openxmlformats.org/drawingml/2006/main">
               <a:ext uri="{FF2B5EF4-FFF2-40B4-BE49-F238E27FC236}">
-                <a16:creationId xmlns:a16="http://schemas.microsoft.com/office/drawing/2014/main" id="{F159930D-AC61-4711-ABD7-5F0035A10A97}"/>
+                <a16:creationId xmlns:a16="http://schemas.microsoft.com/office/drawing/2014/main" id="{1E0BF1A3-22C2-47F9-AEA3-3DB85E1B27AC}"/>
               </a:ext>
             </a:extLst>
           </p:cNvPr>
@@ -10508,7 +10644,7 @@
           <p:cNvPr id="7" name="">
             <a:extLst xmlns:a="http://schemas.openxmlformats.org/drawingml/2006/main">
               <a:ext uri="{FF2B5EF4-FFF2-40B4-BE49-F238E27FC236}">
-                <a16:creationId xmlns:a16="http://schemas.microsoft.com/office/drawing/2014/main" id="{E477A3A9-739F-47FC-B862-59DBB5411176}"/>
+                <a16:creationId xmlns:a16="http://schemas.microsoft.com/office/drawing/2014/main" id="{BA5CFA7F-2CD4-41B6-9A5B-D8FF15D5354D}"/>
               </a:ext>
             </a:extLst>
           </p:cNvPr>
@@ -10576,7 +10712,7 @@
           <p:cNvPr id="8" name="">
             <a:extLst xmlns:a="http://schemas.openxmlformats.org/drawingml/2006/main">
               <a:ext uri="{FF2B5EF4-FFF2-40B4-BE49-F238E27FC236}">
-                <a16:creationId xmlns:a16="http://schemas.microsoft.com/office/drawing/2014/main" id="{3AF8E53B-9722-4743-8156-DD8714BA3C86}"/>
+                <a16:creationId xmlns:a16="http://schemas.microsoft.com/office/drawing/2014/main" id="{FBC11F15-2694-4085-A941-75FF037D11A3}"/>
               </a:ext>
             </a:extLst>
           </p:cNvPr>
@@ -10642,7 +10778,7 @@
     </p:spTree>
     <p:extLst>
       <p:ext uri="{BB962C8B-B14F-4D97-AF65-F5344CB8AC3E}">
-        <p14:creationId xmlns:p14="http://schemas.microsoft.com/office/powerpoint/2010/main" val="1764739013"/>
+        <p14:creationId xmlns:p14="http://schemas.microsoft.com/office/powerpoint/2010/main" val="502724675"/>
       </p:ext>
     </p:extLst>
   </p:cSld>
@@ -10673,7 +10809,7 @@
           <p:cNvPr id="5" name="">
             <a:extLst xmlns:a="http://schemas.openxmlformats.org/drawingml/2006/main">
               <a:ext uri="{FF2B5EF4-FFF2-40B4-BE49-F238E27FC236}">
-                <a16:creationId xmlns:a16="http://schemas.microsoft.com/office/drawing/2014/main" id="{C19AE8DB-348B-4EB5-B6F2-65353DFE2199}"/>
+                <a16:creationId xmlns:a16="http://schemas.microsoft.com/office/drawing/2014/main" id="{4DABC650-6323-4700-84D5-A83718E40BAF}"/>
               </a:ext>
             </a:extLst>
           </p:cNvPr>
@@ -10741,7 +10877,7 @@
           <p:cNvPr id="2" name="">
             <a:extLst xmlns:a="http://schemas.openxmlformats.org/drawingml/2006/main">
               <a:ext uri="{FF2B5EF4-FFF2-40B4-BE49-F238E27FC236}">
-                <a16:creationId xmlns:a16="http://schemas.microsoft.com/office/drawing/2014/main" id="{A9689571-A770-498C-911B-8EA7C5496152}"/>
+                <a16:creationId xmlns:a16="http://schemas.microsoft.com/office/drawing/2014/main" id="{91BF0EAC-8290-4EDF-9F9E-5063FD6C6CFA}"/>
               </a:ext>
             </a:extLst>
           </p:cNvPr>
@@ -10809,7 +10945,7 @@
           <p:cNvPr id="3" name="">
             <a:extLst xmlns:a="http://schemas.openxmlformats.org/drawingml/2006/main">
               <a:ext uri="{FF2B5EF4-FFF2-40B4-BE49-F238E27FC236}">
-                <a16:creationId xmlns:a16="http://schemas.microsoft.com/office/drawing/2014/main" id="{64187E2E-CFAD-4CBB-A6B7-43255FAE85BF}"/>
+                <a16:creationId xmlns:a16="http://schemas.microsoft.com/office/drawing/2014/main" id="{46EA80F5-76AF-4428-B98D-EF44F1217824}"/>
               </a:ext>
             </a:extLst>
           </p:cNvPr>
@@ -11333,7 +11469,7 @@
           <p:cNvPr id="4" name="">
             <a:extLst xmlns:a="http://schemas.openxmlformats.org/drawingml/2006/main">
               <a:ext uri="{FF2B5EF4-FFF2-40B4-BE49-F238E27FC236}">
-                <a16:creationId xmlns:a16="http://schemas.microsoft.com/office/drawing/2014/main" id="{31F019AD-41E8-4AD5-A8D3-ABAE8AEFA124}"/>
+                <a16:creationId xmlns:a16="http://schemas.microsoft.com/office/drawing/2014/main" id="{FA3DABE5-2036-4612-AA4A-14682C11F6F4}"/>
               </a:ext>
             </a:extLst>
           </p:cNvPr>
@@ -11399,7 +11535,7 @@
     </p:spTree>
     <p:extLst>
       <p:ext uri="{BB962C8B-B14F-4D97-AF65-F5344CB8AC3E}">
-        <p14:creationId xmlns:p14="http://schemas.microsoft.com/office/powerpoint/2010/main" val="219920388"/>
+        <p14:creationId xmlns:p14="http://schemas.microsoft.com/office/powerpoint/2010/main" val="1004002317"/>
       </p:ext>
     </p:extLst>
   </p:cSld>
@@ -11430,7 +11566,7 @@
           <p:cNvPr id="6" name="">
             <a:extLst xmlns:a="http://schemas.openxmlformats.org/drawingml/2006/main">
               <a:ext uri="{FF2B5EF4-FFF2-40B4-BE49-F238E27FC236}">
-                <a16:creationId xmlns:a16="http://schemas.microsoft.com/office/drawing/2014/main" id="{68021D24-3155-4ABC-B7B2-C7D8B45F94A0}"/>
+                <a16:creationId xmlns:a16="http://schemas.microsoft.com/office/drawing/2014/main" id="{E4C86F7C-5E67-4D8D-9F12-D88B38B6812F}"/>
               </a:ext>
             </a:extLst>
           </p:cNvPr>
@@ -11498,7 +11634,7 @@
           <p:cNvPr id="2" name="">
             <a:extLst xmlns:a="http://schemas.openxmlformats.org/drawingml/2006/main">
               <a:ext uri="{FF2B5EF4-FFF2-40B4-BE49-F238E27FC236}">
-                <a16:creationId xmlns:a16="http://schemas.microsoft.com/office/drawing/2014/main" id="{27B1842C-35CE-452E-9C81-5F936BB05FF9}"/>
+                <a16:creationId xmlns:a16="http://schemas.microsoft.com/office/drawing/2014/main" id="{26F32E0A-2339-41E1-8930-604538B677AF}"/>
               </a:ext>
             </a:extLst>
           </p:cNvPr>
@@ -11566,7 +11702,7 @@
           <p:cNvPr id="3" name="">
             <a:extLst xmlns:a="http://schemas.openxmlformats.org/drawingml/2006/main">
               <a:ext uri="{FF2B5EF4-FFF2-40B4-BE49-F238E27FC236}">
-                <a16:creationId xmlns:a16="http://schemas.microsoft.com/office/drawing/2014/main" id="{D2BA72A6-E169-472B-B19F-4831782B388D}"/>
+                <a16:creationId xmlns:a16="http://schemas.microsoft.com/office/drawing/2014/main" id="{335D477C-D9FE-482C-9AAF-317A6EAA003A}"/>
               </a:ext>
             </a:extLst>
           </p:cNvPr>
@@ -11634,7 +11770,7 @@
           <p:cNvPr id="4" name="">
             <a:extLst xmlns:a="http://schemas.openxmlformats.org/drawingml/2006/main">
               <a:ext uri="{FF2B5EF4-FFF2-40B4-BE49-F238E27FC236}">
-                <a16:creationId xmlns:a16="http://schemas.microsoft.com/office/drawing/2014/main" id="{264CB779-3FF0-4460-B266-E98C07A07F22}"/>
+                <a16:creationId xmlns:a16="http://schemas.microsoft.com/office/drawing/2014/main" id="{3B5146C3-E22F-409F-AC73-1E3644DC80F1}"/>
               </a:ext>
             </a:extLst>
           </p:cNvPr>
@@ -11702,7 +11838,7 @@
           <p:cNvPr id="5" name="">
             <a:extLst xmlns:a="http://schemas.openxmlformats.org/drawingml/2006/main">
               <a:ext uri="{FF2B5EF4-FFF2-40B4-BE49-F238E27FC236}">
-                <a16:creationId xmlns:a16="http://schemas.microsoft.com/office/drawing/2014/main" id="{A0E24837-D743-4AD3-823A-38930077A083}"/>
+                <a16:creationId xmlns:a16="http://schemas.microsoft.com/office/drawing/2014/main" id="{5DEDD044-C62E-4FFA-A62C-38C19C3AA4A6}"/>
               </a:ext>
             </a:extLst>
           </p:cNvPr>
@@ -11768,7 +11904,7 @@
     </p:spTree>
     <p:extLst>
       <p:ext uri="{BB962C8B-B14F-4D97-AF65-F5344CB8AC3E}">
-        <p14:creationId xmlns:p14="http://schemas.microsoft.com/office/powerpoint/2010/main" val="465884415"/>
+        <p14:creationId xmlns:p14="http://schemas.microsoft.com/office/powerpoint/2010/main" val="1646095239"/>
       </p:ext>
     </p:extLst>
   </p:cSld>
@@ -11799,7 +11935,7 @@
           <p:cNvPr id="8" name="">
             <a:extLst xmlns:a="http://schemas.openxmlformats.org/drawingml/2006/main">
               <a:ext uri="{FF2B5EF4-FFF2-40B4-BE49-F238E27FC236}">
-                <a16:creationId xmlns:a16="http://schemas.microsoft.com/office/drawing/2014/main" id="{72C3DC52-3665-4EB9-BCFA-77F8AAEF8471}"/>
+                <a16:creationId xmlns:a16="http://schemas.microsoft.com/office/drawing/2014/main" id="{4A311DDD-EF0F-4A68-9AA7-F6367E87498E}"/>
               </a:ext>
             </a:extLst>
           </p:cNvPr>
@@ -11867,7 +12003,7 @@
           <p:cNvPr id="2" name="">
             <a:extLst xmlns:a="http://schemas.openxmlformats.org/drawingml/2006/main">
               <a:ext uri="{FF2B5EF4-FFF2-40B4-BE49-F238E27FC236}">
-                <a16:creationId xmlns:a16="http://schemas.microsoft.com/office/drawing/2014/main" id="{F790B375-5836-4F8B-BA4B-9EDA29BCB5F6}"/>
+                <a16:creationId xmlns:a16="http://schemas.microsoft.com/office/drawing/2014/main" id="{EDCB7655-6D66-482A-A8FF-CB454A86B784}"/>
               </a:ext>
             </a:extLst>
           </p:cNvPr>
@@ -11935,7 +12071,7 @@
           <p:cNvPr id="3" name="">
             <a:extLst xmlns:a="http://schemas.openxmlformats.org/drawingml/2006/main">
               <a:ext uri="{FF2B5EF4-FFF2-40B4-BE49-F238E27FC236}">
-                <a16:creationId xmlns:a16="http://schemas.microsoft.com/office/drawing/2014/main" id="{BF58E52D-9767-43C4-8861-8F5704F584FC}"/>
+                <a16:creationId xmlns:a16="http://schemas.microsoft.com/office/drawing/2014/main" id="{76EC6AC6-8690-43C0-A4B7-065B43499708}"/>
               </a:ext>
             </a:extLst>
           </p:cNvPr>
@@ -12003,7 +12139,7 @@
           <p:cNvPr id="4" name="">
             <a:extLst xmlns:a="http://schemas.openxmlformats.org/drawingml/2006/main">
               <a:ext uri="{FF2B5EF4-FFF2-40B4-BE49-F238E27FC236}">
-                <a16:creationId xmlns:a16="http://schemas.microsoft.com/office/drawing/2014/main" id="{69B43795-1B34-4C4B-8CCC-7A2C1F9B2542}"/>
+                <a16:creationId xmlns:a16="http://schemas.microsoft.com/office/drawing/2014/main" id="{0ADFD5ED-0554-4CB0-B08F-9A309509CA36}"/>
               </a:ext>
             </a:extLst>
           </p:cNvPr>
@@ -12071,7 +12207,7 @@
           <p:cNvPr id="5" name="">
             <a:extLst xmlns:a="http://schemas.openxmlformats.org/drawingml/2006/main">
               <a:ext uri="{FF2B5EF4-FFF2-40B4-BE49-F238E27FC236}">
-                <a16:creationId xmlns:a16="http://schemas.microsoft.com/office/drawing/2014/main" id="{3DC7B063-D63E-46A0-97C4-D589C5793A0C}"/>
+                <a16:creationId xmlns:a16="http://schemas.microsoft.com/office/drawing/2014/main" id="{E3D0E06B-2B3D-49E1-94FD-08256D125195}"/>
               </a:ext>
             </a:extLst>
           </p:cNvPr>
@@ -12139,7 +12275,7 @@
           <p:cNvPr id="6" name="">
             <a:extLst xmlns:a="http://schemas.openxmlformats.org/drawingml/2006/main">
               <a:ext uri="{FF2B5EF4-FFF2-40B4-BE49-F238E27FC236}">
-                <a16:creationId xmlns:a16="http://schemas.microsoft.com/office/drawing/2014/main" id="{03414BAE-5120-4AD6-9D2A-9A4BD57CCA42}"/>
+                <a16:creationId xmlns:a16="http://schemas.microsoft.com/office/drawing/2014/main" id="{ACDD41F0-EA6A-4674-99E0-D69B5BA0FB4E}"/>
               </a:ext>
             </a:extLst>
           </p:cNvPr>
@@ -12207,7 +12343,7 @@
           <p:cNvPr id="7" name="">
             <a:extLst xmlns:a="http://schemas.openxmlformats.org/drawingml/2006/main">
               <a:ext uri="{FF2B5EF4-FFF2-40B4-BE49-F238E27FC236}">
-                <a16:creationId xmlns:a16="http://schemas.microsoft.com/office/drawing/2014/main" id="{B4AD186E-7919-4FA9-85C1-4BDDF2F819BD}"/>
+                <a16:creationId xmlns:a16="http://schemas.microsoft.com/office/drawing/2014/main" id="{CED9F458-1978-447F-88CB-3AF5E6E4599C}"/>
               </a:ext>
             </a:extLst>
           </p:cNvPr>
@@ -12273,7 +12409,7 @@
     </p:spTree>
     <p:extLst>
       <p:ext uri="{BB962C8B-B14F-4D97-AF65-F5344CB8AC3E}">
-        <p14:creationId xmlns:p14="http://schemas.microsoft.com/office/powerpoint/2010/main" val="664909922"/>
+        <p14:creationId xmlns:p14="http://schemas.microsoft.com/office/powerpoint/2010/main" val="1296823592"/>
       </p:ext>
     </p:extLst>
   </p:cSld>
@@ -12304,7 +12440,7 @@
           <p:cNvPr id="9" name="">
             <a:extLst xmlns:a="http://schemas.openxmlformats.org/drawingml/2006/main">
               <a:ext uri="{FF2B5EF4-FFF2-40B4-BE49-F238E27FC236}">
-                <a16:creationId xmlns:a16="http://schemas.microsoft.com/office/drawing/2014/main" id="{543030E6-653E-46B3-B9B9-1063956360B3}"/>
+                <a16:creationId xmlns:a16="http://schemas.microsoft.com/office/drawing/2014/main" id="{D6650B8A-0099-42B1-AAF2-5ADD334276FC}"/>
               </a:ext>
             </a:extLst>
           </p:cNvPr>
@@ -12372,7 +12508,7 @@
           <p:cNvPr id="2" name="">
             <a:extLst xmlns:a="http://schemas.openxmlformats.org/drawingml/2006/main">
               <a:ext uri="{FF2B5EF4-FFF2-40B4-BE49-F238E27FC236}">
-                <a16:creationId xmlns:a16="http://schemas.microsoft.com/office/drawing/2014/main" id="{D4FD7058-ECD5-44A2-AFB0-B87341A4E17F}"/>
+                <a16:creationId xmlns:a16="http://schemas.microsoft.com/office/drawing/2014/main" id="{5CB9DD18-A09F-4477-827D-AAFFE7558624}"/>
               </a:ext>
             </a:extLst>
           </p:cNvPr>
@@ -12440,7 +12576,7 @@
           <p:cNvPr id="3" name="">
             <a:extLst xmlns:a="http://schemas.openxmlformats.org/drawingml/2006/main">
               <a:ext uri="{FF2B5EF4-FFF2-40B4-BE49-F238E27FC236}">
-                <a16:creationId xmlns:a16="http://schemas.microsoft.com/office/drawing/2014/main" id="{0A1EEEB6-7A96-4FF1-B21E-1B2EF0341B30}"/>
+                <a16:creationId xmlns:a16="http://schemas.microsoft.com/office/drawing/2014/main" id="{8CC871A7-6945-4B21-B06F-4DAF5526A0FF}"/>
               </a:ext>
             </a:extLst>
           </p:cNvPr>
@@ -12531,7 +12667,7 @@
           <p:cNvPr id="4" name="">
             <a:extLst xmlns:a="http://schemas.openxmlformats.org/drawingml/2006/main">
               <a:ext uri="{FF2B5EF4-FFF2-40B4-BE49-F238E27FC236}">
-                <a16:creationId xmlns:a16="http://schemas.microsoft.com/office/drawing/2014/main" id="{088ED1EC-BDF4-491E-A989-98049796FFC3}"/>
+                <a16:creationId xmlns:a16="http://schemas.microsoft.com/office/drawing/2014/main" id="{895E2EE0-79E4-4372-96EF-792E202367E3}"/>
               </a:ext>
             </a:extLst>
           </p:cNvPr>
@@ -12599,7 +12735,7 @@
           <p:cNvPr id="5" name="">
             <a:extLst xmlns:a="http://schemas.openxmlformats.org/drawingml/2006/main">
               <a:ext uri="{FF2B5EF4-FFF2-40B4-BE49-F238E27FC236}">
-                <a16:creationId xmlns:a16="http://schemas.microsoft.com/office/drawing/2014/main" id="{2BD1DDA6-E077-4B0A-9BFA-E8F754C66D92}"/>
+                <a16:creationId xmlns:a16="http://schemas.microsoft.com/office/drawing/2014/main" id="{24D75106-7AF0-4173-BD35-EFD2AEE7D701}"/>
               </a:ext>
             </a:extLst>
           </p:cNvPr>
@@ -12667,7 +12803,7 @@
           <p:cNvPr id="6" name="">
             <a:extLst xmlns:a="http://schemas.openxmlformats.org/drawingml/2006/main">
               <a:ext uri="{FF2B5EF4-FFF2-40B4-BE49-F238E27FC236}">
-                <a16:creationId xmlns:a16="http://schemas.microsoft.com/office/drawing/2014/main" id="{2C18A79C-B62C-4405-B478-0B4C05931158}"/>
+                <a16:creationId xmlns:a16="http://schemas.microsoft.com/office/drawing/2014/main" id="{5142904F-B728-41B1-A497-60E105B5DDDF}"/>
               </a:ext>
             </a:extLst>
           </p:cNvPr>
@@ -12735,7 +12871,7 @@
           <p:cNvPr id="7" name="">
             <a:extLst xmlns:a="http://schemas.openxmlformats.org/drawingml/2006/main">
               <a:ext uri="{FF2B5EF4-FFF2-40B4-BE49-F238E27FC236}">
-                <a16:creationId xmlns:a16="http://schemas.microsoft.com/office/drawing/2014/main" id="{12E9428C-8E4B-4624-9980-7354FF0E908F}"/>
+                <a16:creationId xmlns:a16="http://schemas.microsoft.com/office/drawing/2014/main" id="{49B8CF20-C52A-4230-9C3B-C9A92748DAA8}"/>
               </a:ext>
             </a:extLst>
           </p:cNvPr>
@@ -12803,7 +12939,7 @@
           <p:cNvPr id="8" name="">
             <a:extLst xmlns:a="http://schemas.openxmlformats.org/drawingml/2006/main">
               <a:ext uri="{FF2B5EF4-FFF2-40B4-BE49-F238E27FC236}">
-                <a16:creationId xmlns:a16="http://schemas.microsoft.com/office/drawing/2014/main" id="{40528AA9-AD24-4783-B4FF-D93B79CB4620}"/>
+                <a16:creationId xmlns:a16="http://schemas.microsoft.com/office/drawing/2014/main" id="{BCDE0D12-7A5B-401B-B5B7-538A1741B7EE}"/>
               </a:ext>
             </a:extLst>
           </p:cNvPr>
@@ -12869,7 +13005,7 @@
     </p:spTree>
     <p:extLst>
       <p:ext uri="{BB962C8B-B14F-4D97-AF65-F5344CB8AC3E}">
-        <p14:creationId xmlns:p14="http://schemas.microsoft.com/office/powerpoint/2010/main" val="1671099860"/>
+        <p14:creationId xmlns:p14="http://schemas.microsoft.com/office/powerpoint/2010/main" val="1167234882"/>
       </p:ext>
     </p:extLst>
   </p:cSld>
@@ -12900,7 +13036,7 @@
           <p:cNvPr id="5" name="">
             <a:extLst xmlns:a="http://schemas.openxmlformats.org/drawingml/2006/main">
               <a:ext uri="{FF2B5EF4-FFF2-40B4-BE49-F238E27FC236}">
-                <a16:creationId xmlns:a16="http://schemas.microsoft.com/office/drawing/2014/main" id="{0438D6EB-0008-4B3F-9BCE-EBCAC3758216}"/>
+                <a16:creationId xmlns:a16="http://schemas.microsoft.com/office/drawing/2014/main" id="{B1361616-85DB-4DFA-B730-5CBE83858869}"/>
               </a:ext>
             </a:extLst>
           </p:cNvPr>
@@ -12968,7 +13104,7 @@
           <p:cNvPr id="2" name="">
             <a:extLst xmlns:a="http://schemas.openxmlformats.org/drawingml/2006/main">
               <a:ext uri="{FF2B5EF4-FFF2-40B4-BE49-F238E27FC236}">
-                <a16:creationId xmlns:a16="http://schemas.microsoft.com/office/drawing/2014/main" id="{575392D9-EC57-4463-AC84-E123BE6C1987}"/>
+                <a16:creationId xmlns:a16="http://schemas.microsoft.com/office/drawing/2014/main" id="{14EDBD20-2D60-404D-9B74-F1FAE471B89D}"/>
               </a:ext>
             </a:extLst>
           </p:cNvPr>
@@ -13036,7 +13172,7 @@
           <p:cNvPr id="3" name="">
             <a:extLst xmlns:a="http://schemas.openxmlformats.org/drawingml/2006/main">
               <a:ext uri="{FF2B5EF4-FFF2-40B4-BE49-F238E27FC236}">
-                <a16:creationId xmlns:a16="http://schemas.microsoft.com/office/drawing/2014/main" id="{E5FBB8FD-6B13-4C9C-BCFA-BD5EB1DD82EB}"/>
+                <a16:creationId xmlns:a16="http://schemas.microsoft.com/office/drawing/2014/main" id="{30F2C4C4-293E-444A-8ECB-609A91D8970E}"/>
               </a:ext>
             </a:extLst>
           </p:cNvPr>
@@ -15498,7 +15634,7 @@
           <p:cNvPr id="4" name="">
             <a:extLst xmlns:a="http://schemas.openxmlformats.org/drawingml/2006/main">
               <a:ext uri="{FF2B5EF4-FFF2-40B4-BE49-F238E27FC236}">
-                <a16:creationId xmlns:a16="http://schemas.microsoft.com/office/drawing/2014/main" id="{DC21EFD1-D672-4217-95E3-328D7C347ACB}"/>
+                <a16:creationId xmlns:a16="http://schemas.microsoft.com/office/drawing/2014/main" id="{11AD869C-4BA7-4B67-9C20-44FCF29B2397}"/>
               </a:ext>
             </a:extLst>
           </p:cNvPr>
@@ -15564,7 +15700,7 @@
     </p:spTree>
     <p:extLst>
       <p:ext uri="{BB962C8B-B14F-4D97-AF65-F5344CB8AC3E}">
-        <p14:creationId xmlns:p14="http://schemas.microsoft.com/office/powerpoint/2010/main" val="1256590060"/>
+        <p14:creationId xmlns:p14="http://schemas.microsoft.com/office/powerpoint/2010/main" val="410141550"/>
       </p:ext>
     </p:extLst>
   </p:cSld>
@@ -15595,7 +15731,7 @@
           <p:cNvPr id="5" name="">
             <a:extLst xmlns:a="http://schemas.openxmlformats.org/drawingml/2006/main">
               <a:ext uri="{FF2B5EF4-FFF2-40B4-BE49-F238E27FC236}">
-                <a16:creationId xmlns:a16="http://schemas.microsoft.com/office/drawing/2014/main" id="{05DD83D1-3F18-4559-982F-F6D5ECEB99FB}"/>
+                <a16:creationId xmlns:a16="http://schemas.microsoft.com/office/drawing/2014/main" id="{3A234179-B14F-439B-9EA6-45D0A1CA1637}"/>
               </a:ext>
             </a:extLst>
           </p:cNvPr>
@@ -15663,7 +15799,7 @@
           <p:cNvPr id="2" name="">
             <a:extLst xmlns:a="http://schemas.openxmlformats.org/drawingml/2006/main">
               <a:ext uri="{FF2B5EF4-FFF2-40B4-BE49-F238E27FC236}">
-                <a16:creationId xmlns:a16="http://schemas.microsoft.com/office/drawing/2014/main" id="{4D60B653-29E1-45E4-9861-6643A880AFFA}"/>
+                <a16:creationId xmlns:a16="http://schemas.microsoft.com/office/drawing/2014/main" id="{E55544A7-DE0F-42AB-BA31-1601293ED12D}"/>
               </a:ext>
             </a:extLst>
           </p:cNvPr>
@@ -15731,7 +15867,7 @@
           <p:cNvPr id="3" name="">
             <a:extLst xmlns:a="http://schemas.openxmlformats.org/drawingml/2006/main">
               <a:ext uri="{FF2B5EF4-FFF2-40B4-BE49-F238E27FC236}">
-                <a16:creationId xmlns:a16="http://schemas.microsoft.com/office/drawing/2014/main" id="{F0452C8D-BCEB-4A08-96FB-118091CAC0B3}"/>
+                <a16:creationId xmlns:a16="http://schemas.microsoft.com/office/drawing/2014/main" id="{E2E73DFC-2E98-43E0-9D12-C4E08C218F39}"/>
               </a:ext>
             </a:extLst>
           </p:cNvPr>
@@ -18193,7 +18329,7 @@
           <p:cNvPr id="4" name="">
             <a:extLst xmlns:a="http://schemas.openxmlformats.org/drawingml/2006/main">
               <a:ext uri="{FF2B5EF4-FFF2-40B4-BE49-F238E27FC236}">
-                <a16:creationId xmlns:a16="http://schemas.microsoft.com/office/drawing/2014/main" id="{F520E1BE-527F-487A-97A8-F5BC634661EA}"/>
+                <a16:creationId xmlns:a16="http://schemas.microsoft.com/office/drawing/2014/main" id="{A2F82CD7-CD82-418A-82F0-7BDBFD5BFBF2}"/>
               </a:ext>
             </a:extLst>
           </p:cNvPr>
@@ -18259,7 +18395,7 @@
     </p:spTree>
     <p:extLst>
       <p:ext uri="{BB962C8B-B14F-4D97-AF65-F5344CB8AC3E}">
-        <p14:creationId xmlns:p14="http://schemas.microsoft.com/office/powerpoint/2010/main" val="1367248247"/>
+        <p14:creationId xmlns:p14="http://schemas.microsoft.com/office/powerpoint/2010/main" val="751323123"/>
       </p:ext>
     </p:extLst>
   </p:cSld>
@@ -18290,7 +18426,7 @@
           <p:cNvPr id="6" name="">
             <a:extLst xmlns:a="http://schemas.openxmlformats.org/drawingml/2006/main">
               <a:ext uri="{FF2B5EF4-FFF2-40B4-BE49-F238E27FC236}">
-                <a16:creationId xmlns:a16="http://schemas.microsoft.com/office/drawing/2014/main" id="{FEFA8FAF-7E3A-46A8-AD21-FC2774FAFA96}"/>
+                <a16:creationId xmlns:a16="http://schemas.microsoft.com/office/drawing/2014/main" id="{9EA8EF0E-DB2B-4DB2-A6DB-FA36A88EF77D}"/>
               </a:ext>
             </a:extLst>
           </p:cNvPr>
@@ -18358,7 +18494,7 @@
           <p:cNvPr id="2" name="">
             <a:extLst xmlns:a="http://schemas.openxmlformats.org/drawingml/2006/main">
               <a:ext uri="{FF2B5EF4-FFF2-40B4-BE49-F238E27FC236}">
-                <a16:creationId xmlns:a16="http://schemas.microsoft.com/office/drawing/2014/main" id="{A4F0A3F3-621C-47FB-A145-BEF679200C52}"/>
+                <a16:creationId xmlns:a16="http://schemas.microsoft.com/office/drawing/2014/main" id="{DBBD33A4-D8AD-44FA-AE95-A84E200A52DB}"/>
               </a:ext>
             </a:extLst>
           </p:cNvPr>
@@ -18426,7 +18562,7 @@
           <p:cNvPr id="3" name="">
             <a:extLst xmlns:a="http://schemas.openxmlformats.org/drawingml/2006/main">
               <a:ext uri="{FF2B5EF4-FFF2-40B4-BE49-F238E27FC236}">
-                <a16:creationId xmlns:a16="http://schemas.microsoft.com/office/drawing/2014/main" id="{F3EFFF6E-B4F6-4454-82E1-C02234C6C307}"/>
+                <a16:creationId xmlns:a16="http://schemas.microsoft.com/office/drawing/2014/main" id="{087C0858-4B0D-4664-9F36-85C411EBE539}"/>
               </a:ext>
             </a:extLst>
           </p:cNvPr>
@@ -18619,7 +18755,7 @@
           <p:cNvPr id="4" name="">
             <a:extLst xmlns:a="http://schemas.openxmlformats.org/drawingml/2006/main">
               <a:ext uri="{FF2B5EF4-FFF2-40B4-BE49-F238E27FC236}">
-                <a16:creationId xmlns:a16="http://schemas.microsoft.com/office/drawing/2014/main" id="{8CB94DD8-123D-4397-B024-1C75778F2CEB}"/>
+                <a16:creationId xmlns:a16="http://schemas.microsoft.com/office/drawing/2014/main" id="{53B23088-AC1A-4C7E-B154-D4126EB20B1A}"/>
               </a:ext>
             </a:extLst>
           </p:cNvPr>
@@ -18812,7 +18948,7 @@
           <p:cNvPr id="5" name="">
             <a:extLst xmlns:a="http://schemas.openxmlformats.org/drawingml/2006/main">
               <a:ext uri="{FF2B5EF4-FFF2-40B4-BE49-F238E27FC236}">
-                <a16:creationId xmlns:a16="http://schemas.microsoft.com/office/drawing/2014/main" id="{DEFBD422-A7C7-4CFF-8C12-DA6FF922074E}"/>
+                <a16:creationId xmlns:a16="http://schemas.microsoft.com/office/drawing/2014/main" id="{E6F35272-B198-453E-A08F-3E78BE593E2D}"/>
               </a:ext>
             </a:extLst>
           </p:cNvPr>
@@ -18878,7 +19014,7 @@
     </p:spTree>
     <p:extLst>
       <p:ext uri="{BB962C8B-B14F-4D97-AF65-F5344CB8AC3E}">
-        <p14:creationId xmlns:p14="http://schemas.microsoft.com/office/powerpoint/2010/main" val="1102625203"/>
+        <p14:creationId xmlns:p14="http://schemas.microsoft.com/office/powerpoint/2010/main" val="1879741832"/>
       </p:ext>
     </p:extLst>
   </p:cSld>
@@ -18909,7 +19045,7 @@
           <p:cNvPr id="5" name="">
             <a:extLst xmlns:a="http://schemas.openxmlformats.org/drawingml/2006/main">
               <a:ext uri="{FF2B5EF4-FFF2-40B4-BE49-F238E27FC236}">
-                <a16:creationId xmlns:a16="http://schemas.microsoft.com/office/drawing/2014/main" id="{EE19FF51-C379-44E6-AED5-3128C8CBCC9D}"/>
+                <a16:creationId xmlns:a16="http://schemas.microsoft.com/office/drawing/2014/main" id="{E9988B4B-C953-4AA7-8B43-6EB9C00D9A21}"/>
               </a:ext>
             </a:extLst>
           </p:cNvPr>
@@ -18977,7 +19113,7 @@
           <p:cNvPr id="2" name="">
             <a:extLst xmlns:a="http://schemas.openxmlformats.org/drawingml/2006/main">
               <a:ext uri="{FF2B5EF4-FFF2-40B4-BE49-F238E27FC236}">
-                <a16:creationId xmlns:a16="http://schemas.microsoft.com/office/drawing/2014/main" id="{95CE5540-B783-4A68-8CED-B5A6854B37DA}"/>
+                <a16:creationId xmlns:a16="http://schemas.microsoft.com/office/drawing/2014/main" id="{5C181EDD-62CB-4295-A15A-2473CD8A8CF2}"/>
               </a:ext>
             </a:extLst>
           </p:cNvPr>
@@ -19045,7 +19181,7 @@
           <p:cNvPr id="3" name="">
             <a:extLst xmlns:a="http://schemas.openxmlformats.org/drawingml/2006/main">
               <a:ext uri="{FF2B5EF4-FFF2-40B4-BE49-F238E27FC236}">
-                <a16:creationId xmlns:a16="http://schemas.microsoft.com/office/drawing/2014/main" id="{08729EB8-3BAC-4692-A83D-49DCF2D287D8}"/>
+                <a16:creationId xmlns:a16="http://schemas.microsoft.com/office/drawing/2014/main" id="{36167DC7-D571-4BD1-913F-6ECB6CA4D1F1}"/>
               </a:ext>
             </a:extLst>
           </p:cNvPr>
@@ -19261,7 +19397,7 @@
           <p:cNvPr id="4" name="">
             <a:extLst xmlns:a="http://schemas.openxmlformats.org/drawingml/2006/main">
               <a:ext uri="{FF2B5EF4-FFF2-40B4-BE49-F238E27FC236}">
-                <a16:creationId xmlns:a16="http://schemas.microsoft.com/office/drawing/2014/main" id="{C9A481EF-D02E-4CC2-B770-45720F9FDA51}"/>
+                <a16:creationId xmlns:a16="http://schemas.microsoft.com/office/drawing/2014/main" id="{3F6C3762-4F93-4173-A0A7-E49C07C411FF}"/>
               </a:ext>
             </a:extLst>
           </p:cNvPr>
@@ -19327,7 +19463,7 @@
     </p:spTree>
     <p:extLst>
       <p:ext uri="{BB962C8B-B14F-4D97-AF65-F5344CB8AC3E}">
-        <p14:creationId xmlns:p14="http://schemas.microsoft.com/office/powerpoint/2010/main" val="1670242021"/>
+        <p14:creationId xmlns:p14="http://schemas.microsoft.com/office/powerpoint/2010/main" val="1311579941"/>
       </p:ext>
     </p:extLst>
   </p:cSld>
@@ -19358,7 +19494,7 @@
           <p:cNvPr id="10" name="">
             <a:extLst xmlns:a="http://schemas.openxmlformats.org/drawingml/2006/main">
               <a:ext uri="{FF2B5EF4-FFF2-40B4-BE49-F238E27FC236}">
-                <a16:creationId xmlns:a16="http://schemas.microsoft.com/office/drawing/2014/main" id="{D53DBB27-CF6E-4B32-8BB3-4C4659131D6E}"/>
+                <a16:creationId xmlns:a16="http://schemas.microsoft.com/office/drawing/2014/main" id="{79B130AA-D1F3-4637-B091-8D2F590C60E8}"/>
               </a:ext>
             </a:extLst>
           </p:cNvPr>
@@ -19426,7 +19562,7 @@
           <p:cNvPr id="2" name="">
             <a:extLst xmlns:a="http://schemas.openxmlformats.org/drawingml/2006/main">
               <a:ext uri="{FF2B5EF4-FFF2-40B4-BE49-F238E27FC236}">
-                <a16:creationId xmlns:a16="http://schemas.microsoft.com/office/drawing/2014/main" id="{264BF93D-F8A4-4699-A6FF-2BAAB7674F83}"/>
+                <a16:creationId xmlns:a16="http://schemas.microsoft.com/office/drawing/2014/main" id="{19167071-3E81-465D-911F-E0C12BFD4D01}"/>
               </a:ext>
             </a:extLst>
           </p:cNvPr>
@@ -19494,7 +19630,7 @@
           <p:cNvPr id="3" name="">
             <a:extLst xmlns:a="http://schemas.openxmlformats.org/drawingml/2006/main">
               <a:ext uri="{FF2B5EF4-FFF2-40B4-BE49-F238E27FC236}">
-                <a16:creationId xmlns:a16="http://schemas.microsoft.com/office/drawing/2014/main" id="{2B9F4B6B-B03A-40FD-AD17-FD9E4FBF3A60}"/>
+                <a16:creationId xmlns:a16="http://schemas.microsoft.com/office/drawing/2014/main" id="{FB63E25D-29BB-41E9-A3D9-3E8E8D4A60CC}"/>
               </a:ext>
             </a:extLst>
           </p:cNvPr>
@@ -19562,7 +19698,7 @@
           <p:cNvPr id="4" name="">
             <a:extLst xmlns:a="http://schemas.openxmlformats.org/drawingml/2006/main">
               <a:ext uri="{FF2B5EF4-FFF2-40B4-BE49-F238E27FC236}">
-                <a16:creationId xmlns:a16="http://schemas.microsoft.com/office/drawing/2014/main" id="{084932DD-1A58-4761-95B2-DD2EBF4CDA37}"/>
+                <a16:creationId xmlns:a16="http://schemas.microsoft.com/office/drawing/2014/main" id="{F5AFD732-A16A-45CA-8C6C-E8794D24D1DC}"/>
               </a:ext>
             </a:extLst>
           </p:cNvPr>
@@ -19630,7 +19766,7 @@
           <p:cNvPr id="5" name="">
             <a:extLst xmlns:a="http://schemas.openxmlformats.org/drawingml/2006/main">
               <a:ext uri="{FF2B5EF4-FFF2-40B4-BE49-F238E27FC236}">
-                <a16:creationId xmlns:a16="http://schemas.microsoft.com/office/drawing/2014/main" id="{91CD87E7-115D-4B0B-BD5E-817F26633D2D}"/>
+                <a16:creationId xmlns:a16="http://schemas.microsoft.com/office/drawing/2014/main" id="{A8538DCE-DFAA-4236-9BD5-AAF130D76CE7}"/>
               </a:ext>
             </a:extLst>
           </p:cNvPr>
@@ -19698,7 +19834,7 @@
           <p:cNvPr id="6" name="">
             <a:extLst xmlns:a="http://schemas.openxmlformats.org/drawingml/2006/main">
               <a:ext uri="{FF2B5EF4-FFF2-40B4-BE49-F238E27FC236}">
-                <a16:creationId xmlns:a16="http://schemas.microsoft.com/office/drawing/2014/main" id="{9C170269-C337-404C-BF49-4849396D3CDD}"/>
+                <a16:creationId xmlns:a16="http://schemas.microsoft.com/office/drawing/2014/main" id="{0405FC78-1817-4D86-B81D-B7D7E65029C2}"/>
               </a:ext>
             </a:extLst>
           </p:cNvPr>
@@ -19766,7 +19902,7 @@
           <p:cNvPr id="7" name="">
             <a:extLst xmlns:a="http://schemas.openxmlformats.org/drawingml/2006/main">
               <a:ext uri="{FF2B5EF4-FFF2-40B4-BE49-F238E27FC236}">
-                <a16:creationId xmlns:a16="http://schemas.microsoft.com/office/drawing/2014/main" id="{2A362C7D-BD09-4238-A222-18129E752589}"/>
+                <a16:creationId xmlns:a16="http://schemas.microsoft.com/office/drawing/2014/main" id="{DB85A234-7E82-4E73-98A0-A5EF60C5D321}"/>
               </a:ext>
             </a:extLst>
           </p:cNvPr>
@@ -19834,7 +19970,7 @@
           <p:cNvPr id="8" name="">
             <a:extLst xmlns:a="http://schemas.openxmlformats.org/drawingml/2006/main">
               <a:ext uri="{FF2B5EF4-FFF2-40B4-BE49-F238E27FC236}">
-                <a16:creationId xmlns:a16="http://schemas.microsoft.com/office/drawing/2014/main" id="{F1D969B6-DD00-406A-832A-63D0BFF6B64B}"/>
+                <a16:creationId xmlns:a16="http://schemas.microsoft.com/office/drawing/2014/main" id="{052B3F1B-6787-4457-8D2D-1C8A8DA5B67A}"/>
               </a:ext>
             </a:extLst>
           </p:cNvPr>
@@ -19902,7 +20038,7 @@
           <p:cNvPr id="9" name="">
             <a:extLst xmlns:a="http://schemas.openxmlformats.org/drawingml/2006/main">
               <a:ext uri="{FF2B5EF4-FFF2-40B4-BE49-F238E27FC236}">
-                <a16:creationId xmlns:a16="http://schemas.microsoft.com/office/drawing/2014/main" id="{A2174F65-59E9-4227-A141-6967B36117F4}"/>
+                <a16:creationId xmlns:a16="http://schemas.microsoft.com/office/drawing/2014/main" id="{05904EE9-1E7E-4CD3-98BC-01D00FD0E2CC}"/>
               </a:ext>
             </a:extLst>
           </p:cNvPr>
@@ -19968,7 +20104,7 @@
     </p:spTree>
     <p:extLst>
       <p:ext uri="{BB962C8B-B14F-4D97-AF65-F5344CB8AC3E}">
-        <p14:creationId xmlns:p14="http://schemas.microsoft.com/office/powerpoint/2010/main" val="974976635"/>
+        <p14:creationId xmlns:p14="http://schemas.microsoft.com/office/powerpoint/2010/main" val="1883795539"/>
       </p:ext>
     </p:extLst>
   </p:cSld>
@@ -19999,7 +20135,7 @@
           <p:cNvPr id="6" name="">
             <a:extLst xmlns:a="http://schemas.openxmlformats.org/drawingml/2006/main">
               <a:ext uri="{FF2B5EF4-FFF2-40B4-BE49-F238E27FC236}">
-                <a16:creationId xmlns:a16="http://schemas.microsoft.com/office/drawing/2014/main" id="{F1583A2B-C682-4B10-BD8A-CCB56BB69590}"/>
+                <a16:creationId xmlns:a16="http://schemas.microsoft.com/office/drawing/2014/main" id="{38D7ADBD-EACB-4CF1-9CA5-7AE69558D0CE}"/>
               </a:ext>
             </a:extLst>
           </p:cNvPr>
@@ -20067,7 +20203,7 @@
           <p:cNvPr id="2" name="">
             <a:extLst xmlns:a="http://schemas.openxmlformats.org/drawingml/2006/main">
               <a:ext uri="{FF2B5EF4-FFF2-40B4-BE49-F238E27FC236}">
-                <a16:creationId xmlns:a16="http://schemas.microsoft.com/office/drawing/2014/main" id="{3104517F-DFDA-4709-9042-DF4A2A656D57}"/>
+                <a16:creationId xmlns:a16="http://schemas.microsoft.com/office/drawing/2014/main" id="{D2D1A4CD-E99B-4A75-8BC3-22FBB964CDA8}"/>
               </a:ext>
             </a:extLst>
           </p:cNvPr>
@@ -20135,7 +20271,7 @@
           <p:cNvPr id="3" name="">
             <a:extLst xmlns:a="http://schemas.openxmlformats.org/drawingml/2006/main">
               <a:ext uri="{FF2B5EF4-FFF2-40B4-BE49-F238E27FC236}">
-                <a16:creationId xmlns:a16="http://schemas.microsoft.com/office/drawing/2014/main" id="{2BDBE2F9-D975-4D1E-A0A2-20A393C74E45}"/>
+                <a16:creationId xmlns:a16="http://schemas.microsoft.com/office/drawing/2014/main" id="{AC46E254-F738-4D45-A0D7-54230698ED8E}"/>
               </a:ext>
             </a:extLst>
           </p:cNvPr>
@@ -20767,7 +20903,7 @@
           <p:cNvPr id="4" name="">
             <a:extLst xmlns:a="http://schemas.openxmlformats.org/drawingml/2006/main">
               <a:ext uri="{FF2B5EF4-FFF2-40B4-BE49-F238E27FC236}">
-                <a16:creationId xmlns:a16="http://schemas.microsoft.com/office/drawing/2014/main" id="{8B89E4AF-C7B8-438C-A581-E90188611C9B}"/>
+                <a16:creationId xmlns:a16="http://schemas.microsoft.com/office/drawing/2014/main" id="{9A5D2D8E-511D-4363-856B-EF5C7F4A4827}"/>
               </a:ext>
             </a:extLst>
           </p:cNvPr>
@@ -20835,7 +20971,7 @@
           <p:cNvPr id="5" name="">
             <a:extLst xmlns:a="http://schemas.openxmlformats.org/drawingml/2006/main">
               <a:ext uri="{FF2B5EF4-FFF2-40B4-BE49-F238E27FC236}">
-                <a16:creationId xmlns:a16="http://schemas.microsoft.com/office/drawing/2014/main" id="{DC01752D-5F29-416C-8C9A-91649995CF90}"/>
+                <a16:creationId xmlns:a16="http://schemas.microsoft.com/office/drawing/2014/main" id="{2576ED56-6A24-4D7D-9F3E-78EE8DF007B1}"/>
               </a:ext>
             </a:extLst>
           </p:cNvPr>
@@ -20901,7 +21037,7 @@
     </p:spTree>
     <p:extLst>
       <p:ext uri="{BB962C8B-B14F-4D97-AF65-F5344CB8AC3E}">
-        <p14:creationId xmlns:p14="http://schemas.microsoft.com/office/powerpoint/2010/main" val="1913607254"/>
+        <p14:creationId xmlns:p14="http://schemas.microsoft.com/office/powerpoint/2010/main" val="523832917"/>
       </p:ext>
     </p:extLst>
   </p:cSld>
@@ -20932,7 +21068,7 @@
           <p:cNvPr id="5" name="">
             <a:extLst xmlns:a="http://schemas.openxmlformats.org/drawingml/2006/main">
               <a:ext uri="{FF2B5EF4-FFF2-40B4-BE49-F238E27FC236}">
-                <a16:creationId xmlns:a16="http://schemas.microsoft.com/office/drawing/2014/main" id="{F6ACFCD3-3717-430C-9E8F-44DDDBE5521B}"/>
+                <a16:creationId xmlns:a16="http://schemas.microsoft.com/office/drawing/2014/main" id="{3FEFC81D-0F52-4754-83BB-5ABFCC3A7382}"/>
               </a:ext>
             </a:extLst>
           </p:cNvPr>
@@ -21000,7 +21136,7 @@
           <p:cNvPr id="2" name="">
             <a:extLst xmlns:a="http://schemas.openxmlformats.org/drawingml/2006/main">
               <a:ext uri="{FF2B5EF4-FFF2-40B4-BE49-F238E27FC236}">
-                <a16:creationId xmlns:a16="http://schemas.microsoft.com/office/drawing/2014/main" id="{0BF22841-0486-40BD-AE49-9564BCAB32FE}"/>
+                <a16:creationId xmlns:a16="http://schemas.microsoft.com/office/drawing/2014/main" id="{FD02C08E-0389-4F04-81A8-412879E15456}"/>
               </a:ext>
             </a:extLst>
           </p:cNvPr>
@@ -21068,7 +21204,7 @@
           <p:cNvPr id="3" name="">
             <a:extLst xmlns:a="http://schemas.openxmlformats.org/drawingml/2006/main">
               <a:ext uri="{FF2B5EF4-FFF2-40B4-BE49-F238E27FC236}">
-                <a16:creationId xmlns:a16="http://schemas.microsoft.com/office/drawing/2014/main" id="{4EBC0B51-06BD-4886-AC6A-DA1538BBFE7A}"/>
+                <a16:creationId xmlns:a16="http://schemas.microsoft.com/office/drawing/2014/main" id="{79CBE3C9-3893-4ABF-B958-2F47FD86946C}"/>
               </a:ext>
             </a:extLst>
           </p:cNvPr>
@@ -21702,7 +21838,7 @@
           <p:cNvPr id="4" name="">
             <a:extLst xmlns:a="http://schemas.openxmlformats.org/drawingml/2006/main">
               <a:ext uri="{FF2B5EF4-FFF2-40B4-BE49-F238E27FC236}">
-                <a16:creationId xmlns:a16="http://schemas.microsoft.com/office/drawing/2014/main" id="{C0FCAA25-EEF3-49B3-8949-FD9043D3C075}"/>
+                <a16:creationId xmlns:a16="http://schemas.microsoft.com/office/drawing/2014/main" id="{06724937-9526-4C15-A869-FB05F9FC7844}"/>
               </a:ext>
             </a:extLst>
           </p:cNvPr>
@@ -21768,7 +21904,7 @@
     </p:spTree>
     <p:extLst>
       <p:ext uri="{BB962C8B-B14F-4D97-AF65-F5344CB8AC3E}">
-        <p14:creationId xmlns:p14="http://schemas.microsoft.com/office/powerpoint/2010/main" val="991394533"/>
+        <p14:creationId xmlns:p14="http://schemas.microsoft.com/office/powerpoint/2010/main" val="385649138"/>
       </p:ext>
     </p:extLst>
   </p:cSld>
@@ -21799,7 +21935,7 @@
           <p:cNvPr id="6" name="">
             <a:extLst xmlns:a="http://schemas.openxmlformats.org/drawingml/2006/main">
               <a:ext uri="{FF2B5EF4-FFF2-40B4-BE49-F238E27FC236}">
-                <a16:creationId xmlns:a16="http://schemas.microsoft.com/office/drawing/2014/main" id="{B364DE17-0F1E-4C55-8134-56114723EECD}"/>
+                <a16:creationId xmlns:a16="http://schemas.microsoft.com/office/drawing/2014/main" id="{170FAC82-18C1-4FDC-BB55-9E3F0EFC2ED8}"/>
               </a:ext>
             </a:extLst>
           </p:cNvPr>
@@ -21867,7 +22003,7 @@
           <p:cNvPr id="2" name="">
             <a:extLst xmlns:a="http://schemas.openxmlformats.org/drawingml/2006/main">
               <a:ext uri="{FF2B5EF4-FFF2-40B4-BE49-F238E27FC236}">
-                <a16:creationId xmlns:a16="http://schemas.microsoft.com/office/drawing/2014/main" id="{FD79E35A-7BE2-4894-AC88-BCFB8561FFC2}"/>
+                <a16:creationId xmlns:a16="http://schemas.microsoft.com/office/drawing/2014/main" id="{0E73EAC9-31DE-4F14-A878-2EC0314C4032}"/>
               </a:ext>
             </a:extLst>
           </p:cNvPr>
@@ -21935,7 +22071,7 @@
           <p:cNvPr id="3" name="">
             <a:extLst xmlns:a="http://schemas.openxmlformats.org/drawingml/2006/main">
               <a:ext uri="{FF2B5EF4-FFF2-40B4-BE49-F238E27FC236}">
-                <a16:creationId xmlns:a16="http://schemas.microsoft.com/office/drawing/2014/main" id="{5F47B61F-44CE-4B71-8F62-7C8F9F501B35}"/>
+                <a16:creationId xmlns:a16="http://schemas.microsoft.com/office/drawing/2014/main" id="{99C2130C-8FE1-40DF-8B4A-8F4AB3DF31FC}"/>
               </a:ext>
             </a:extLst>
           </p:cNvPr>
@@ -22026,7 +22162,7 @@
           <p:cNvPr id="4" name="">
             <a:extLst xmlns:a="http://schemas.openxmlformats.org/drawingml/2006/main">
               <a:ext uri="{FF2B5EF4-FFF2-40B4-BE49-F238E27FC236}">
-                <a16:creationId xmlns:a16="http://schemas.microsoft.com/office/drawing/2014/main" id="{A32A03FB-3EDF-46B0-8AE6-EA30E43D2F66}"/>
+                <a16:creationId xmlns:a16="http://schemas.microsoft.com/office/drawing/2014/main" id="{C551A21C-B965-4BE6-A395-D63F5177741E}"/>
               </a:ext>
             </a:extLst>
           </p:cNvPr>
@@ -22094,7 +22230,7 @@
           <p:cNvPr id="5" name="">
             <a:extLst xmlns:a="http://schemas.openxmlformats.org/drawingml/2006/main">
               <a:ext uri="{FF2B5EF4-FFF2-40B4-BE49-F238E27FC236}">
-                <a16:creationId xmlns:a16="http://schemas.microsoft.com/office/drawing/2014/main" id="{D12694DC-6D20-42E3-A8ED-15F67F84D813}"/>
+                <a16:creationId xmlns:a16="http://schemas.microsoft.com/office/drawing/2014/main" id="{B5BCC41B-402B-4EB9-8AD7-FE27FE9EA881}"/>
               </a:ext>
             </a:extLst>
           </p:cNvPr>
@@ -22206,7 +22342,7 @@
     </p:spTree>
     <p:extLst>
       <p:ext uri="{BB962C8B-B14F-4D97-AF65-F5344CB8AC3E}">
-        <p14:creationId xmlns:p14="http://schemas.microsoft.com/office/powerpoint/2010/main" val="1879871089"/>
+        <p14:creationId xmlns:p14="http://schemas.microsoft.com/office/powerpoint/2010/main" val="2102538728"/>
       </p:ext>
     </p:extLst>
   </p:cSld>
@@ -22237,7 +22373,7 @@
           <p:cNvPr id="6" name="">
             <a:extLst xmlns:a="http://schemas.openxmlformats.org/drawingml/2006/main">
               <a:ext uri="{FF2B5EF4-FFF2-40B4-BE49-F238E27FC236}">
-                <a16:creationId xmlns:a16="http://schemas.microsoft.com/office/drawing/2014/main" id="{E1BE41E4-963F-4BB1-B507-949386A8245F}"/>
+                <a16:creationId xmlns:a16="http://schemas.microsoft.com/office/drawing/2014/main" id="{A49E2302-7F77-4978-91D2-B36ADD89A9F2}"/>
               </a:ext>
             </a:extLst>
           </p:cNvPr>
@@ -22305,7 +22441,7 @@
           <p:cNvPr id="2" name="">
             <a:extLst xmlns:a="http://schemas.openxmlformats.org/drawingml/2006/main">
               <a:ext uri="{FF2B5EF4-FFF2-40B4-BE49-F238E27FC236}">
-                <a16:creationId xmlns:a16="http://schemas.microsoft.com/office/drawing/2014/main" id="{45AC3D60-4FB2-443C-90D2-8C131C8CE621}"/>
+                <a16:creationId xmlns:a16="http://schemas.microsoft.com/office/drawing/2014/main" id="{3A11D6AE-C99A-4BED-A421-9CEA2B7A96AF}"/>
               </a:ext>
             </a:extLst>
           </p:cNvPr>
@@ -22373,7 +22509,7 @@
           <p:cNvPr id="3" name="">
             <a:extLst xmlns:a="http://schemas.openxmlformats.org/drawingml/2006/main">
               <a:ext uri="{FF2B5EF4-FFF2-40B4-BE49-F238E27FC236}">
-                <a16:creationId xmlns:a16="http://schemas.microsoft.com/office/drawing/2014/main" id="{BF6A58B4-3972-44DF-A9AC-BAE605A6D979}"/>
+                <a16:creationId xmlns:a16="http://schemas.microsoft.com/office/drawing/2014/main" id="{4BC01BB9-8292-4904-80B9-4CB65B3DA40E}"/>
               </a:ext>
             </a:extLst>
           </p:cNvPr>
@@ -22441,7 +22577,7 @@
           <p:cNvPr id="4" name="">
             <a:extLst xmlns:a="http://schemas.openxmlformats.org/drawingml/2006/main">
               <a:ext uri="{FF2B5EF4-FFF2-40B4-BE49-F238E27FC236}">
-                <a16:creationId xmlns:a16="http://schemas.microsoft.com/office/drawing/2014/main" id="{0499288F-A39B-4424-BB56-5C6D98C49D0D}"/>
+                <a16:creationId xmlns:a16="http://schemas.microsoft.com/office/drawing/2014/main" id="{56FB9871-EF68-460C-9745-B7078E32EC36}"/>
               </a:ext>
             </a:extLst>
           </p:cNvPr>
@@ -22722,7 +22858,7 @@
           <p:cNvPr id="5" name="">
             <a:extLst xmlns:a="http://schemas.openxmlformats.org/drawingml/2006/main">
               <a:ext uri="{FF2B5EF4-FFF2-40B4-BE49-F238E27FC236}">
-                <a16:creationId xmlns:a16="http://schemas.microsoft.com/office/drawing/2014/main" id="{5060DCEE-5464-475C-B1CF-A4857EAC27A0}"/>
+                <a16:creationId xmlns:a16="http://schemas.microsoft.com/office/drawing/2014/main" id="{06447E91-6212-4AD2-9144-2F3B0746AE91}"/>
               </a:ext>
             </a:extLst>
           </p:cNvPr>
@@ -22788,7 +22924,7 @@
     </p:spTree>
     <p:extLst>
       <p:ext uri="{BB962C8B-B14F-4D97-AF65-F5344CB8AC3E}">
-        <p14:creationId xmlns:p14="http://schemas.microsoft.com/office/powerpoint/2010/main" val="1485510950"/>
+        <p14:creationId xmlns:p14="http://schemas.microsoft.com/office/powerpoint/2010/main" val="712887683"/>
       </p:ext>
     </p:extLst>
   </p:cSld>
@@ -22819,7 +22955,7 @@
           <p:cNvPr id="5" name="">
             <a:extLst xmlns:a="http://schemas.openxmlformats.org/drawingml/2006/main">
               <a:ext uri="{FF2B5EF4-FFF2-40B4-BE49-F238E27FC236}">
-                <a16:creationId xmlns:a16="http://schemas.microsoft.com/office/drawing/2014/main" id="{3B94AA0E-C630-4C4B-AA3B-11259D1D072F}"/>
+                <a16:creationId xmlns:a16="http://schemas.microsoft.com/office/drawing/2014/main" id="{E8792F5D-5F3A-4D2A-86ED-E8513E19B5E3}"/>
               </a:ext>
             </a:extLst>
           </p:cNvPr>
@@ -22887,7 +23023,7 @@
           <p:cNvPr id="2" name="">
             <a:extLst xmlns:a="http://schemas.openxmlformats.org/drawingml/2006/main">
               <a:ext uri="{FF2B5EF4-FFF2-40B4-BE49-F238E27FC236}">
-                <a16:creationId xmlns:a16="http://schemas.microsoft.com/office/drawing/2014/main" id="{4531B763-B702-4A37-B429-5C470D6CC096}"/>
+                <a16:creationId xmlns:a16="http://schemas.microsoft.com/office/drawing/2014/main" id="{93E48B29-E6AA-460C-BB38-4DFA0DEEFB7B}"/>
               </a:ext>
             </a:extLst>
           </p:cNvPr>
@@ -22955,7 +23091,7 @@
           <p:cNvPr id="3" name="">
             <a:extLst xmlns:a="http://schemas.openxmlformats.org/drawingml/2006/main">
               <a:ext uri="{FF2B5EF4-FFF2-40B4-BE49-F238E27FC236}">
-                <a16:creationId xmlns:a16="http://schemas.microsoft.com/office/drawing/2014/main" id="{379267F5-4421-48A5-B8AC-65FC9772E476}"/>
+                <a16:creationId xmlns:a16="http://schemas.microsoft.com/office/drawing/2014/main" id="{70322C7B-D276-449D-96C9-27431DC78447}"/>
               </a:ext>
             </a:extLst>
           </p:cNvPr>
@@ -23589,7 +23725,7 @@
           <p:cNvPr id="4" name="">
             <a:extLst xmlns:a="http://schemas.openxmlformats.org/drawingml/2006/main">
               <a:ext uri="{FF2B5EF4-FFF2-40B4-BE49-F238E27FC236}">
-                <a16:creationId xmlns:a16="http://schemas.microsoft.com/office/drawing/2014/main" id="{DFD1D2A7-096D-49DE-A3DF-60F8570F792A}"/>
+                <a16:creationId xmlns:a16="http://schemas.microsoft.com/office/drawing/2014/main" id="{AEF4A021-78FF-4047-83E1-037BD01D2513}"/>
               </a:ext>
             </a:extLst>
           </p:cNvPr>
@@ -23655,7 +23791,7 @@
     </p:spTree>
     <p:extLst>
       <p:ext uri="{BB962C8B-B14F-4D97-AF65-F5344CB8AC3E}">
-        <p14:creationId xmlns:p14="http://schemas.microsoft.com/office/powerpoint/2010/main" val="376941693"/>
+        <p14:creationId xmlns:p14="http://schemas.microsoft.com/office/powerpoint/2010/main" val="2009096512"/>
       </p:ext>
     </p:extLst>
   </p:cSld>
@@ -23686,7 +23822,7 @@
           <p:cNvPr id="5" name="">
             <a:extLst xmlns:a="http://schemas.openxmlformats.org/drawingml/2006/main">
               <a:ext uri="{FF2B5EF4-FFF2-40B4-BE49-F238E27FC236}">
-                <a16:creationId xmlns:a16="http://schemas.microsoft.com/office/drawing/2014/main" id="{36C158BB-F82E-4D6D-A9C7-113E3E43AA2C}"/>
+                <a16:creationId xmlns:a16="http://schemas.microsoft.com/office/drawing/2014/main" id="{D5860B18-0BD8-4D70-A2AF-6A0143484971}"/>
               </a:ext>
             </a:extLst>
           </p:cNvPr>
@@ -23754,7 +23890,7 @@
           <p:cNvPr id="2" name="">
             <a:extLst xmlns:a="http://schemas.openxmlformats.org/drawingml/2006/main">
               <a:ext uri="{FF2B5EF4-FFF2-40B4-BE49-F238E27FC236}">
-                <a16:creationId xmlns:a16="http://schemas.microsoft.com/office/drawing/2014/main" id="{39D338D5-03FE-4D59-AC1D-EB240AD7DCEC}"/>
+                <a16:creationId xmlns:a16="http://schemas.microsoft.com/office/drawing/2014/main" id="{36D9DE36-2A9D-4060-B4F6-17E8EEAD0277}"/>
               </a:ext>
             </a:extLst>
           </p:cNvPr>
@@ -23822,7 +23958,7 @@
           <p:cNvPr id="3" name="">
             <a:extLst xmlns:a="http://schemas.openxmlformats.org/drawingml/2006/main">
               <a:ext uri="{FF2B5EF4-FFF2-40B4-BE49-F238E27FC236}">
-                <a16:creationId xmlns:a16="http://schemas.microsoft.com/office/drawing/2014/main" id="{0DF23B1B-28FA-47CC-A49E-5E0C6CA2D3C0}"/>
+                <a16:creationId xmlns:a16="http://schemas.microsoft.com/office/drawing/2014/main" id="{A3C89D07-6257-4706-8DB9-AAA1B99476A7}"/>
               </a:ext>
             </a:extLst>
           </p:cNvPr>
@@ -24802,7 +24938,7 @@
           <p:cNvPr id="4" name="">
             <a:extLst xmlns:a="http://schemas.openxmlformats.org/drawingml/2006/main">
               <a:ext uri="{FF2B5EF4-FFF2-40B4-BE49-F238E27FC236}">
-                <a16:creationId xmlns:a16="http://schemas.microsoft.com/office/drawing/2014/main" id="{1D4B9D4F-4E11-4974-8A1B-E8F49118AD18}"/>
+                <a16:creationId xmlns:a16="http://schemas.microsoft.com/office/drawing/2014/main" id="{3786AB83-1348-4E85-BA99-F54907ECC516}"/>
               </a:ext>
             </a:extLst>
           </p:cNvPr>
@@ -24868,7 +25004,7 @@
     </p:spTree>
     <p:extLst>
       <p:ext uri="{BB962C8B-B14F-4D97-AF65-F5344CB8AC3E}">
-        <p14:creationId xmlns:p14="http://schemas.microsoft.com/office/powerpoint/2010/main" val="352192691"/>
+        <p14:creationId xmlns:p14="http://schemas.microsoft.com/office/powerpoint/2010/main" val="332118172"/>
       </p:ext>
     </p:extLst>
   </p:cSld>

</xml_diff>

<commit_message>
Refactor research showcase and presentation materials
- Deleted obsolete candidate PowerPoint and chart data snapshot files.
- Updated log.json to include new narrative workflow structure and presentation brief.
- Revised HANDOFF.md to clarify the content of the research showcase and presentation files.
- Enhanced README.md to reflect the new ten-section presentation format and navigation features.
- Updated RELEASE_MANIFEST.json with new file sizes and SHA256 checksums for modified files.
- Improved research presentation and showcase HTML files with enhanced navigation and presentation controls.
- Adjusted CSS styles in tokens.css and showcase.template.html for better presentation layout and mobile responsiveness.
- Modified rendering scripts to support higher resolution slide exports and improved presentation functionality.
</commit_message>
<xml_diff>
--- a/docs/submission/research_presentation.pptx
+++ b/docs/submission/research_presentation.pptx
@@ -2,35 +2,35 @@
 <file path=ppt/presentation.xml><?xml version="1.0" encoding="utf-8"?>
 <p:presentation xmlns:p="http://schemas.openxmlformats.org/presentationml/2006/main">
   <p:sldMasterIdLst>
-    <p:sldMasterId xmlns:r="http://schemas.openxmlformats.org/officeDocument/2006/relationships" id="2147483648" r:id="R9c6c356a00c24216"/>
+    <p:sldMasterId xmlns:r="http://schemas.openxmlformats.org/officeDocument/2006/relationships" id="2147483648" r:id="Rf3141f07d0244c4e"/>
   </p:sldMasterIdLst>
   <p:notesMasterIdLst>
-    <p:notesMasterId xmlns:r="http://schemas.openxmlformats.org/officeDocument/2006/relationships" r:id="Rf62b88b3174744a2"/>
+    <p:notesMasterId xmlns:r="http://schemas.openxmlformats.org/officeDocument/2006/relationships" r:id="R75de973936ab4be8"/>
   </p:notesMasterIdLst>
   <p:sldIdLst>
-    <p:sldId xmlns:r="http://schemas.openxmlformats.org/officeDocument/2006/relationships" id="256" r:id="R6cb99e5e24044e9c"/>
-    <p:sldId xmlns:r="http://schemas.openxmlformats.org/officeDocument/2006/relationships" id="257" r:id="R683cc98eba194053"/>
-    <p:sldId xmlns:r="http://schemas.openxmlformats.org/officeDocument/2006/relationships" id="258" r:id="R99a7462c99c3494d"/>
-    <p:sldId xmlns:r="http://schemas.openxmlformats.org/officeDocument/2006/relationships" id="259" r:id="R59517a990ce546c1"/>
-    <p:sldId xmlns:r="http://schemas.openxmlformats.org/officeDocument/2006/relationships" id="260" r:id="R203626b09bfe4434"/>
-    <p:sldId xmlns:r="http://schemas.openxmlformats.org/officeDocument/2006/relationships" id="261" r:id="Ra549c2b0f0cd420b"/>
-    <p:sldId xmlns:r="http://schemas.openxmlformats.org/officeDocument/2006/relationships" id="262" r:id="Rda5e393662cc4118"/>
-    <p:sldId xmlns:r="http://schemas.openxmlformats.org/officeDocument/2006/relationships" id="263" r:id="R4049471c62284674"/>
-    <p:sldId xmlns:r="http://schemas.openxmlformats.org/officeDocument/2006/relationships" id="264" r:id="R448186e904ed4b4c"/>
-    <p:sldId xmlns:r="http://schemas.openxmlformats.org/officeDocument/2006/relationships" id="265" r:id="Rd3ee439cbc9d4f46"/>
-    <p:sldId xmlns:r="http://schemas.openxmlformats.org/officeDocument/2006/relationships" id="266" r:id="Rae8e191268054114"/>
-    <p:sldId xmlns:r="http://schemas.openxmlformats.org/officeDocument/2006/relationships" id="267" r:id="R92ef950385e2427b"/>
-    <p:sldId xmlns:r="http://schemas.openxmlformats.org/officeDocument/2006/relationships" id="268" r:id="R7a32e770adea4af9"/>
-    <p:sldId xmlns:r="http://schemas.openxmlformats.org/officeDocument/2006/relationships" id="269" r:id="Rd639337330ab4c78"/>
-    <p:sldId xmlns:r="http://schemas.openxmlformats.org/officeDocument/2006/relationships" id="270" r:id="R7bbdc004b7cc4c62"/>
-    <p:sldId xmlns:r="http://schemas.openxmlformats.org/officeDocument/2006/relationships" id="271" r:id="Rddf6081a3d194d35"/>
-    <p:sldId xmlns:r="http://schemas.openxmlformats.org/officeDocument/2006/relationships" id="272" r:id="R9eaec823b0134e4c"/>
-    <p:sldId xmlns:r="http://schemas.openxmlformats.org/officeDocument/2006/relationships" id="273" r:id="R3a043eb3ce8f41e1"/>
-    <p:sldId xmlns:r="http://schemas.openxmlformats.org/officeDocument/2006/relationships" id="274" r:id="R5f44069003674a11"/>
-    <p:sldId xmlns:r="http://schemas.openxmlformats.org/officeDocument/2006/relationships" id="275" r:id="R6a37f5f1d7734e3f"/>
-    <p:sldId xmlns:r="http://schemas.openxmlformats.org/officeDocument/2006/relationships" id="276" r:id="R2a3391cb63554041"/>
-    <p:sldId xmlns:r="http://schemas.openxmlformats.org/officeDocument/2006/relationships" id="277" r:id="Rc68e90da0254457c"/>
-    <p:sldId xmlns:r="http://schemas.openxmlformats.org/officeDocument/2006/relationships" id="278" r:id="R928662f164a0486f"/>
+    <p:sldId xmlns:r="http://schemas.openxmlformats.org/officeDocument/2006/relationships" id="256" r:id="R8741b8880040412a"/>
+    <p:sldId xmlns:r="http://schemas.openxmlformats.org/officeDocument/2006/relationships" id="257" r:id="R60706d809fae478a"/>
+    <p:sldId xmlns:r="http://schemas.openxmlformats.org/officeDocument/2006/relationships" id="258" r:id="R511813c432994962"/>
+    <p:sldId xmlns:r="http://schemas.openxmlformats.org/officeDocument/2006/relationships" id="259" r:id="R00efe6bb56ed4c06"/>
+    <p:sldId xmlns:r="http://schemas.openxmlformats.org/officeDocument/2006/relationships" id="260" r:id="Rc8d51fff54804e6d"/>
+    <p:sldId xmlns:r="http://schemas.openxmlformats.org/officeDocument/2006/relationships" id="261" r:id="R725227c035fa4f80"/>
+    <p:sldId xmlns:r="http://schemas.openxmlformats.org/officeDocument/2006/relationships" id="262" r:id="Re1071f936f5d47ce"/>
+    <p:sldId xmlns:r="http://schemas.openxmlformats.org/officeDocument/2006/relationships" id="263" r:id="R698ec056f25f43d3"/>
+    <p:sldId xmlns:r="http://schemas.openxmlformats.org/officeDocument/2006/relationships" id="264" r:id="Rbd2f7cc96d8d4b19"/>
+    <p:sldId xmlns:r="http://schemas.openxmlformats.org/officeDocument/2006/relationships" id="265" r:id="R44445afd76584d0f"/>
+    <p:sldId xmlns:r="http://schemas.openxmlformats.org/officeDocument/2006/relationships" id="266" r:id="R398052737aa54416"/>
+    <p:sldId xmlns:r="http://schemas.openxmlformats.org/officeDocument/2006/relationships" id="267" r:id="R9d480f6f31aa4e98"/>
+    <p:sldId xmlns:r="http://schemas.openxmlformats.org/officeDocument/2006/relationships" id="268" r:id="R3cf1c412e3934b0c"/>
+    <p:sldId xmlns:r="http://schemas.openxmlformats.org/officeDocument/2006/relationships" id="269" r:id="Rbb6e128b5deb4f57"/>
+    <p:sldId xmlns:r="http://schemas.openxmlformats.org/officeDocument/2006/relationships" id="270" r:id="R5d89a30cc71246b7"/>
+    <p:sldId xmlns:r="http://schemas.openxmlformats.org/officeDocument/2006/relationships" id="271" r:id="Ra78a85908b344759"/>
+    <p:sldId xmlns:r="http://schemas.openxmlformats.org/officeDocument/2006/relationships" id="272" r:id="Rabc680f655434d2e"/>
+    <p:sldId xmlns:r="http://schemas.openxmlformats.org/officeDocument/2006/relationships" id="273" r:id="R4e976ed4716a4487"/>
+    <p:sldId xmlns:r="http://schemas.openxmlformats.org/officeDocument/2006/relationships" id="274" r:id="Rbb8e961cbf5a455c"/>
+    <p:sldId xmlns:r="http://schemas.openxmlformats.org/officeDocument/2006/relationships" id="275" r:id="R21d495b09faf47c9"/>
+    <p:sldId xmlns:r="http://schemas.openxmlformats.org/officeDocument/2006/relationships" id="276" r:id="R8a89663becd94e54"/>
+    <p:sldId xmlns:r="http://schemas.openxmlformats.org/officeDocument/2006/relationships" id="277" r:id="Ra743ce98ca7b465d"/>
+    <p:sldId xmlns:r="http://schemas.openxmlformats.org/officeDocument/2006/relationships" id="278" r:id="Ra9a66d9dced044e6"/>
   </p:sldIdLst>
   <p:sldSz cx="12192000" cy="6858000"/>
   <p:notesSz cx="6858000" cy="9144000"/>
@@ -2081,7 +2081,7 @@
           <p:cNvPr id="3" name="Title">
             <a:extLst xmlns:a="http://schemas.openxmlformats.org/drawingml/2006/main">
               <a:ext uri="{FF2B5EF4-FFF2-40B4-BE49-F238E27FC236}">
-                <a16:creationId xmlns:a16="http://schemas.microsoft.com/office/drawing/2014/main" id="{447D57F2-0EB2-4257-B43D-9A092395016A}"/>
+                <a16:creationId xmlns:a16="http://schemas.microsoft.com/office/drawing/2014/main" id="{8CD807F8-1F5E-460E-9AE3-7BB9EE2AA8F1}"/>
               </a:ext>
             </a:extLst>
           </p:cNvPr>
@@ -2238,7 +2238,7 @@
           <p:cNvPr id="2" name="Subtitle">
             <a:extLst xmlns:a="http://schemas.openxmlformats.org/drawingml/2006/main">
               <a:ext uri="{FF2B5EF4-FFF2-40B4-BE49-F238E27FC236}">
-                <a16:creationId xmlns:a16="http://schemas.microsoft.com/office/drawing/2014/main" id="{0919F2FD-37B5-4D8D-B944-415337289286}"/>
+                <a16:creationId xmlns:a16="http://schemas.microsoft.com/office/drawing/2014/main" id="{A4AAEE87-77FA-4BFD-8121-35AAF5C12864}"/>
               </a:ext>
             </a:extLst>
           </p:cNvPr>
@@ -2412,7 +2412,7 @@
           <p:cNvPr id="2" name="Section title">
             <a:extLst xmlns:a="http://schemas.openxmlformats.org/drawingml/2006/main">
               <a:ext uri="{FF2B5EF4-FFF2-40B4-BE49-F238E27FC236}">
-                <a16:creationId xmlns:a16="http://schemas.microsoft.com/office/drawing/2014/main" id="{4CE11F3D-232D-49F5-8E75-0045CED98AC6}"/>
+                <a16:creationId xmlns:a16="http://schemas.microsoft.com/office/drawing/2014/main" id="{511AB818-91B6-4D95-B426-874C9700CBEC}"/>
               </a:ext>
             </a:extLst>
           </p:cNvPr>
@@ -2586,7 +2586,7 @@
           <p:cNvPr id="3" name="Title">
             <a:extLst xmlns:a="http://schemas.openxmlformats.org/drawingml/2006/main">
               <a:ext uri="{FF2B5EF4-FFF2-40B4-BE49-F238E27FC236}">
-                <a16:creationId xmlns:a16="http://schemas.microsoft.com/office/drawing/2014/main" id="{DD4D0A99-2C6A-41CD-8154-8EC66181129F}"/>
+                <a16:creationId xmlns:a16="http://schemas.microsoft.com/office/drawing/2014/main" id="{AC071DF1-C700-4E56-ADF0-0F8911ADF3B4}"/>
               </a:ext>
             </a:extLst>
           </p:cNvPr>
@@ -2743,7 +2743,7 @@
           <p:cNvPr id="2" name="Body">
             <a:extLst xmlns:a="http://schemas.openxmlformats.org/drawingml/2006/main">
               <a:ext uri="{FF2B5EF4-FFF2-40B4-BE49-F238E27FC236}">
-                <a16:creationId xmlns:a16="http://schemas.microsoft.com/office/drawing/2014/main" id="{F75F5044-207D-4F85-93DF-BCEEB2878C5B}"/>
+                <a16:creationId xmlns:a16="http://schemas.microsoft.com/office/drawing/2014/main" id="{E5E30F3C-9BF6-46A3-BA08-2F49ADCA627B}"/>
               </a:ext>
             </a:extLst>
           </p:cNvPr>
@@ -2917,7 +2917,7 @@
           <p:cNvPr id="4" name="Title">
             <a:extLst xmlns:a="http://schemas.openxmlformats.org/drawingml/2006/main">
               <a:ext uri="{FF2B5EF4-FFF2-40B4-BE49-F238E27FC236}">
-                <a16:creationId xmlns:a16="http://schemas.microsoft.com/office/drawing/2014/main" id="{2D191EF2-BCE6-46F5-8AA0-436EDC9BB60C}"/>
+                <a16:creationId xmlns:a16="http://schemas.microsoft.com/office/drawing/2014/main" id="{4BEAFF15-D9B2-45C3-9799-6E57D47A4355}"/>
               </a:ext>
             </a:extLst>
           </p:cNvPr>
@@ -3074,7 +3074,7 @@
           <p:cNvPr id="2" name="Left column">
             <a:extLst xmlns:a="http://schemas.openxmlformats.org/drawingml/2006/main">
               <a:ext uri="{FF2B5EF4-FFF2-40B4-BE49-F238E27FC236}">
-                <a16:creationId xmlns:a16="http://schemas.microsoft.com/office/drawing/2014/main" id="{28367350-2BC3-4EE1-8C2C-2F42AAA44F31}"/>
+                <a16:creationId xmlns:a16="http://schemas.microsoft.com/office/drawing/2014/main" id="{F8587A12-A90B-4308-A1A6-24B5F378D3CA}"/>
               </a:ext>
             </a:extLst>
           </p:cNvPr>
@@ -3231,7 +3231,7 @@
           <p:cNvPr id="3" name="Right column">
             <a:extLst xmlns:a="http://schemas.openxmlformats.org/drawingml/2006/main">
               <a:ext uri="{FF2B5EF4-FFF2-40B4-BE49-F238E27FC236}">
-                <a16:creationId xmlns:a16="http://schemas.microsoft.com/office/drawing/2014/main" id="{D53E00B6-69D3-482D-B28E-59A569D418C1}"/>
+                <a16:creationId xmlns:a16="http://schemas.microsoft.com/office/drawing/2014/main" id="{1A966A55-707C-46AD-B61C-E4F636CB9F7C}"/>
               </a:ext>
             </a:extLst>
           </p:cNvPr>
@@ -3405,7 +3405,7 @@
           <p:cNvPr id="3" name="Title">
             <a:extLst xmlns:a="http://schemas.openxmlformats.org/drawingml/2006/main">
               <a:ext uri="{FF2B5EF4-FFF2-40B4-BE49-F238E27FC236}">
-                <a16:creationId xmlns:a16="http://schemas.microsoft.com/office/drawing/2014/main" id="{331DCDEF-D467-48CD-B709-4662A37DA214}"/>
+                <a16:creationId xmlns:a16="http://schemas.microsoft.com/office/drawing/2014/main" id="{F2DDFA7A-3AE6-4BFD-B484-1F248A7E769C}"/>
               </a:ext>
             </a:extLst>
           </p:cNvPr>
@@ -3562,7 +3562,7 @@
           <p:cNvPr id="2" name="Left column">
             <a:extLst xmlns:a="http://schemas.openxmlformats.org/drawingml/2006/main">
               <a:ext uri="{FF2B5EF4-FFF2-40B4-BE49-F238E27FC236}">
-                <a16:creationId xmlns:a16="http://schemas.microsoft.com/office/drawing/2014/main" id="{F3D2301E-8EFD-4652-AEDC-557CB212A7C8}"/>
+                <a16:creationId xmlns:a16="http://schemas.microsoft.com/office/drawing/2014/main" id="{63ABE266-3DF7-4DEE-87F6-34E217485398}"/>
               </a:ext>
             </a:extLst>
           </p:cNvPr>
@@ -3757,12 +3757,12 @@
   </p:cSld>
   <p:clrMap bg1="lt1" tx1="dk1" bg2="lt2" tx2="dk2" accent1="accent1" accent2="accent2" accent3="accent3" accent4="accent4" accent5="accent5" accent6="accent6" hlink="hlink" folHlink="folHlink"/>
   <p:sldLayoutIdLst>
-    <p:sldLayoutId xmlns:r="http://schemas.openxmlformats.org/officeDocument/2006/relationships" id="2147483649" r:id="R2e0edd4e3cd04fda"/>
-    <p:sldLayoutId xmlns:r="http://schemas.openxmlformats.org/officeDocument/2006/relationships" id="2147483650" r:id="R2c8b26480ccf46f4"/>
-    <p:sldLayoutId xmlns:r="http://schemas.openxmlformats.org/officeDocument/2006/relationships" id="2147483651" r:id="Rf1535c47096c474e"/>
-    <p:sldLayoutId xmlns:r="http://schemas.openxmlformats.org/officeDocument/2006/relationships" id="2147483652" r:id="R3b4c1fee34b344cd"/>
-    <p:sldLayoutId xmlns:r="http://schemas.openxmlformats.org/officeDocument/2006/relationships" id="2147483653" r:id="R0cca37785f724de7"/>
-    <p:sldLayoutId xmlns:r="http://schemas.openxmlformats.org/officeDocument/2006/relationships" id="2147483654" r:id="R02b02aa8e2434641"/>
+    <p:sldLayoutId xmlns:r="http://schemas.openxmlformats.org/officeDocument/2006/relationships" id="2147483649" r:id="R1ddf1c42ceec41ff"/>
+    <p:sldLayoutId xmlns:r="http://schemas.openxmlformats.org/officeDocument/2006/relationships" id="2147483650" r:id="Rd0bd8a6b99c24ac6"/>
+    <p:sldLayoutId xmlns:r="http://schemas.openxmlformats.org/officeDocument/2006/relationships" id="2147483651" r:id="R3070a66773954d91"/>
+    <p:sldLayoutId xmlns:r="http://schemas.openxmlformats.org/officeDocument/2006/relationships" id="2147483652" r:id="R46e495c09f8c4356"/>
+    <p:sldLayoutId xmlns:r="http://schemas.openxmlformats.org/officeDocument/2006/relationships" id="2147483653" r:id="R2964e236a8594b75"/>
+    <p:sldLayoutId xmlns:r="http://schemas.openxmlformats.org/officeDocument/2006/relationships" id="2147483654" r:id="R0b5d0079569441b8"/>
   </p:sldLayoutIdLst>
   <p:txStyles>
     <p:titleStyle>
@@ -4717,7 +4717,7 @@
           <p:cNvPr id="8" name="">
             <a:extLst xmlns:a="http://schemas.openxmlformats.org/drawingml/2006/main">
               <a:ext uri="{FF2B5EF4-FFF2-40B4-BE49-F238E27FC236}">
-                <a16:creationId xmlns:a16="http://schemas.microsoft.com/office/drawing/2014/main" id="{C66C6C70-269E-4929-A9D7-FB7DD73CF30C}"/>
+                <a16:creationId xmlns:a16="http://schemas.microsoft.com/office/drawing/2014/main" id="{B98ADD8C-49F0-460E-9371-581F8EF906EE}"/>
               </a:ext>
             </a:extLst>
           </p:cNvPr>
@@ -4785,7 +4785,7 @@
           <p:cNvPr id="2" name="">
             <a:extLst xmlns:a="http://schemas.openxmlformats.org/drawingml/2006/main">
               <a:ext uri="{FF2B5EF4-FFF2-40B4-BE49-F238E27FC236}">
-                <a16:creationId xmlns:a16="http://schemas.microsoft.com/office/drawing/2014/main" id="{F825BFEA-EEC1-40D9-A3E1-0FDA22EC2FC5}"/>
+                <a16:creationId xmlns:a16="http://schemas.microsoft.com/office/drawing/2014/main" id="{075AEA12-E67B-4982-A75D-7575B2688326}"/>
               </a:ext>
             </a:extLst>
           </p:cNvPr>
@@ -4876,7 +4876,7 @@
           <p:cNvPr id="3" name="">
             <a:extLst xmlns:a="http://schemas.openxmlformats.org/drawingml/2006/main">
               <a:ext uri="{FF2B5EF4-FFF2-40B4-BE49-F238E27FC236}">
-                <a16:creationId xmlns:a16="http://schemas.microsoft.com/office/drawing/2014/main" id="{A18A9D4D-27B9-404D-BAEA-ADDD70716812}"/>
+                <a16:creationId xmlns:a16="http://schemas.microsoft.com/office/drawing/2014/main" id="{204B4AE6-5420-4966-B857-4E45EF0D67A8}"/>
               </a:ext>
             </a:extLst>
           </p:cNvPr>
@@ -4944,7 +4944,7 @@
           <p:cNvPr id="4" name="">
             <a:extLst xmlns:a="http://schemas.openxmlformats.org/drawingml/2006/main">
               <a:ext uri="{FF2B5EF4-FFF2-40B4-BE49-F238E27FC236}">
-                <a16:creationId xmlns:a16="http://schemas.microsoft.com/office/drawing/2014/main" id="{197FFEA0-8602-4324-99B7-9483EFCA7406}"/>
+                <a16:creationId xmlns:a16="http://schemas.microsoft.com/office/drawing/2014/main" id="{5AD7B6DA-E317-465D-81D6-AE86A04D5CDE}"/>
               </a:ext>
             </a:extLst>
           </p:cNvPr>
@@ -5012,7 +5012,7 @@
           <p:cNvPr id="5" name="">
             <a:extLst xmlns:a="http://schemas.openxmlformats.org/drawingml/2006/main">
               <a:ext uri="{FF2B5EF4-FFF2-40B4-BE49-F238E27FC236}">
-                <a16:creationId xmlns:a16="http://schemas.microsoft.com/office/drawing/2014/main" id="{0FA5B03D-EAD5-4123-A5A9-F7F137F8DB5A}"/>
+                <a16:creationId xmlns:a16="http://schemas.microsoft.com/office/drawing/2014/main" id="{0B22A946-7C96-4ED8-9E4D-38C82276B950}"/>
               </a:ext>
             </a:extLst>
           </p:cNvPr>
@@ -5080,7 +5080,7 @@
           <p:cNvPr id="6" name="">
             <a:extLst xmlns:a="http://schemas.openxmlformats.org/drawingml/2006/main">
               <a:ext uri="{FF2B5EF4-FFF2-40B4-BE49-F238E27FC236}">
-                <a16:creationId xmlns:a16="http://schemas.microsoft.com/office/drawing/2014/main" id="{07DB673F-AAD9-488E-B7C4-7C579F1DCDD6}"/>
+                <a16:creationId xmlns:a16="http://schemas.microsoft.com/office/drawing/2014/main" id="{198A0C15-C0EC-4FFC-8B91-AE045DB5BE9C}"/>
               </a:ext>
             </a:extLst>
           </p:cNvPr>
@@ -5148,7 +5148,7 @@
           <p:cNvPr id="7" name="">
             <a:extLst xmlns:a="http://schemas.openxmlformats.org/drawingml/2006/main">
               <a:ext uri="{FF2B5EF4-FFF2-40B4-BE49-F238E27FC236}">
-                <a16:creationId xmlns:a16="http://schemas.microsoft.com/office/drawing/2014/main" id="{75ACF59C-E1BD-4B46-A2F4-BFDEA34E991C}"/>
+                <a16:creationId xmlns:a16="http://schemas.microsoft.com/office/drawing/2014/main" id="{AD45543A-618E-4CC6-B5CD-CC9CD16FAE4D}"/>
               </a:ext>
             </a:extLst>
           </p:cNvPr>
@@ -5214,7 +5214,7 @@
     </p:spTree>
     <p:extLst>
       <p:ext uri="{BB962C8B-B14F-4D97-AF65-F5344CB8AC3E}">
-        <p14:creationId xmlns:p14="http://schemas.microsoft.com/office/powerpoint/2010/main" val="533043133"/>
+        <p14:creationId xmlns:p14="http://schemas.microsoft.com/office/powerpoint/2010/main" val="1334117416"/>
       </p:ext>
     </p:extLst>
   </p:cSld>
@@ -5245,7 +5245,7 @@
           <p:cNvPr id="9" name="">
             <a:extLst xmlns:a="http://schemas.openxmlformats.org/drawingml/2006/main">
               <a:ext uri="{FF2B5EF4-FFF2-40B4-BE49-F238E27FC236}">
-                <a16:creationId xmlns:a16="http://schemas.microsoft.com/office/drawing/2014/main" id="{C9ABCA35-AF64-4070-99DE-297649924C2E}"/>
+                <a16:creationId xmlns:a16="http://schemas.microsoft.com/office/drawing/2014/main" id="{5F5E6DAA-5EDC-4266-991E-4EAF39966ED0}"/>
               </a:ext>
             </a:extLst>
           </p:cNvPr>
@@ -5313,7 +5313,7 @@
           <p:cNvPr id="2" name="">
             <a:extLst xmlns:a="http://schemas.openxmlformats.org/drawingml/2006/main">
               <a:ext uri="{FF2B5EF4-FFF2-40B4-BE49-F238E27FC236}">
-                <a16:creationId xmlns:a16="http://schemas.microsoft.com/office/drawing/2014/main" id="{DDA8A9B2-F113-415F-BAAC-492B5B105F26}"/>
+                <a16:creationId xmlns:a16="http://schemas.microsoft.com/office/drawing/2014/main" id="{D0216704-18A2-43FE-B9FB-33CF912B859E}"/>
               </a:ext>
             </a:extLst>
           </p:cNvPr>
@@ -5381,7 +5381,7 @@
           <p:cNvPr id="3" name="">
             <a:extLst xmlns:a="http://schemas.openxmlformats.org/drawingml/2006/main">
               <a:ext uri="{FF2B5EF4-FFF2-40B4-BE49-F238E27FC236}">
-                <a16:creationId xmlns:a16="http://schemas.microsoft.com/office/drawing/2014/main" id="{456E956E-38EB-4E32-82A4-02B833C5B627}"/>
+                <a16:creationId xmlns:a16="http://schemas.microsoft.com/office/drawing/2014/main" id="{479EF978-E4D5-4DBD-AE1E-A3D5358B3060}"/>
               </a:ext>
             </a:extLst>
           </p:cNvPr>
@@ -5449,7 +5449,7 @@
           <p:cNvPr id="4" name="">
             <a:extLst xmlns:a="http://schemas.openxmlformats.org/drawingml/2006/main">
               <a:ext uri="{FF2B5EF4-FFF2-40B4-BE49-F238E27FC236}">
-                <a16:creationId xmlns:a16="http://schemas.microsoft.com/office/drawing/2014/main" id="{5E07FD11-A0EB-4CF9-86D1-98734344C579}"/>
+                <a16:creationId xmlns:a16="http://schemas.microsoft.com/office/drawing/2014/main" id="{87B1981D-CE40-441D-B171-7E32E25F7714}"/>
               </a:ext>
             </a:extLst>
           </p:cNvPr>
@@ -5517,7 +5517,7 @@
           <p:cNvPr id="5" name="">
             <a:extLst xmlns:a="http://schemas.openxmlformats.org/drawingml/2006/main">
               <a:ext uri="{FF2B5EF4-FFF2-40B4-BE49-F238E27FC236}">
-                <a16:creationId xmlns:a16="http://schemas.microsoft.com/office/drawing/2014/main" id="{A2977B1D-0F8B-406D-8AEF-F9921B77628B}"/>
+                <a16:creationId xmlns:a16="http://schemas.microsoft.com/office/drawing/2014/main" id="{23577335-4A0B-4C6A-AC9A-3C38EC0CAA90}"/>
               </a:ext>
             </a:extLst>
           </p:cNvPr>
@@ -5585,7 +5585,7 @@
           <p:cNvPr id="6" name="">
             <a:extLst xmlns:a="http://schemas.openxmlformats.org/drawingml/2006/main">
               <a:ext uri="{FF2B5EF4-FFF2-40B4-BE49-F238E27FC236}">
-                <a16:creationId xmlns:a16="http://schemas.microsoft.com/office/drawing/2014/main" id="{63A5493E-AECB-4134-B06A-6D5BCAB7D47E}"/>
+                <a16:creationId xmlns:a16="http://schemas.microsoft.com/office/drawing/2014/main" id="{85A5AE0C-1CB8-4DEC-A3E2-F9AE6D956D59}"/>
               </a:ext>
             </a:extLst>
           </p:cNvPr>
@@ -5653,7 +5653,7 @@
           <p:cNvPr id="7" name="">
             <a:extLst xmlns:a="http://schemas.openxmlformats.org/drawingml/2006/main">
               <a:ext uri="{FF2B5EF4-FFF2-40B4-BE49-F238E27FC236}">
-                <a16:creationId xmlns:a16="http://schemas.microsoft.com/office/drawing/2014/main" id="{74C3BDCD-EDCE-4AC8-BAE1-965E5E1D3E86}"/>
+                <a16:creationId xmlns:a16="http://schemas.microsoft.com/office/drawing/2014/main" id="{3BF21D91-31BF-4481-96AA-C2F2E0E0BE8F}"/>
               </a:ext>
             </a:extLst>
           </p:cNvPr>
@@ -5721,7 +5721,7 @@
           <p:cNvPr id="8" name="">
             <a:extLst xmlns:a="http://schemas.openxmlformats.org/drawingml/2006/main">
               <a:ext uri="{FF2B5EF4-FFF2-40B4-BE49-F238E27FC236}">
-                <a16:creationId xmlns:a16="http://schemas.microsoft.com/office/drawing/2014/main" id="{DEECF162-A71D-4CC9-8442-5394E372295D}"/>
+                <a16:creationId xmlns:a16="http://schemas.microsoft.com/office/drawing/2014/main" id="{0237CDC7-E5E4-405C-A8F8-31D77929A932}"/>
               </a:ext>
             </a:extLst>
           </p:cNvPr>
@@ -5787,7 +5787,7 @@
     </p:spTree>
     <p:extLst>
       <p:ext uri="{BB962C8B-B14F-4D97-AF65-F5344CB8AC3E}">
-        <p14:creationId xmlns:p14="http://schemas.microsoft.com/office/powerpoint/2010/main" val="278882281"/>
+        <p14:creationId xmlns:p14="http://schemas.microsoft.com/office/powerpoint/2010/main" val="491008910"/>
       </p:ext>
     </p:extLst>
   </p:cSld>
@@ -5818,7 +5818,7 @@
           <p:cNvPr id="5" name="">
             <a:extLst xmlns:a="http://schemas.openxmlformats.org/drawingml/2006/main">
               <a:ext uri="{FF2B5EF4-FFF2-40B4-BE49-F238E27FC236}">
-                <a16:creationId xmlns:a16="http://schemas.microsoft.com/office/drawing/2014/main" id="{AB79319C-4540-4942-9D4C-C1828BDF331D}"/>
+                <a16:creationId xmlns:a16="http://schemas.microsoft.com/office/drawing/2014/main" id="{4A38334A-F0AE-404E-BC26-2C7F0AC67518}"/>
               </a:ext>
             </a:extLst>
           </p:cNvPr>
@@ -5886,7 +5886,7 @@
           <p:cNvPr id="2" name="">
             <a:extLst xmlns:a="http://schemas.openxmlformats.org/drawingml/2006/main">
               <a:ext uri="{FF2B5EF4-FFF2-40B4-BE49-F238E27FC236}">
-                <a16:creationId xmlns:a16="http://schemas.microsoft.com/office/drawing/2014/main" id="{A24C464E-5EA9-4631-99D1-05BF572CDBEE}"/>
+                <a16:creationId xmlns:a16="http://schemas.microsoft.com/office/drawing/2014/main" id="{E4A7C430-9E51-4CBA-AD3E-2DE9C8920C26}"/>
               </a:ext>
             </a:extLst>
           </p:cNvPr>
@@ -5954,7 +5954,7 @@
           <p:cNvPr id="3" name="">
             <a:extLst xmlns:a="http://schemas.openxmlformats.org/drawingml/2006/main">
               <a:ext uri="{FF2B5EF4-FFF2-40B4-BE49-F238E27FC236}">
-                <a16:creationId xmlns:a16="http://schemas.microsoft.com/office/drawing/2014/main" id="{5C0FFB3F-21EC-4F16-90F6-5306CB46B37B}"/>
+                <a16:creationId xmlns:a16="http://schemas.microsoft.com/office/drawing/2014/main" id="{AF7336B6-880B-4B1B-ACD7-FF9285F5C4B3}"/>
               </a:ext>
             </a:extLst>
           </p:cNvPr>
@@ -6934,7 +6934,7 @@
           <p:cNvPr id="4" name="">
             <a:extLst xmlns:a="http://schemas.openxmlformats.org/drawingml/2006/main">
               <a:ext uri="{FF2B5EF4-FFF2-40B4-BE49-F238E27FC236}">
-                <a16:creationId xmlns:a16="http://schemas.microsoft.com/office/drawing/2014/main" id="{5081FD98-9268-4270-8340-9EDF8D1060EF}"/>
+                <a16:creationId xmlns:a16="http://schemas.microsoft.com/office/drawing/2014/main" id="{8018EF87-7868-44C0-A54E-6F6D8AEAEB72}"/>
               </a:ext>
             </a:extLst>
           </p:cNvPr>
@@ -7000,7 +7000,7 @@
     </p:spTree>
     <p:extLst>
       <p:ext uri="{BB962C8B-B14F-4D97-AF65-F5344CB8AC3E}">
-        <p14:creationId xmlns:p14="http://schemas.microsoft.com/office/powerpoint/2010/main" val="904352364"/>
+        <p14:creationId xmlns:p14="http://schemas.microsoft.com/office/powerpoint/2010/main" val="1249695168"/>
       </p:ext>
     </p:extLst>
   </p:cSld>
@@ -7031,7 +7031,7 @@
           <p:cNvPr id="5" name="">
             <a:extLst xmlns:a="http://schemas.openxmlformats.org/drawingml/2006/main">
               <a:ext uri="{FF2B5EF4-FFF2-40B4-BE49-F238E27FC236}">
-                <a16:creationId xmlns:a16="http://schemas.microsoft.com/office/drawing/2014/main" id="{15C111A4-4457-4868-9714-29EAAA310AC4}"/>
+                <a16:creationId xmlns:a16="http://schemas.microsoft.com/office/drawing/2014/main" id="{DB3D33A9-2102-49FA-B9AA-C886EACC1406}"/>
               </a:ext>
             </a:extLst>
           </p:cNvPr>
@@ -7099,7 +7099,7 @@
           <p:cNvPr id="2" name="">
             <a:extLst xmlns:a="http://schemas.openxmlformats.org/drawingml/2006/main">
               <a:ext uri="{FF2B5EF4-FFF2-40B4-BE49-F238E27FC236}">
-                <a16:creationId xmlns:a16="http://schemas.microsoft.com/office/drawing/2014/main" id="{BF96F369-00E7-4D8B-A643-17016E9C1311}"/>
+                <a16:creationId xmlns:a16="http://schemas.microsoft.com/office/drawing/2014/main" id="{85C38B8F-39D2-4084-BC26-D5BD7D64470D}"/>
               </a:ext>
             </a:extLst>
           </p:cNvPr>
@@ -7167,7 +7167,7 @@
           <p:cNvPr id="3" name="Chart">
             <a:extLst xmlns:a="http://schemas.openxmlformats.org/drawingml/2006/main">
               <a:ext uri="{FF2B5EF4-FFF2-40B4-BE49-F238E27FC236}">
-                <a16:creationId xmlns:a16="http://schemas.microsoft.com/office/drawing/2014/main" id="{9E902B3E-48F5-4E53-AE7F-FF57B1B8C49C}"/>
+                <a16:creationId xmlns:a16="http://schemas.microsoft.com/office/drawing/2014/main" id="{618ACF34-0663-477B-99A0-67D00EB4F3F7}"/>
               </a:ext>
             </a:extLst>
           </p:cNvPr>
@@ -7180,7 +7180,7 @@
         </p:xfrm>
         <a:graphic xmlns:a="http://schemas.openxmlformats.org/drawingml/2006/main">
           <a:graphicData uri="http://schemas.openxmlformats.org/drawingml/2006/chart">
-            <c:chart xmlns:r="http://schemas.openxmlformats.org/officeDocument/2006/relationships" xmlns:c="http://schemas.openxmlformats.org/drawingml/2006/chart" r:id="R386281dde9054383"/>
+            <c:chart xmlns:r="http://schemas.openxmlformats.org/officeDocument/2006/relationships" xmlns:c="http://schemas.openxmlformats.org/drawingml/2006/chart" r:id="R0c5c18c63fa84ad6"/>
           </a:graphicData>
         </a:graphic>
       </p:graphicFrame>
@@ -7189,7 +7189,7 @@
           <p:cNvPr id="4" name="">
             <a:extLst xmlns:a="http://schemas.openxmlformats.org/drawingml/2006/main">
               <a:ext uri="{FF2B5EF4-FFF2-40B4-BE49-F238E27FC236}">
-                <a16:creationId xmlns:a16="http://schemas.microsoft.com/office/drawing/2014/main" id="{F1FD1D07-5228-4363-A42A-565EAE7C8324}"/>
+                <a16:creationId xmlns:a16="http://schemas.microsoft.com/office/drawing/2014/main" id="{CDE314A9-0D2D-42B1-9A01-958F8276E67E}"/>
               </a:ext>
             </a:extLst>
           </p:cNvPr>
@@ -7255,7 +7255,7 @@
     </p:spTree>
     <p:extLst>
       <p:ext uri="{BB962C8B-B14F-4D97-AF65-F5344CB8AC3E}">
-        <p14:creationId xmlns:p14="http://schemas.microsoft.com/office/powerpoint/2010/main" val="2085511345"/>
+        <p14:creationId xmlns:p14="http://schemas.microsoft.com/office/powerpoint/2010/main" val="1089507631"/>
       </p:ext>
     </p:extLst>
   </p:cSld>
@@ -7286,7 +7286,7 @@
           <p:cNvPr id="5" name="">
             <a:extLst xmlns:a="http://schemas.openxmlformats.org/drawingml/2006/main">
               <a:ext uri="{FF2B5EF4-FFF2-40B4-BE49-F238E27FC236}">
-                <a16:creationId xmlns:a16="http://schemas.microsoft.com/office/drawing/2014/main" id="{55A3C662-6FDA-4718-8FCE-6AFBE368317F}"/>
+                <a16:creationId xmlns:a16="http://schemas.microsoft.com/office/drawing/2014/main" id="{39BF2AF7-AEFC-435C-9A68-5C718CF922FA}"/>
               </a:ext>
             </a:extLst>
           </p:cNvPr>
@@ -7354,7 +7354,7 @@
           <p:cNvPr id="2" name="">
             <a:extLst xmlns:a="http://schemas.openxmlformats.org/drawingml/2006/main">
               <a:ext uri="{FF2B5EF4-FFF2-40B4-BE49-F238E27FC236}">
-                <a16:creationId xmlns:a16="http://schemas.microsoft.com/office/drawing/2014/main" id="{A7B54F30-34C9-4F2B-A7A0-792232CF002A}"/>
+                <a16:creationId xmlns:a16="http://schemas.microsoft.com/office/drawing/2014/main" id="{103A47F3-E7B3-4827-AAF7-BCD1C4780EB5}"/>
               </a:ext>
             </a:extLst>
           </p:cNvPr>
@@ -7422,7 +7422,7 @@
           <p:cNvPr id="3" name="Chart">
             <a:extLst xmlns:a="http://schemas.openxmlformats.org/drawingml/2006/main">
               <a:ext uri="{FF2B5EF4-FFF2-40B4-BE49-F238E27FC236}">
-                <a16:creationId xmlns:a16="http://schemas.microsoft.com/office/drawing/2014/main" id="{45EEA2BC-C6CD-4D52-9538-84428C2B213A}"/>
+                <a16:creationId xmlns:a16="http://schemas.microsoft.com/office/drawing/2014/main" id="{50C1BD33-BCD0-4AE4-86F2-3144475044AE}"/>
               </a:ext>
             </a:extLst>
           </p:cNvPr>
@@ -7435,7 +7435,7 @@
         </p:xfrm>
         <a:graphic xmlns:a="http://schemas.openxmlformats.org/drawingml/2006/main">
           <a:graphicData uri="http://schemas.openxmlformats.org/drawingml/2006/chart">
-            <c:chart xmlns:r="http://schemas.openxmlformats.org/officeDocument/2006/relationships" xmlns:c="http://schemas.openxmlformats.org/drawingml/2006/chart" r:id="R2c1e484c7dbb4074"/>
+            <c:chart xmlns:r="http://schemas.openxmlformats.org/officeDocument/2006/relationships" xmlns:c="http://schemas.openxmlformats.org/drawingml/2006/chart" r:id="R05c01f588f5646e4"/>
           </a:graphicData>
         </a:graphic>
       </p:graphicFrame>
@@ -7444,7 +7444,7 @@
           <p:cNvPr id="4" name="">
             <a:extLst xmlns:a="http://schemas.openxmlformats.org/drawingml/2006/main">
               <a:ext uri="{FF2B5EF4-FFF2-40B4-BE49-F238E27FC236}">
-                <a16:creationId xmlns:a16="http://schemas.microsoft.com/office/drawing/2014/main" id="{9FAA9A31-7657-41A4-940C-1AFF265B02AC}"/>
+                <a16:creationId xmlns:a16="http://schemas.microsoft.com/office/drawing/2014/main" id="{0C92BCCB-96C5-4264-BD1A-F6A9793AF4B1}"/>
               </a:ext>
             </a:extLst>
           </p:cNvPr>
@@ -7510,7 +7510,7 @@
     </p:spTree>
     <p:extLst>
       <p:ext uri="{BB962C8B-B14F-4D97-AF65-F5344CB8AC3E}">
-        <p14:creationId xmlns:p14="http://schemas.microsoft.com/office/powerpoint/2010/main" val="1115149335"/>
+        <p14:creationId xmlns:p14="http://schemas.microsoft.com/office/powerpoint/2010/main" val="376225849"/>
       </p:ext>
     </p:extLst>
   </p:cSld>
@@ -7541,7 +7541,7 @@
           <p:cNvPr id="8" name="">
             <a:extLst xmlns:a="http://schemas.openxmlformats.org/drawingml/2006/main">
               <a:ext uri="{FF2B5EF4-FFF2-40B4-BE49-F238E27FC236}">
-                <a16:creationId xmlns:a16="http://schemas.microsoft.com/office/drawing/2014/main" id="{7B44E571-003A-421D-96D4-21C9DDFE2735}"/>
+                <a16:creationId xmlns:a16="http://schemas.microsoft.com/office/drawing/2014/main" id="{6BA17E3D-F35F-427A-AF7B-24228F2F4CDC}"/>
               </a:ext>
             </a:extLst>
           </p:cNvPr>
@@ -7609,7 +7609,7 @@
           <p:cNvPr id="2" name="">
             <a:extLst xmlns:a="http://schemas.openxmlformats.org/drawingml/2006/main">
               <a:ext uri="{FF2B5EF4-FFF2-40B4-BE49-F238E27FC236}">
-                <a16:creationId xmlns:a16="http://schemas.microsoft.com/office/drawing/2014/main" id="{7D7D2454-0CED-473D-AEF4-8CB04F49F878}"/>
+                <a16:creationId xmlns:a16="http://schemas.microsoft.com/office/drawing/2014/main" id="{08037345-4F2A-4B5D-80B3-77BF6199708C}"/>
               </a:ext>
             </a:extLst>
           </p:cNvPr>
@@ -7677,7 +7677,7 @@
           <p:cNvPr id="3" name="">
             <a:extLst xmlns:a="http://schemas.openxmlformats.org/drawingml/2006/main">
               <a:ext uri="{FF2B5EF4-FFF2-40B4-BE49-F238E27FC236}">
-                <a16:creationId xmlns:a16="http://schemas.microsoft.com/office/drawing/2014/main" id="{122E954F-7E60-4E06-9C85-019CE73B908D}"/>
+                <a16:creationId xmlns:a16="http://schemas.microsoft.com/office/drawing/2014/main" id="{4899DBB7-15A3-4E3F-AD5F-9AAFB23327D4}"/>
               </a:ext>
             </a:extLst>
           </p:cNvPr>
@@ -7745,7 +7745,7 @@
           <p:cNvPr id="4" name="">
             <a:extLst xmlns:a="http://schemas.openxmlformats.org/drawingml/2006/main">
               <a:ext uri="{FF2B5EF4-FFF2-40B4-BE49-F238E27FC236}">
-                <a16:creationId xmlns:a16="http://schemas.microsoft.com/office/drawing/2014/main" id="{A4D85A45-DCFA-49D8-9543-37E3286C0AF2}"/>
+                <a16:creationId xmlns:a16="http://schemas.microsoft.com/office/drawing/2014/main" id="{C8715629-EB3B-40EB-92E8-9F9E05556AE2}"/>
               </a:ext>
             </a:extLst>
           </p:cNvPr>
@@ -7813,7 +7813,7 @@
           <p:cNvPr id="5" name="">
             <a:extLst xmlns:a="http://schemas.openxmlformats.org/drawingml/2006/main">
               <a:ext uri="{FF2B5EF4-FFF2-40B4-BE49-F238E27FC236}">
-                <a16:creationId xmlns:a16="http://schemas.microsoft.com/office/drawing/2014/main" id="{4450A49E-B849-4165-B899-7AE8689595D4}"/>
+                <a16:creationId xmlns:a16="http://schemas.microsoft.com/office/drawing/2014/main" id="{DA7FE3D5-5F51-43F8-BBC6-740A71C9BCAA}"/>
               </a:ext>
             </a:extLst>
           </p:cNvPr>
@@ -8447,7 +8447,7 @@
           <p:cNvPr id="6" name="">
             <a:extLst xmlns:a="http://schemas.openxmlformats.org/drawingml/2006/main">
               <a:ext uri="{FF2B5EF4-FFF2-40B4-BE49-F238E27FC236}">
-                <a16:creationId xmlns:a16="http://schemas.microsoft.com/office/drawing/2014/main" id="{DBA37316-886C-49F7-BBC2-5CA02B65B4E4}"/>
+                <a16:creationId xmlns:a16="http://schemas.microsoft.com/office/drawing/2014/main" id="{0F83007E-5982-4B82-A4A7-21C0B497D78C}"/>
               </a:ext>
             </a:extLst>
           </p:cNvPr>
@@ -9081,7 +9081,7 @@
           <p:cNvPr id="7" name="">
             <a:extLst xmlns:a="http://schemas.openxmlformats.org/drawingml/2006/main">
               <a:ext uri="{FF2B5EF4-FFF2-40B4-BE49-F238E27FC236}">
-                <a16:creationId xmlns:a16="http://schemas.microsoft.com/office/drawing/2014/main" id="{A3BD5A92-3646-4D38-B61B-AC372FC5E718}"/>
+                <a16:creationId xmlns:a16="http://schemas.microsoft.com/office/drawing/2014/main" id="{C5945FE8-EEF3-4DE5-9DB4-4B5A4096899B}"/>
               </a:ext>
             </a:extLst>
           </p:cNvPr>
@@ -9147,7 +9147,7 @@
     </p:spTree>
     <p:extLst>
       <p:ext uri="{BB962C8B-B14F-4D97-AF65-F5344CB8AC3E}">
-        <p14:creationId xmlns:p14="http://schemas.microsoft.com/office/powerpoint/2010/main" val="1519951560"/>
+        <p14:creationId xmlns:p14="http://schemas.microsoft.com/office/powerpoint/2010/main" val="1923450951"/>
       </p:ext>
     </p:extLst>
   </p:cSld>
@@ -9178,7 +9178,7 @@
           <p:cNvPr id="5" name="">
             <a:extLst xmlns:a="http://schemas.openxmlformats.org/drawingml/2006/main">
               <a:ext uri="{FF2B5EF4-FFF2-40B4-BE49-F238E27FC236}">
-                <a16:creationId xmlns:a16="http://schemas.microsoft.com/office/drawing/2014/main" id="{85AA4FD2-36CA-4E93-9629-66C7EB44A88A}"/>
+                <a16:creationId xmlns:a16="http://schemas.microsoft.com/office/drawing/2014/main" id="{787CE333-E6D8-4156-8378-8E3B527440F5}"/>
               </a:ext>
             </a:extLst>
           </p:cNvPr>
@@ -9246,7 +9246,7 @@
           <p:cNvPr id="2" name="">
             <a:extLst xmlns:a="http://schemas.openxmlformats.org/drawingml/2006/main">
               <a:ext uri="{FF2B5EF4-FFF2-40B4-BE49-F238E27FC236}">
-                <a16:creationId xmlns:a16="http://schemas.microsoft.com/office/drawing/2014/main" id="{65870EA5-001C-40B7-AD88-0A325D4A4DE3}"/>
+                <a16:creationId xmlns:a16="http://schemas.microsoft.com/office/drawing/2014/main" id="{92F4CDEF-1616-4C42-9EB4-927AAAFBF71B}"/>
               </a:ext>
             </a:extLst>
           </p:cNvPr>
@@ -9314,7 +9314,7 @@
           <p:cNvPr id="3" name="">
             <a:extLst xmlns:a="http://schemas.openxmlformats.org/drawingml/2006/main">
               <a:ext uri="{FF2B5EF4-FFF2-40B4-BE49-F238E27FC236}">
-                <a16:creationId xmlns:a16="http://schemas.microsoft.com/office/drawing/2014/main" id="{7DB80955-5DD3-4EE2-8FFD-E0E715B21E78}"/>
+                <a16:creationId xmlns:a16="http://schemas.microsoft.com/office/drawing/2014/main" id="{D2454159-1AA1-4431-94D9-4F616B753D20}"/>
               </a:ext>
             </a:extLst>
           </p:cNvPr>
@@ -10139,7 +10139,7 @@
           <p:cNvPr id="4" name="">
             <a:extLst xmlns:a="http://schemas.openxmlformats.org/drawingml/2006/main">
               <a:ext uri="{FF2B5EF4-FFF2-40B4-BE49-F238E27FC236}">
-                <a16:creationId xmlns:a16="http://schemas.microsoft.com/office/drawing/2014/main" id="{D31B2DBF-F181-4B67-AC5F-31864C3ACA44}"/>
+                <a16:creationId xmlns:a16="http://schemas.microsoft.com/office/drawing/2014/main" id="{7E0C324A-2D4E-443E-B330-E900FE4AD73C}"/>
               </a:ext>
             </a:extLst>
           </p:cNvPr>
@@ -10205,7 +10205,7 @@
     </p:spTree>
     <p:extLst>
       <p:ext uri="{BB962C8B-B14F-4D97-AF65-F5344CB8AC3E}">
-        <p14:creationId xmlns:p14="http://schemas.microsoft.com/office/powerpoint/2010/main" val="1697517050"/>
+        <p14:creationId xmlns:p14="http://schemas.microsoft.com/office/powerpoint/2010/main" val="437025533"/>
       </p:ext>
     </p:extLst>
   </p:cSld>
@@ -10236,7 +10236,7 @@
           <p:cNvPr id="9" name="">
             <a:extLst xmlns:a="http://schemas.openxmlformats.org/drawingml/2006/main">
               <a:ext uri="{FF2B5EF4-FFF2-40B4-BE49-F238E27FC236}">
-                <a16:creationId xmlns:a16="http://schemas.microsoft.com/office/drawing/2014/main" id="{61307981-1B70-499E-B842-E09323CEDB9B}"/>
+                <a16:creationId xmlns:a16="http://schemas.microsoft.com/office/drawing/2014/main" id="{D259EAE7-4DFC-4107-B323-5A3E76BD65FE}"/>
               </a:ext>
             </a:extLst>
           </p:cNvPr>
@@ -10304,7 +10304,7 @@
           <p:cNvPr id="2" name="">
             <a:extLst xmlns:a="http://schemas.openxmlformats.org/drawingml/2006/main">
               <a:ext uri="{FF2B5EF4-FFF2-40B4-BE49-F238E27FC236}">
-                <a16:creationId xmlns:a16="http://schemas.microsoft.com/office/drawing/2014/main" id="{267CA827-18E3-4814-99D3-03726E1B8C15}"/>
+                <a16:creationId xmlns:a16="http://schemas.microsoft.com/office/drawing/2014/main" id="{84221184-5DED-44BB-AD4B-EA16A317C770}"/>
               </a:ext>
             </a:extLst>
           </p:cNvPr>
@@ -10372,7 +10372,7 @@
           <p:cNvPr id="3" name="">
             <a:extLst xmlns:a="http://schemas.openxmlformats.org/drawingml/2006/main">
               <a:ext uri="{FF2B5EF4-FFF2-40B4-BE49-F238E27FC236}">
-                <a16:creationId xmlns:a16="http://schemas.microsoft.com/office/drawing/2014/main" id="{9CCF612E-A72D-4081-AB4F-38725C9F57F7}"/>
+                <a16:creationId xmlns:a16="http://schemas.microsoft.com/office/drawing/2014/main" id="{5D5EE6C4-A005-409B-AB1F-A068793D6C51}"/>
               </a:ext>
             </a:extLst>
           </p:cNvPr>
@@ -10440,7 +10440,7 @@
           <p:cNvPr id="4" name="">
             <a:extLst xmlns:a="http://schemas.openxmlformats.org/drawingml/2006/main">
               <a:ext uri="{FF2B5EF4-FFF2-40B4-BE49-F238E27FC236}">
-                <a16:creationId xmlns:a16="http://schemas.microsoft.com/office/drawing/2014/main" id="{C543EE8A-3D72-438A-B177-8B945E26724D}"/>
+                <a16:creationId xmlns:a16="http://schemas.microsoft.com/office/drawing/2014/main" id="{36634BF5-E92C-4CB6-8D74-B6356E19B979}"/>
               </a:ext>
             </a:extLst>
           </p:cNvPr>
@@ -10508,7 +10508,7 @@
           <p:cNvPr id="5" name="">
             <a:extLst xmlns:a="http://schemas.openxmlformats.org/drawingml/2006/main">
               <a:ext uri="{FF2B5EF4-FFF2-40B4-BE49-F238E27FC236}">
-                <a16:creationId xmlns:a16="http://schemas.microsoft.com/office/drawing/2014/main" id="{A6243356-3ACA-40DB-8275-047DF75F0412}"/>
+                <a16:creationId xmlns:a16="http://schemas.microsoft.com/office/drawing/2014/main" id="{914F0BD3-8A31-4A35-B5DE-6D2076F9B9CA}"/>
               </a:ext>
             </a:extLst>
           </p:cNvPr>
@@ -10576,7 +10576,7 @@
           <p:cNvPr id="6" name="">
             <a:extLst xmlns:a="http://schemas.openxmlformats.org/drawingml/2006/main">
               <a:ext uri="{FF2B5EF4-FFF2-40B4-BE49-F238E27FC236}">
-                <a16:creationId xmlns:a16="http://schemas.microsoft.com/office/drawing/2014/main" id="{1E0BF1A3-22C2-47F9-AEA3-3DB85E1B27AC}"/>
+                <a16:creationId xmlns:a16="http://schemas.microsoft.com/office/drawing/2014/main" id="{399F9F8D-B237-4577-8118-6ED8BAEA3A55}"/>
               </a:ext>
             </a:extLst>
           </p:cNvPr>
@@ -10644,7 +10644,7 @@
           <p:cNvPr id="7" name="">
             <a:extLst xmlns:a="http://schemas.openxmlformats.org/drawingml/2006/main">
               <a:ext uri="{FF2B5EF4-FFF2-40B4-BE49-F238E27FC236}">
-                <a16:creationId xmlns:a16="http://schemas.microsoft.com/office/drawing/2014/main" id="{BA5CFA7F-2CD4-41B6-9A5B-D8FF15D5354D}"/>
+                <a16:creationId xmlns:a16="http://schemas.microsoft.com/office/drawing/2014/main" id="{9EB52054-A8B9-4E1F-B862-8BD7B50BBA7B}"/>
               </a:ext>
             </a:extLst>
           </p:cNvPr>
@@ -10712,7 +10712,7 @@
           <p:cNvPr id="8" name="">
             <a:extLst xmlns:a="http://schemas.openxmlformats.org/drawingml/2006/main">
               <a:ext uri="{FF2B5EF4-FFF2-40B4-BE49-F238E27FC236}">
-                <a16:creationId xmlns:a16="http://schemas.microsoft.com/office/drawing/2014/main" id="{FBC11F15-2694-4085-A941-75FF037D11A3}"/>
+                <a16:creationId xmlns:a16="http://schemas.microsoft.com/office/drawing/2014/main" id="{EB5BCFCC-4EA1-4FF6-AFE6-C9B4D668DED7}"/>
               </a:ext>
             </a:extLst>
           </p:cNvPr>
@@ -10778,7 +10778,7 @@
     </p:spTree>
     <p:extLst>
       <p:ext uri="{BB962C8B-B14F-4D97-AF65-F5344CB8AC3E}">
-        <p14:creationId xmlns:p14="http://schemas.microsoft.com/office/powerpoint/2010/main" val="502724675"/>
+        <p14:creationId xmlns:p14="http://schemas.microsoft.com/office/powerpoint/2010/main" val="713564024"/>
       </p:ext>
     </p:extLst>
   </p:cSld>
@@ -10809,7 +10809,7 @@
           <p:cNvPr id="5" name="">
             <a:extLst xmlns:a="http://schemas.openxmlformats.org/drawingml/2006/main">
               <a:ext uri="{FF2B5EF4-FFF2-40B4-BE49-F238E27FC236}">
-                <a16:creationId xmlns:a16="http://schemas.microsoft.com/office/drawing/2014/main" id="{4DABC650-6323-4700-84D5-A83718E40BAF}"/>
+                <a16:creationId xmlns:a16="http://schemas.microsoft.com/office/drawing/2014/main" id="{DA4BEB9F-32CB-4223-ABF8-8877A1719E7A}"/>
               </a:ext>
             </a:extLst>
           </p:cNvPr>
@@ -10877,7 +10877,7 @@
           <p:cNvPr id="2" name="">
             <a:extLst xmlns:a="http://schemas.openxmlformats.org/drawingml/2006/main">
               <a:ext uri="{FF2B5EF4-FFF2-40B4-BE49-F238E27FC236}">
-                <a16:creationId xmlns:a16="http://schemas.microsoft.com/office/drawing/2014/main" id="{91BF0EAC-8290-4EDF-9F9E-5063FD6C6CFA}"/>
+                <a16:creationId xmlns:a16="http://schemas.microsoft.com/office/drawing/2014/main" id="{238AF262-F271-4B48-9E20-DD194AC2BB1F}"/>
               </a:ext>
             </a:extLst>
           </p:cNvPr>
@@ -10945,7 +10945,7 @@
           <p:cNvPr id="3" name="">
             <a:extLst xmlns:a="http://schemas.openxmlformats.org/drawingml/2006/main">
               <a:ext uri="{FF2B5EF4-FFF2-40B4-BE49-F238E27FC236}">
-                <a16:creationId xmlns:a16="http://schemas.microsoft.com/office/drawing/2014/main" id="{46EA80F5-76AF-4428-B98D-EF44F1217824}"/>
+                <a16:creationId xmlns:a16="http://schemas.microsoft.com/office/drawing/2014/main" id="{454A7BEA-6A85-4D87-9470-B7BB387F9FF5}"/>
               </a:ext>
             </a:extLst>
           </p:cNvPr>
@@ -11469,7 +11469,7 @@
           <p:cNvPr id="4" name="">
             <a:extLst xmlns:a="http://schemas.openxmlformats.org/drawingml/2006/main">
               <a:ext uri="{FF2B5EF4-FFF2-40B4-BE49-F238E27FC236}">
-                <a16:creationId xmlns:a16="http://schemas.microsoft.com/office/drawing/2014/main" id="{FA3DABE5-2036-4612-AA4A-14682C11F6F4}"/>
+                <a16:creationId xmlns:a16="http://schemas.microsoft.com/office/drawing/2014/main" id="{7A961634-1CCE-491F-8678-9E2FD6A79CC1}"/>
               </a:ext>
             </a:extLst>
           </p:cNvPr>
@@ -11535,7 +11535,7 @@
     </p:spTree>
     <p:extLst>
       <p:ext uri="{BB962C8B-B14F-4D97-AF65-F5344CB8AC3E}">
-        <p14:creationId xmlns:p14="http://schemas.microsoft.com/office/powerpoint/2010/main" val="1004002317"/>
+        <p14:creationId xmlns:p14="http://schemas.microsoft.com/office/powerpoint/2010/main" val="731982300"/>
       </p:ext>
     </p:extLst>
   </p:cSld>
@@ -11566,7 +11566,7 @@
           <p:cNvPr id="6" name="">
             <a:extLst xmlns:a="http://schemas.openxmlformats.org/drawingml/2006/main">
               <a:ext uri="{FF2B5EF4-FFF2-40B4-BE49-F238E27FC236}">
-                <a16:creationId xmlns:a16="http://schemas.microsoft.com/office/drawing/2014/main" id="{E4C86F7C-5E67-4D8D-9F12-D88B38B6812F}"/>
+                <a16:creationId xmlns:a16="http://schemas.microsoft.com/office/drawing/2014/main" id="{47F4D64F-9222-4680-837D-2BF7F9BFE200}"/>
               </a:ext>
             </a:extLst>
           </p:cNvPr>
@@ -11634,7 +11634,7 @@
           <p:cNvPr id="2" name="">
             <a:extLst xmlns:a="http://schemas.openxmlformats.org/drawingml/2006/main">
               <a:ext uri="{FF2B5EF4-FFF2-40B4-BE49-F238E27FC236}">
-                <a16:creationId xmlns:a16="http://schemas.microsoft.com/office/drawing/2014/main" id="{26F32E0A-2339-41E1-8930-604538B677AF}"/>
+                <a16:creationId xmlns:a16="http://schemas.microsoft.com/office/drawing/2014/main" id="{6BDEA444-F364-410A-9C12-85E523B2C6AE}"/>
               </a:ext>
             </a:extLst>
           </p:cNvPr>
@@ -11702,7 +11702,7 @@
           <p:cNvPr id="3" name="">
             <a:extLst xmlns:a="http://schemas.openxmlformats.org/drawingml/2006/main">
               <a:ext uri="{FF2B5EF4-FFF2-40B4-BE49-F238E27FC236}">
-                <a16:creationId xmlns:a16="http://schemas.microsoft.com/office/drawing/2014/main" id="{335D477C-D9FE-482C-9AAF-317A6EAA003A}"/>
+                <a16:creationId xmlns:a16="http://schemas.microsoft.com/office/drawing/2014/main" id="{1A595264-D219-4263-ADED-B81594D13F25}"/>
               </a:ext>
             </a:extLst>
           </p:cNvPr>
@@ -11770,7 +11770,7 @@
           <p:cNvPr id="4" name="">
             <a:extLst xmlns:a="http://schemas.openxmlformats.org/drawingml/2006/main">
               <a:ext uri="{FF2B5EF4-FFF2-40B4-BE49-F238E27FC236}">
-                <a16:creationId xmlns:a16="http://schemas.microsoft.com/office/drawing/2014/main" id="{3B5146C3-E22F-409F-AC73-1E3644DC80F1}"/>
+                <a16:creationId xmlns:a16="http://schemas.microsoft.com/office/drawing/2014/main" id="{2FD0A731-509A-481E-9226-414BB1ED3ECF}"/>
               </a:ext>
             </a:extLst>
           </p:cNvPr>
@@ -11838,7 +11838,7 @@
           <p:cNvPr id="5" name="">
             <a:extLst xmlns:a="http://schemas.openxmlformats.org/drawingml/2006/main">
               <a:ext uri="{FF2B5EF4-FFF2-40B4-BE49-F238E27FC236}">
-                <a16:creationId xmlns:a16="http://schemas.microsoft.com/office/drawing/2014/main" id="{5DEDD044-C62E-4FFA-A62C-38C19C3AA4A6}"/>
+                <a16:creationId xmlns:a16="http://schemas.microsoft.com/office/drawing/2014/main" id="{3BD8416B-4F5D-450E-A628-2A6CE35BC3D5}"/>
               </a:ext>
             </a:extLst>
           </p:cNvPr>
@@ -11904,7 +11904,7 @@
     </p:spTree>
     <p:extLst>
       <p:ext uri="{BB962C8B-B14F-4D97-AF65-F5344CB8AC3E}">
-        <p14:creationId xmlns:p14="http://schemas.microsoft.com/office/powerpoint/2010/main" val="1646095239"/>
+        <p14:creationId xmlns:p14="http://schemas.microsoft.com/office/powerpoint/2010/main" val="1178786958"/>
       </p:ext>
     </p:extLst>
   </p:cSld>
@@ -11935,7 +11935,7 @@
           <p:cNvPr id="8" name="">
             <a:extLst xmlns:a="http://schemas.openxmlformats.org/drawingml/2006/main">
               <a:ext uri="{FF2B5EF4-FFF2-40B4-BE49-F238E27FC236}">
-                <a16:creationId xmlns:a16="http://schemas.microsoft.com/office/drawing/2014/main" id="{4A311DDD-EF0F-4A68-9AA7-F6367E87498E}"/>
+                <a16:creationId xmlns:a16="http://schemas.microsoft.com/office/drawing/2014/main" id="{667A9283-ECD7-43C6-8401-1CF5CBE97700}"/>
               </a:ext>
             </a:extLst>
           </p:cNvPr>
@@ -12003,7 +12003,7 @@
           <p:cNvPr id="2" name="">
             <a:extLst xmlns:a="http://schemas.openxmlformats.org/drawingml/2006/main">
               <a:ext uri="{FF2B5EF4-FFF2-40B4-BE49-F238E27FC236}">
-                <a16:creationId xmlns:a16="http://schemas.microsoft.com/office/drawing/2014/main" id="{EDCB7655-6D66-482A-A8FF-CB454A86B784}"/>
+                <a16:creationId xmlns:a16="http://schemas.microsoft.com/office/drawing/2014/main" id="{A69494C3-8ECA-4631-8B2E-AFB119B02ED1}"/>
               </a:ext>
             </a:extLst>
           </p:cNvPr>
@@ -12071,7 +12071,7 @@
           <p:cNvPr id="3" name="">
             <a:extLst xmlns:a="http://schemas.openxmlformats.org/drawingml/2006/main">
               <a:ext uri="{FF2B5EF4-FFF2-40B4-BE49-F238E27FC236}">
-                <a16:creationId xmlns:a16="http://schemas.microsoft.com/office/drawing/2014/main" id="{76EC6AC6-8690-43C0-A4B7-065B43499708}"/>
+                <a16:creationId xmlns:a16="http://schemas.microsoft.com/office/drawing/2014/main" id="{9360121B-288F-49F6-97E4-B5053AE987AB}"/>
               </a:ext>
             </a:extLst>
           </p:cNvPr>
@@ -12139,7 +12139,7 @@
           <p:cNvPr id="4" name="">
             <a:extLst xmlns:a="http://schemas.openxmlformats.org/drawingml/2006/main">
               <a:ext uri="{FF2B5EF4-FFF2-40B4-BE49-F238E27FC236}">
-                <a16:creationId xmlns:a16="http://schemas.microsoft.com/office/drawing/2014/main" id="{0ADFD5ED-0554-4CB0-B08F-9A309509CA36}"/>
+                <a16:creationId xmlns:a16="http://schemas.microsoft.com/office/drawing/2014/main" id="{ED27BB22-EBBE-40AF-A50D-D84A67CFDEB9}"/>
               </a:ext>
             </a:extLst>
           </p:cNvPr>
@@ -12207,7 +12207,7 @@
           <p:cNvPr id="5" name="">
             <a:extLst xmlns:a="http://schemas.openxmlformats.org/drawingml/2006/main">
               <a:ext uri="{FF2B5EF4-FFF2-40B4-BE49-F238E27FC236}">
-                <a16:creationId xmlns:a16="http://schemas.microsoft.com/office/drawing/2014/main" id="{E3D0E06B-2B3D-49E1-94FD-08256D125195}"/>
+                <a16:creationId xmlns:a16="http://schemas.microsoft.com/office/drawing/2014/main" id="{04EFBE32-56F4-4FC2-AA62-0B30F175F425}"/>
               </a:ext>
             </a:extLst>
           </p:cNvPr>
@@ -12275,7 +12275,7 @@
           <p:cNvPr id="6" name="">
             <a:extLst xmlns:a="http://schemas.openxmlformats.org/drawingml/2006/main">
               <a:ext uri="{FF2B5EF4-FFF2-40B4-BE49-F238E27FC236}">
-                <a16:creationId xmlns:a16="http://schemas.microsoft.com/office/drawing/2014/main" id="{ACDD41F0-EA6A-4674-99E0-D69B5BA0FB4E}"/>
+                <a16:creationId xmlns:a16="http://schemas.microsoft.com/office/drawing/2014/main" id="{3301F4EE-D24A-4FBF-B4CB-6AE3BA3B1C54}"/>
               </a:ext>
             </a:extLst>
           </p:cNvPr>
@@ -12343,7 +12343,7 @@
           <p:cNvPr id="7" name="">
             <a:extLst xmlns:a="http://schemas.openxmlformats.org/drawingml/2006/main">
               <a:ext uri="{FF2B5EF4-FFF2-40B4-BE49-F238E27FC236}">
-                <a16:creationId xmlns:a16="http://schemas.microsoft.com/office/drawing/2014/main" id="{CED9F458-1978-447F-88CB-3AF5E6E4599C}"/>
+                <a16:creationId xmlns:a16="http://schemas.microsoft.com/office/drawing/2014/main" id="{D57F6FB3-3997-468E-85DD-28CF5A2EFD9C}"/>
               </a:ext>
             </a:extLst>
           </p:cNvPr>
@@ -12409,7 +12409,7 @@
     </p:spTree>
     <p:extLst>
       <p:ext uri="{BB962C8B-B14F-4D97-AF65-F5344CB8AC3E}">
-        <p14:creationId xmlns:p14="http://schemas.microsoft.com/office/powerpoint/2010/main" val="1296823592"/>
+        <p14:creationId xmlns:p14="http://schemas.microsoft.com/office/powerpoint/2010/main" val="410794731"/>
       </p:ext>
     </p:extLst>
   </p:cSld>
@@ -12440,7 +12440,7 @@
           <p:cNvPr id="9" name="">
             <a:extLst xmlns:a="http://schemas.openxmlformats.org/drawingml/2006/main">
               <a:ext uri="{FF2B5EF4-FFF2-40B4-BE49-F238E27FC236}">
-                <a16:creationId xmlns:a16="http://schemas.microsoft.com/office/drawing/2014/main" id="{D6650B8A-0099-42B1-AAF2-5ADD334276FC}"/>
+                <a16:creationId xmlns:a16="http://schemas.microsoft.com/office/drawing/2014/main" id="{8E9A687F-A815-41FC-94A5-E8BEFE0366FC}"/>
               </a:ext>
             </a:extLst>
           </p:cNvPr>
@@ -12508,7 +12508,7 @@
           <p:cNvPr id="2" name="">
             <a:extLst xmlns:a="http://schemas.openxmlformats.org/drawingml/2006/main">
               <a:ext uri="{FF2B5EF4-FFF2-40B4-BE49-F238E27FC236}">
-                <a16:creationId xmlns:a16="http://schemas.microsoft.com/office/drawing/2014/main" id="{5CB9DD18-A09F-4477-827D-AAFFE7558624}"/>
+                <a16:creationId xmlns:a16="http://schemas.microsoft.com/office/drawing/2014/main" id="{6E4D3DF0-ABD9-41E4-AB96-BD79C524B78F}"/>
               </a:ext>
             </a:extLst>
           </p:cNvPr>
@@ -12576,7 +12576,7 @@
           <p:cNvPr id="3" name="">
             <a:extLst xmlns:a="http://schemas.openxmlformats.org/drawingml/2006/main">
               <a:ext uri="{FF2B5EF4-FFF2-40B4-BE49-F238E27FC236}">
-                <a16:creationId xmlns:a16="http://schemas.microsoft.com/office/drawing/2014/main" id="{8CC871A7-6945-4B21-B06F-4DAF5526A0FF}"/>
+                <a16:creationId xmlns:a16="http://schemas.microsoft.com/office/drawing/2014/main" id="{8DB8618A-275F-4741-8FD0-535F9ADCD573}"/>
               </a:ext>
             </a:extLst>
           </p:cNvPr>
@@ -12667,7 +12667,7 @@
           <p:cNvPr id="4" name="">
             <a:extLst xmlns:a="http://schemas.openxmlformats.org/drawingml/2006/main">
               <a:ext uri="{FF2B5EF4-FFF2-40B4-BE49-F238E27FC236}">
-                <a16:creationId xmlns:a16="http://schemas.microsoft.com/office/drawing/2014/main" id="{895E2EE0-79E4-4372-96EF-792E202367E3}"/>
+                <a16:creationId xmlns:a16="http://schemas.microsoft.com/office/drawing/2014/main" id="{29104297-B9F7-4EEC-92F6-A825E5DA43AA}"/>
               </a:ext>
             </a:extLst>
           </p:cNvPr>
@@ -12735,7 +12735,7 @@
           <p:cNvPr id="5" name="">
             <a:extLst xmlns:a="http://schemas.openxmlformats.org/drawingml/2006/main">
               <a:ext uri="{FF2B5EF4-FFF2-40B4-BE49-F238E27FC236}">
-                <a16:creationId xmlns:a16="http://schemas.microsoft.com/office/drawing/2014/main" id="{24D75106-7AF0-4173-BD35-EFD2AEE7D701}"/>
+                <a16:creationId xmlns:a16="http://schemas.microsoft.com/office/drawing/2014/main" id="{78CFA6EB-5D5F-4538-8369-C31184DFD629}"/>
               </a:ext>
             </a:extLst>
           </p:cNvPr>
@@ -12803,7 +12803,7 @@
           <p:cNvPr id="6" name="">
             <a:extLst xmlns:a="http://schemas.openxmlformats.org/drawingml/2006/main">
               <a:ext uri="{FF2B5EF4-FFF2-40B4-BE49-F238E27FC236}">
-                <a16:creationId xmlns:a16="http://schemas.microsoft.com/office/drawing/2014/main" id="{5142904F-B728-41B1-A497-60E105B5DDDF}"/>
+                <a16:creationId xmlns:a16="http://schemas.microsoft.com/office/drawing/2014/main" id="{79A8EB2B-FE10-4598-A169-0C18E46D6BDA}"/>
               </a:ext>
             </a:extLst>
           </p:cNvPr>
@@ -12871,7 +12871,7 @@
           <p:cNvPr id="7" name="">
             <a:extLst xmlns:a="http://schemas.openxmlformats.org/drawingml/2006/main">
               <a:ext uri="{FF2B5EF4-FFF2-40B4-BE49-F238E27FC236}">
-                <a16:creationId xmlns:a16="http://schemas.microsoft.com/office/drawing/2014/main" id="{49B8CF20-C52A-4230-9C3B-C9A92748DAA8}"/>
+                <a16:creationId xmlns:a16="http://schemas.microsoft.com/office/drawing/2014/main" id="{D63E3175-09F2-4368-B4A0-AE5521C7506A}"/>
               </a:ext>
             </a:extLst>
           </p:cNvPr>
@@ -12939,7 +12939,7 @@
           <p:cNvPr id="8" name="">
             <a:extLst xmlns:a="http://schemas.openxmlformats.org/drawingml/2006/main">
               <a:ext uri="{FF2B5EF4-FFF2-40B4-BE49-F238E27FC236}">
-                <a16:creationId xmlns:a16="http://schemas.microsoft.com/office/drawing/2014/main" id="{BCDE0D12-7A5B-401B-B5B7-538A1741B7EE}"/>
+                <a16:creationId xmlns:a16="http://schemas.microsoft.com/office/drawing/2014/main" id="{FC2035D0-AA2A-4838-BAEC-1D71C0E24573}"/>
               </a:ext>
             </a:extLst>
           </p:cNvPr>
@@ -13005,7 +13005,7 @@
     </p:spTree>
     <p:extLst>
       <p:ext uri="{BB962C8B-B14F-4D97-AF65-F5344CB8AC3E}">
-        <p14:creationId xmlns:p14="http://schemas.microsoft.com/office/powerpoint/2010/main" val="1167234882"/>
+        <p14:creationId xmlns:p14="http://schemas.microsoft.com/office/powerpoint/2010/main" val="1016602732"/>
       </p:ext>
     </p:extLst>
   </p:cSld>
@@ -13036,7 +13036,7 @@
           <p:cNvPr id="5" name="">
             <a:extLst xmlns:a="http://schemas.openxmlformats.org/drawingml/2006/main">
               <a:ext uri="{FF2B5EF4-FFF2-40B4-BE49-F238E27FC236}">
-                <a16:creationId xmlns:a16="http://schemas.microsoft.com/office/drawing/2014/main" id="{B1361616-85DB-4DFA-B730-5CBE83858869}"/>
+                <a16:creationId xmlns:a16="http://schemas.microsoft.com/office/drawing/2014/main" id="{B49EEA37-EDEE-467F-B555-86799E353997}"/>
               </a:ext>
             </a:extLst>
           </p:cNvPr>
@@ -13104,7 +13104,7 @@
           <p:cNvPr id="2" name="">
             <a:extLst xmlns:a="http://schemas.openxmlformats.org/drawingml/2006/main">
               <a:ext uri="{FF2B5EF4-FFF2-40B4-BE49-F238E27FC236}">
-                <a16:creationId xmlns:a16="http://schemas.microsoft.com/office/drawing/2014/main" id="{14EDBD20-2D60-404D-9B74-F1FAE471B89D}"/>
+                <a16:creationId xmlns:a16="http://schemas.microsoft.com/office/drawing/2014/main" id="{08D57B56-CD7C-4190-8988-5755BF5BD051}"/>
               </a:ext>
             </a:extLst>
           </p:cNvPr>
@@ -13172,7 +13172,7 @@
           <p:cNvPr id="3" name="">
             <a:extLst xmlns:a="http://schemas.openxmlformats.org/drawingml/2006/main">
               <a:ext uri="{FF2B5EF4-FFF2-40B4-BE49-F238E27FC236}">
-                <a16:creationId xmlns:a16="http://schemas.microsoft.com/office/drawing/2014/main" id="{30F2C4C4-293E-444A-8ECB-609A91D8970E}"/>
+                <a16:creationId xmlns:a16="http://schemas.microsoft.com/office/drawing/2014/main" id="{84DA9084-DDE4-431C-9624-DAFF3E56C8DA}"/>
               </a:ext>
             </a:extLst>
           </p:cNvPr>
@@ -15634,7 +15634,7 @@
           <p:cNvPr id="4" name="">
             <a:extLst xmlns:a="http://schemas.openxmlformats.org/drawingml/2006/main">
               <a:ext uri="{FF2B5EF4-FFF2-40B4-BE49-F238E27FC236}">
-                <a16:creationId xmlns:a16="http://schemas.microsoft.com/office/drawing/2014/main" id="{11AD869C-4BA7-4B67-9C20-44FCF29B2397}"/>
+                <a16:creationId xmlns:a16="http://schemas.microsoft.com/office/drawing/2014/main" id="{1D10AC4A-650E-4385-AA0B-3E2566C1FEE7}"/>
               </a:ext>
             </a:extLst>
           </p:cNvPr>
@@ -15700,7 +15700,7 @@
     </p:spTree>
     <p:extLst>
       <p:ext uri="{BB962C8B-B14F-4D97-AF65-F5344CB8AC3E}">
-        <p14:creationId xmlns:p14="http://schemas.microsoft.com/office/powerpoint/2010/main" val="410141550"/>
+        <p14:creationId xmlns:p14="http://schemas.microsoft.com/office/powerpoint/2010/main" val="708895464"/>
       </p:ext>
     </p:extLst>
   </p:cSld>
@@ -15731,7 +15731,7 @@
           <p:cNvPr id="5" name="">
             <a:extLst xmlns:a="http://schemas.openxmlformats.org/drawingml/2006/main">
               <a:ext uri="{FF2B5EF4-FFF2-40B4-BE49-F238E27FC236}">
-                <a16:creationId xmlns:a16="http://schemas.microsoft.com/office/drawing/2014/main" id="{3A234179-B14F-439B-9EA6-45D0A1CA1637}"/>
+                <a16:creationId xmlns:a16="http://schemas.microsoft.com/office/drawing/2014/main" id="{0DB10775-1206-4FBE-87C9-7B2001AABE67}"/>
               </a:ext>
             </a:extLst>
           </p:cNvPr>
@@ -15799,7 +15799,7 @@
           <p:cNvPr id="2" name="">
             <a:extLst xmlns:a="http://schemas.openxmlformats.org/drawingml/2006/main">
               <a:ext uri="{FF2B5EF4-FFF2-40B4-BE49-F238E27FC236}">
-                <a16:creationId xmlns:a16="http://schemas.microsoft.com/office/drawing/2014/main" id="{E55544A7-DE0F-42AB-BA31-1601293ED12D}"/>
+                <a16:creationId xmlns:a16="http://schemas.microsoft.com/office/drawing/2014/main" id="{97FBA525-14FB-4327-8200-76333C049B21}"/>
               </a:ext>
             </a:extLst>
           </p:cNvPr>
@@ -15867,7 +15867,7 @@
           <p:cNvPr id="3" name="">
             <a:extLst xmlns:a="http://schemas.openxmlformats.org/drawingml/2006/main">
               <a:ext uri="{FF2B5EF4-FFF2-40B4-BE49-F238E27FC236}">
-                <a16:creationId xmlns:a16="http://schemas.microsoft.com/office/drawing/2014/main" id="{E2E73DFC-2E98-43E0-9D12-C4E08C218F39}"/>
+                <a16:creationId xmlns:a16="http://schemas.microsoft.com/office/drawing/2014/main" id="{4B13EBC1-2738-41F5-BBC2-7871803DC3E2}"/>
               </a:ext>
             </a:extLst>
           </p:cNvPr>
@@ -18329,7 +18329,7 @@
           <p:cNvPr id="4" name="">
             <a:extLst xmlns:a="http://schemas.openxmlformats.org/drawingml/2006/main">
               <a:ext uri="{FF2B5EF4-FFF2-40B4-BE49-F238E27FC236}">
-                <a16:creationId xmlns:a16="http://schemas.microsoft.com/office/drawing/2014/main" id="{A2F82CD7-CD82-418A-82F0-7BDBFD5BFBF2}"/>
+                <a16:creationId xmlns:a16="http://schemas.microsoft.com/office/drawing/2014/main" id="{B48B1E96-F7EC-478D-8AD9-5A9E11E7883D}"/>
               </a:ext>
             </a:extLst>
           </p:cNvPr>
@@ -18395,7 +18395,7 @@
     </p:spTree>
     <p:extLst>
       <p:ext uri="{BB962C8B-B14F-4D97-AF65-F5344CB8AC3E}">
-        <p14:creationId xmlns:p14="http://schemas.microsoft.com/office/powerpoint/2010/main" val="751323123"/>
+        <p14:creationId xmlns:p14="http://schemas.microsoft.com/office/powerpoint/2010/main" val="398608971"/>
       </p:ext>
     </p:extLst>
   </p:cSld>
@@ -18426,7 +18426,7 @@
           <p:cNvPr id="6" name="">
             <a:extLst xmlns:a="http://schemas.openxmlformats.org/drawingml/2006/main">
               <a:ext uri="{FF2B5EF4-FFF2-40B4-BE49-F238E27FC236}">
-                <a16:creationId xmlns:a16="http://schemas.microsoft.com/office/drawing/2014/main" id="{9EA8EF0E-DB2B-4DB2-A6DB-FA36A88EF77D}"/>
+                <a16:creationId xmlns:a16="http://schemas.microsoft.com/office/drawing/2014/main" id="{C0BD3578-D47C-4D31-B234-4D2830E07382}"/>
               </a:ext>
             </a:extLst>
           </p:cNvPr>
@@ -18494,7 +18494,7 @@
           <p:cNvPr id="2" name="">
             <a:extLst xmlns:a="http://schemas.openxmlformats.org/drawingml/2006/main">
               <a:ext uri="{FF2B5EF4-FFF2-40B4-BE49-F238E27FC236}">
-                <a16:creationId xmlns:a16="http://schemas.microsoft.com/office/drawing/2014/main" id="{DBBD33A4-D8AD-44FA-AE95-A84E200A52DB}"/>
+                <a16:creationId xmlns:a16="http://schemas.microsoft.com/office/drawing/2014/main" id="{92D7DA9D-7455-44C4-A693-CA10D88BA67E}"/>
               </a:ext>
             </a:extLst>
           </p:cNvPr>
@@ -18562,7 +18562,7 @@
           <p:cNvPr id="3" name="">
             <a:extLst xmlns:a="http://schemas.openxmlformats.org/drawingml/2006/main">
               <a:ext uri="{FF2B5EF4-FFF2-40B4-BE49-F238E27FC236}">
-                <a16:creationId xmlns:a16="http://schemas.microsoft.com/office/drawing/2014/main" id="{087C0858-4B0D-4664-9F36-85C411EBE539}"/>
+                <a16:creationId xmlns:a16="http://schemas.microsoft.com/office/drawing/2014/main" id="{D5D84C3F-52A2-4116-A84F-677712DC8C1E}"/>
               </a:ext>
             </a:extLst>
           </p:cNvPr>
@@ -18755,7 +18755,7 @@
           <p:cNvPr id="4" name="">
             <a:extLst xmlns:a="http://schemas.openxmlformats.org/drawingml/2006/main">
               <a:ext uri="{FF2B5EF4-FFF2-40B4-BE49-F238E27FC236}">
-                <a16:creationId xmlns:a16="http://schemas.microsoft.com/office/drawing/2014/main" id="{53B23088-AC1A-4C7E-B154-D4126EB20B1A}"/>
+                <a16:creationId xmlns:a16="http://schemas.microsoft.com/office/drawing/2014/main" id="{C2CA66FC-DF86-4AB1-BB6B-D44B740A815C}"/>
               </a:ext>
             </a:extLst>
           </p:cNvPr>
@@ -18948,7 +18948,7 @@
           <p:cNvPr id="5" name="">
             <a:extLst xmlns:a="http://schemas.openxmlformats.org/drawingml/2006/main">
               <a:ext uri="{FF2B5EF4-FFF2-40B4-BE49-F238E27FC236}">
-                <a16:creationId xmlns:a16="http://schemas.microsoft.com/office/drawing/2014/main" id="{E6F35272-B198-453E-A08F-3E78BE593E2D}"/>
+                <a16:creationId xmlns:a16="http://schemas.microsoft.com/office/drawing/2014/main" id="{7B67C4E1-1BD0-4D41-B13B-B049CF28DB91}"/>
               </a:ext>
             </a:extLst>
           </p:cNvPr>
@@ -19014,7 +19014,7 @@
     </p:spTree>
     <p:extLst>
       <p:ext uri="{BB962C8B-B14F-4D97-AF65-F5344CB8AC3E}">
-        <p14:creationId xmlns:p14="http://schemas.microsoft.com/office/powerpoint/2010/main" val="1879741832"/>
+        <p14:creationId xmlns:p14="http://schemas.microsoft.com/office/powerpoint/2010/main" val="1004856844"/>
       </p:ext>
     </p:extLst>
   </p:cSld>
@@ -19045,7 +19045,7 @@
           <p:cNvPr id="5" name="">
             <a:extLst xmlns:a="http://schemas.openxmlformats.org/drawingml/2006/main">
               <a:ext uri="{FF2B5EF4-FFF2-40B4-BE49-F238E27FC236}">
-                <a16:creationId xmlns:a16="http://schemas.microsoft.com/office/drawing/2014/main" id="{E9988B4B-C953-4AA7-8B43-6EB9C00D9A21}"/>
+                <a16:creationId xmlns:a16="http://schemas.microsoft.com/office/drawing/2014/main" id="{6D717808-8E3C-4909-B77D-C8CB60DD56E2}"/>
               </a:ext>
             </a:extLst>
           </p:cNvPr>
@@ -19113,7 +19113,7 @@
           <p:cNvPr id="2" name="">
             <a:extLst xmlns:a="http://schemas.openxmlformats.org/drawingml/2006/main">
               <a:ext uri="{FF2B5EF4-FFF2-40B4-BE49-F238E27FC236}">
-                <a16:creationId xmlns:a16="http://schemas.microsoft.com/office/drawing/2014/main" id="{5C181EDD-62CB-4295-A15A-2473CD8A8CF2}"/>
+                <a16:creationId xmlns:a16="http://schemas.microsoft.com/office/drawing/2014/main" id="{08F7F5BB-E7BB-49D7-82CB-56FBEF0A2566}"/>
               </a:ext>
             </a:extLst>
           </p:cNvPr>
@@ -19181,7 +19181,7 @@
           <p:cNvPr id="3" name="">
             <a:extLst xmlns:a="http://schemas.openxmlformats.org/drawingml/2006/main">
               <a:ext uri="{FF2B5EF4-FFF2-40B4-BE49-F238E27FC236}">
-                <a16:creationId xmlns:a16="http://schemas.microsoft.com/office/drawing/2014/main" id="{36167DC7-D571-4BD1-913F-6ECB6CA4D1F1}"/>
+                <a16:creationId xmlns:a16="http://schemas.microsoft.com/office/drawing/2014/main" id="{CB0078B5-872F-409E-8FF4-E6C47D74F593}"/>
               </a:ext>
             </a:extLst>
           </p:cNvPr>
@@ -19397,7 +19397,7 @@
           <p:cNvPr id="4" name="">
             <a:extLst xmlns:a="http://schemas.openxmlformats.org/drawingml/2006/main">
               <a:ext uri="{FF2B5EF4-FFF2-40B4-BE49-F238E27FC236}">
-                <a16:creationId xmlns:a16="http://schemas.microsoft.com/office/drawing/2014/main" id="{3F6C3762-4F93-4173-A0A7-E49C07C411FF}"/>
+                <a16:creationId xmlns:a16="http://schemas.microsoft.com/office/drawing/2014/main" id="{77A9708E-ADD2-460D-8910-A1221699BB46}"/>
               </a:ext>
             </a:extLst>
           </p:cNvPr>
@@ -19463,7 +19463,7 @@
     </p:spTree>
     <p:extLst>
       <p:ext uri="{BB962C8B-B14F-4D97-AF65-F5344CB8AC3E}">
-        <p14:creationId xmlns:p14="http://schemas.microsoft.com/office/powerpoint/2010/main" val="1311579941"/>
+        <p14:creationId xmlns:p14="http://schemas.microsoft.com/office/powerpoint/2010/main" val="683723529"/>
       </p:ext>
     </p:extLst>
   </p:cSld>
@@ -19494,7 +19494,7 @@
           <p:cNvPr id="10" name="">
             <a:extLst xmlns:a="http://schemas.openxmlformats.org/drawingml/2006/main">
               <a:ext uri="{FF2B5EF4-FFF2-40B4-BE49-F238E27FC236}">
-                <a16:creationId xmlns:a16="http://schemas.microsoft.com/office/drawing/2014/main" id="{79B130AA-D1F3-4637-B091-8D2F590C60E8}"/>
+                <a16:creationId xmlns:a16="http://schemas.microsoft.com/office/drawing/2014/main" id="{605DAF6F-056F-414E-920F-2390C50AA5A6}"/>
               </a:ext>
             </a:extLst>
           </p:cNvPr>
@@ -19562,7 +19562,7 @@
           <p:cNvPr id="2" name="">
             <a:extLst xmlns:a="http://schemas.openxmlformats.org/drawingml/2006/main">
               <a:ext uri="{FF2B5EF4-FFF2-40B4-BE49-F238E27FC236}">
-                <a16:creationId xmlns:a16="http://schemas.microsoft.com/office/drawing/2014/main" id="{19167071-3E81-465D-911F-E0C12BFD4D01}"/>
+                <a16:creationId xmlns:a16="http://schemas.microsoft.com/office/drawing/2014/main" id="{4280E86A-FF65-476E-870A-ECD34D6F87CD}"/>
               </a:ext>
             </a:extLst>
           </p:cNvPr>
@@ -19630,7 +19630,7 @@
           <p:cNvPr id="3" name="">
             <a:extLst xmlns:a="http://schemas.openxmlformats.org/drawingml/2006/main">
               <a:ext uri="{FF2B5EF4-FFF2-40B4-BE49-F238E27FC236}">
-                <a16:creationId xmlns:a16="http://schemas.microsoft.com/office/drawing/2014/main" id="{FB63E25D-29BB-41E9-A3D9-3E8E8D4A60CC}"/>
+                <a16:creationId xmlns:a16="http://schemas.microsoft.com/office/drawing/2014/main" id="{9D9ABE75-22BD-48E4-98DD-D16E8C5D74A9}"/>
               </a:ext>
             </a:extLst>
           </p:cNvPr>
@@ -19698,7 +19698,7 @@
           <p:cNvPr id="4" name="">
             <a:extLst xmlns:a="http://schemas.openxmlformats.org/drawingml/2006/main">
               <a:ext uri="{FF2B5EF4-FFF2-40B4-BE49-F238E27FC236}">
-                <a16:creationId xmlns:a16="http://schemas.microsoft.com/office/drawing/2014/main" id="{F5AFD732-A16A-45CA-8C6C-E8794D24D1DC}"/>
+                <a16:creationId xmlns:a16="http://schemas.microsoft.com/office/drawing/2014/main" id="{AAC55D26-5E07-40B0-8425-623377BB33C2}"/>
               </a:ext>
             </a:extLst>
           </p:cNvPr>
@@ -19766,7 +19766,7 @@
           <p:cNvPr id="5" name="">
             <a:extLst xmlns:a="http://schemas.openxmlformats.org/drawingml/2006/main">
               <a:ext uri="{FF2B5EF4-FFF2-40B4-BE49-F238E27FC236}">
-                <a16:creationId xmlns:a16="http://schemas.microsoft.com/office/drawing/2014/main" id="{A8538DCE-DFAA-4236-9BD5-AAF130D76CE7}"/>
+                <a16:creationId xmlns:a16="http://schemas.microsoft.com/office/drawing/2014/main" id="{088DC407-5E5C-4B6A-9844-E1973B7D62A5}"/>
               </a:ext>
             </a:extLst>
           </p:cNvPr>
@@ -19834,7 +19834,7 @@
           <p:cNvPr id="6" name="">
             <a:extLst xmlns:a="http://schemas.openxmlformats.org/drawingml/2006/main">
               <a:ext uri="{FF2B5EF4-FFF2-40B4-BE49-F238E27FC236}">
-                <a16:creationId xmlns:a16="http://schemas.microsoft.com/office/drawing/2014/main" id="{0405FC78-1817-4D86-B81D-B7D7E65029C2}"/>
+                <a16:creationId xmlns:a16="http://schemas.microsoft.com/office/drawing/2014/main" id="{2EDAEC29-0A6E-4BD0-8976-2FBEBF4E9F01}"/>
               </a:ext>
             </a:extLst>
           </p:cNvPr>
@@ -19902,7 +19902,7 @@
           <p:cNvPr id="7" name="">
             <a:extLst xmlns:a="http://schemas.openxmlformats.org/drawingml/2006/main">
               <a:ext uri="{FF2B5EF4-FFF2-40B4-BE49-F238E27FC236}">
-                <a16:creationId xmlns:a16="http://schemas.microsoft.com/office/drawing/2014/main" id="{DB85A234-7E82-4E73-98A0-A5EF60C5D321}"/>
+                <a16:creationId xmlns:a16="http://schemas.microsoft.com/office/drawing/2014/main" id="{870E7566-102E-471F-B36C-ABDD5FCA5D63}"/>
               </a:ext>
             </a:extLst>
           </p:cNvPr>
@@ -19970,7 +19970,7 @@
           <p:cNvPr id="8" name="">
             <a:extLst xmlns:a="http://schemas.openxmlformats.org/drawingml/2006/main">
               <a:ext uri="{FF2B5EF4-FFF2-40B4-BE49-F238E27FC236}">
-                <a16:creationId xmlns:a16="http://schemas.microsoft.com/office/drawing/2014/main" id="{052B3F1B-6787-4457-8D2D-1C8A8DA5B67A}"/>
+                <a16:creationId xmlns:a16="http://schemas.microsoft.com/office/drawing/2014/main" id="{865E4D3A-93DD-4908-B445-7F1ED2B6E652}"/>
               </a:ext>
             </a:extLst>
           </p:cNvPr>
@@ -20038,7 +20038,7 @@
           <p:cNvPr id="9" name="">
             <a:extLst xmlns:a="http://schemas.openxmlformats.org/drawingml/2006/main">
               <a:ext uri="{FF2B5EF4-FFF2-40B4-BE49-F238E27FC236}">
-                <a16:creationId xmlns:a16="http://schemas.microsoft.com/office/drawing/2014/main" id="{05904EE9-1E7E-4CD3-98BC-01D00FD0E2CC}"/>
+                <a16:creationId xmlns:a16="http://schemas.microsoft.com/office/drawing/2014/main" id="{B15681E1-8531-4AB5-B742-E06AA1CFB075}"/>
               </a:ext>
             </a:extLst>
           </p:cNvPr>
@@ -20104,7 +20104,7 @@
     </p:spTree>
     <p:extLst>
       <p:ext uri="{BB962C8B-B14F-4D97-AF65-F5344CB8AC3E}">
-        <p14:creationId xmlns:p14="http://schemas.microsoft.com/office/powerpoint/2010/main" val="1883795539"/>
+        <p14:creationId xmlns:p14="http://schemas.microsoft.com/office/powerpoint/2010/main" val="501018077"/>
       </p:ext>
     </p:extLst>
   </p:cSld>
@@ -20135,7 +20135,7 @@
           <p:cNvPr id="6" name="">
             <a:extLst xmlns:a="http://schemas.openxmlformats.org/drawingml/2006/main">
               <a:ext uri="{FF2B5EF4-FFF2-40B4-BE49-F238E27FC236}">
-                <a16:creationId xmlns:a16="http://schemas.microsoft.com/office/drawing/2014/main" id="{38D7ADBD-EACB-4CF1-9CA5-7AE69558D0CE}"/>
+                <a16:creationId xmlns:a16="http://schemas.microsoft.com/office/drawing/2014/main" id="{B3FB6CC0-3A6F-40CB-81B2-E79BF4D068AC}"/>
               </a:ext>
             </a:extLst>
           </p:cNvPr>
@@ -20203,7 +20203,7 @@
           <p:cNvPr id="2" name="">
             <a:extLst xmlns:a="http://schemas.openxmlformats.org/drawingml/2006/main">
               <a:ext uri="{FF2B5EF4-FFF2-40B4-BE49-F238E27FC236}">
-                <a16:creationId xmlns:a16="http://schemas.microsoft.com/office/drawing/2014/main" id="{D2D1A4CD-E99B-4A75-8BC3-22FBB964CDA8}"/>
+                <a16:creationId xmlns:a16="http://schemas.microsoft.com/office/drawing/2014/main" id="{9427679A-1DED-42D8-B41F-440AB27C2AAD}"/>
               </a:ext>
             </a:extLst>
           </p:cNvPr>
@@ -20271,7 +20271,7 @@
           <p:cNvPr id="3" name="">
             <a:extLst xmlns:a="http://schemas.openxmlformats.org/drawingml/2006/main">
               <a:ext uri="{FF2B5EF4-FFF2-40B4-BE49-F238E27FC236}">
-                <a16:creationId xmlns:a16="http://schemas.microsoft.com/office/drawing/2014/main" id="{AC46E254-F738-4D45-A0D7-54230698ED8E}"/>
+                <a16:creationId xmlns:a16="http://schemas.microsoft.com/office/drawing/2014/main" id="{190D5F3B-45EF-4309-A078-29166279E5E7}"/>
               </a:ext>
             </a:extLst>
           </p:cNvPr>
@@ -20903,7 +20903,7 @@
           <p:cNvPr id="4" name="">
             <a:extLst xmlns:a="http://schemas.openxmlformats.org/drawingml/2006/main">
               <a:ext uri="{FF2B5EF4-FFF2-40B4-BE49-F238E27FC236}">
-                <a16:creationId xmlns:a16="http://schemas.microsoft.com/office/drawing/2014/main" id="{9A5D2D8E-511D-4363-856B-EF5C7F4A4827}"/>
+                <a16:creationId xmlns:a16="http://schemas.microsoft.com/office/drawing/2014/main" id="{B07C9162-E095-4F9C-90B0-BE2861A4E520}"/>
               </a:ext>
             </a:extLst>
           </p:cNvPr>
@@ -20971,7 +20971,7 @@
           <p:cNvPr id="5" name="">
             <a:extLst xmlns:a="http://schemas.openxmlformats.org/drawingml/2006/main">
               <a:ext uri="{FF2B5EF4-FFF2-40B4-BE49-F238E27FC236}">
-                <a16:creationId xmlns:a16="http://schemas.microsoft.com/office/drawing/2014/main" id="{2576ED56-6A24-4D7D-9F3E-78EE8DF007B1}"/>
+                <a16:creationId xmlns:a16="http://schemas.microsoft.com/office/drawing/2014/main" id="{6DC490D5-C604-4FA2-9C0F-088A64A9FF8E}"/>
               </a:ext>
             </a:extLst>
           </p:cNvPr>
@@ -21037,7 +21037,7 @@
     </p:spTree>
     <p:extLst>
       <p:ext uri="{BB962C8B-B14F-4D97-AF65-F5344CB8AC3E}">
-        <p14:creationId xmlns:p14="http://schemas.microsoft.com/office/powerpoint/2010/main" val="523832917"/>
+        <p14:creationId xmlns:p14="http://schemas.microsoft.com/office/powerpoint/2010/main" val="1038208312"/>
       </p:ext>
     </p:extLst>
   </p:cSld>
@@ -21068,7 +21068,7 @@
           <p:cNvPr id="5" name="">
             <a:extLst xmlns:a="http://schemas.openxmlformats.org/drawingml/2006/main">
               <a:ext uri="{FF2B5EF4-FFF2-40B4-BE49-F238E27FC236}">
-                <a16:creationId xmlns:a16="http://schemas.microsoft.com/office/drawing/2014/main" id="{3FEFC81D-0F52-4754-83BB-5ABFCC3A7382}"/>
+                <a16:creationId xmlns:a16="http://schemas.microsoft.com/office/drawing/2014/main" id="{1680DA28-D3E3-492B-A7E6-E929DCE8787F}"/>
               </a:ext>
             </a:extLst>
           </p:cNvPr>
@@ -21136,7 +21136,7 @@
           <p:cNvPr id="2" name="">
             <a:extLst xmlns:a="http://schemas.openxmlformats.org/drawingml/2006/main">
               <a:ext uri="{FF2B5EF4-FFF2-40B4-BE49-F238E27FC236}">
-                <a16:creationId xmlns:a16="http://schemas.microsoft.com/office/drawing/2014/main" id="{FD02C08E-0389-4F04-81A8-412879E15456}"/>
+                <a16:creationId xmlns:a16="http://schemas.microsoft.com/office/drawing/2014/main" id="{0BE3E08B-BD11-4629-AC00-BA60A734D4BD}"/>
               </a:ext>
             </a:extLst>
           </p:cNvPr>
@@ -21204,7 +21204,7 @@
           <p:cNvPr id="3" name="">
             <a:extLst xmlns:a="http://schemas.openxmlformats.org/drawingml/2006/main">
               <a:ext uri="{FF2B5EF4-FFF2-40B4-BE49-F238E27FC236}">
-                <a16:creationId xmlns:a16="http://schemas.microsoft.com/office/drawing/2014/main" id="{79CBE3C9-3893-4ABF-B958-2F47FD86946C}"/>
+                <a16:creationId xmlns:a16="http://schemas.microsoft.com/office/drawing/2014/main" id="{6F0FECB3-8E5C-47AD-9F9D-46DB91915239}"/>
               </a:ext>
             </a:extLst>
           </p:cNvPr>
@@ -21838,7 +21838,7 @@
           <p:cNvPr id="4" name="">
             <a:extLst xmlns:a="http://schemas.openxmlformats.org/drawingml/2006/main">
               <a:ext uri="{FF2B5EF4-FFF2-40B4-BE49-F238E27FC236}">
-                <a16:creationId xmlns:a16="http://schemas.microsoft.com/office/drawing/2014/main" id="{06724937-9526-4C15-A869-FB05F9FC7844}"/>
+                <a16:creationId xmlns:a16="http://schemas.microsoft.com/office/drawing/2014/main" id="{21AD33CC-2016-4285-B641-604D1ECA2F3E}"/>
               </a:ext>
             </a:extLst>
           </p:cNvPr>
@@ -21904,7 +21904,7 @@
     </p:spTree>
     <p:extLst>
       <p:ext uri="{BB962C8B-B14F-4D97-AF65-F5344CB8AC3E}">
-        <p14:creationId xmlns:p14="http://schemas.microsoft.com/office/powerpoint/2010/main" val="385649138"/>
+        <p14:creationId xmlns:p14="http://schemas.microsoft.com/office/powerpoint/2010/main" val="909161515"/>
       </p:ext>
     </p:extLst>
   </p:cSld>
@@ -21935,7 +21935,7 @@
           <p:cNvPr id="6" name="">
             <a:extLst xmlns:a="http://schemas.openxmlformats.org/drawingml/2006/main">
               <a:ext uri="{FF2B5EF4-FFF2-40B4-BE49-F238E27FC236}">
-                <a16:creationId xmlns:a16="http://schemas.microsoft.com/office/drawing/2014/main" id="{170FAC82-18C1-4FDC-BB55-9E3F0EFC2ED8}"/>
+                <a16:creationId xmlns:a16="http://schemas.microsoft.com/office/drawing/2014/main" id="{85636749-4BD7-4F28-8D75-8756941B37DE}"/>
               </a:ext>
             </a:extLst>
           </p:cNvPr>
@@ -22003,7 +22003,7 @@
           <p:cNvPr id="2" name="">
             <a:extLst xmlns:a="http://schemas.openxmlformats.org/drawingml/2006/main">
               <a:ext uri="{FF2B5EF4-FFF2-40B4-BE49-F238E27FC236}">
-                <a16:creationId xmlns:a16="http://schemas.microsoft.com/office/drawing/2014/main" id="{0E73EAC9-31DE-4F14-A878-2EC0314C4032}"/>
+                <a16:creationId xmlns:a16="http://schemas.microsoft.com/office/drawing/2014/main" id="{2C939076-77A0-4DC4-9D20-BC809B4307B3}"/>
               </a:ext>
             </a:extLst>
           </p:cNvPr>
@@ -22071,7 +22071,7 @@
           <p:cNvPr id="3" name="">
             <a:extLst xmlns:a="http://schemas.openxmlformats.org/drawingml/2006/main">
               <a:ext uri="{FF2B5EF4-FFF2-40B4-BE49-F238E27FC236}">
-                <a16:creationId xmlns:a16="http://schemas.microsoft.com/office/drawing/2014/main" id="{99C2130C-8FE1-40DF-8B4A-8F4AB3DF31FC}"/>
+                <a16:creationId xmlns:a16="http://schemas.microsoft.com/office/drawing/2014/main" id="{9B1B3DDC-DA7A-433A-BD8F-787890D5906D}"/>
               </a:ext>
             </a:extLst>
           </p:cNvPr>
@@ -22162,7 +22162,7 @@
           <p:cNvPr id="4" name="">
             <a:extLst xmlns:a="http://schemas.openxmlformats.org/drawingml/2006/main">
               <a:ext uri="{FF2B5EF4-FFF2-40B4-BE49-F238E27FC236}">
-                <a16:creationId xmlns:a16="http://schemas.microsoft.com/office/drawing/2014/main" id="{C551A21C-B965-4BE6-A395-D63F5177741E}"/>
+                <a16:creationId xmlns:a16="http://schemas.microsoft.com/office/drawing/2014/main" id="{4E506AAB-DC59-4FB9-AF12-5B0B4C7046EA}"/>
               </a:ext>
             </a:extLst>
           </p:cNvPr>
@@ -22230,7 +22230,7 @@
           <p:cNvPr id="5" name="">
             <a:extLst xmlns:a="http://schemas.openxmlformats.org/drawingml/2006/main">
               <a:ext uri="{FF2B5EF4-FFF2-40B4-BE49-F238E27FC236}">
-                <a16:creationId xmlns:a16="http://schemas.microsoft.com/office/drawing/2014/main" id="{B5BCC41B-402B-4EB9-8AD7-FE27FE9EA881}"/>
+                <a16:creationId xmlns:a16="http://schemas.microsoft.com/office/drawing/2014/main" id="{B9A9543D-AA34-4298-8EA2-CBEC439214C4}"/>
               </a:ext>
             </a:extLst>
           </p:cNvPr>
@@ -22342,7 +22342,7 @@
     </p:spTree>
     <p:extLst>
       <p:ext uri="{BB962C8B-B14F-4D97-AF65-F5344CB8AC3E}">
-        <p14:creationId xmlns:p14="http://schemas.microsoft.com/office/powerpoint/2010/main" val="2102538728"/>
+        <p14:creationId xmlns:p14="http://schemas.microsoft.com/office/powerpoint/2010/main" val="1199997592"/>
       </p:ext>
     </p:extLst>
   </p:cSld>
@@ -22373,7 +22373,7 @@
           <p:cNvPr id="6" name="">
             <a:extLst xmlns:a="http://schemas.openxmlformats.org/drawingml/2006/main">
               <a:ext uri="{FF2B5EF4-FFF2-40B4-BE49-F238E27FC236}">
-                <a16:creationId xmlns:a16="http://schemas.microsoft.com/office/drawing/2014/main" id="{A49E2302-7F77-4978-91D2-B36ADD89A9F2}"/>
+                <a16:creationId xmlns:a16="http://schemas.microsoft.com/office/drawing/2014/main" id="{57920315-627D-430A-8B36-8E610E7D0A18}"/>
               </a:ext>
             </a:extLst>
           </p:cNvPr>
@@ -22441,7 +22441,7 @@
           <p:cNvPr id="2" name="">
             <a:extLst xmlns:a="http://schemas.openxmlformats.org/drawingml/2006/main">
               <a:ext uri="{FF2B5EF4-FFF2-40B4-BE49-F238E27FC236}">
-                <a16:creationId xmlns:a16="http://schemas.microsoft.com/office/drawing/2014/main" id="{3A11D6AE-C99A-4BED-A421-9CEA2B7A96AF}"/>
+                <a16:creationId xmlns:a16="http://schemas.microsoft.com/office/drawing/2014/main" id="{692F7209-B0B3-43EA-A8B7-79D945BB2041}"/>
               </a:ext>
             </a:extLst>
           </p:cNvPr>
@@ -22509,7 +22509,7 @@
           <p:cNvPr id="3" name="">
             <a:extLst xmlns:a="http://schemas.openxmlformats.org/drawingml/2006/main">
               <a:ext uri="{FF2B5EF4-FFF2-40B4-BE49-F238E27FC236}">
-                <a16:creationId xmlns:a16="http://schemas.microsoft.com/office/drawing/2014/main" id="{4BC01BB9-8292-4904-80B9-4CB65B3DA40E}"/>
+                <a16:creationId xmlns:a16="http://schemas.microsoft.com/office/drawing/2014/main" id="{08F47A04-73AF-4F77-8140-704817075B1E}"/>
               </a:ext>
             </a:extLst>
           </p:cNvPr>
@@ -22577,7 +22577,7 @@
           <p:cNvPr id="4" name="">
             <a:extLst xmlns:a="http://schemas.openxmlformats.org/drawingml/2006/main">
               <a:ext uri="{FF2B5EF4-FFF2-40B4-BE49-F238E27FC236}">
-                <a16:creationId xmlns:a16="http://schemas.microsoft.com/office/drawing/2014/main" id="{56FB9871-EF68-460C-9745-B7078E32EC36}"/>
+                <a16:creationId xmlns:a16="http://schemas.microsoft.com/office/drawing/2014/main" id="{A023D28F-A8AF-4EAC-B3BB-FB4F740D9C17}"/>
               </a:ext>
             </a:extLst>
           </p:cNvPr>
@@ -22858,7 +22858,7 @@
           <p:cNvPr id="5" name="">
             <a:extLst xmlns:a="http://schemas.openxmlformats.org/drawingml/2006/main">
               <a:ext uri="{FF2B5EF4-FFF2-40B4-BE49-F238E27FC236}">
-                <a16:creationId xmlns:a16="http://schemas.microsoft.com/office/drawing/2014/main" id="{06447E91-6212-4AD2-9144-2F3B0746AE91}"/>
+                <a16:creationId xmlns:a16="http://schemas.microsoft.com/office/drawing/2014/main" id="{26D600A7-D4EB-4E51-879F-75D2865EFA3C}"/>
               </a:ext>
             </a:extLst>
           </p:cNvPr>
@@ -22924,7 +22924,7 @@
     </p:spTree>
     <p:extLst>
       <p:ext uri="{BB962C8B-B14F-4D97-AF65-F5344CB8AC3E}">
-        <p14:creationId xmlns:p14="http://schemas.microsoft.com/office/powerpoint/2010/main" val="712887683"/>
+        <p14:creationId xmlns:p14="http://schemas.microsoft.com/office/powerpoint/2010/main" val="1973926663"/>
       </p:ext>
     </p:extLst>
   </p:cSld>
@@ -22955,7 +22955,7 @@
           <p:cNvPr id="5" name="">
             <a:extLst xmlns:a="http://schemas.openxmlformats.org/drawingml/2006/main">
               <a:ext uri="{FF2B5EF4-FFF2-40B4-BE49-F238E27FC236}">
-                <a16:creationId xmlns:a16="http://schemas.microsoft.com/office/drawing/2014/main" id="{E8792F5D-5F3A-4D2A-86ED-E8513E19B5E3}"/>
+                <a16:creationId xmlns:a16="http://schemas.microsoft.com/office/drawing/2014/main" id="{E891ACB3-AEED-4531-8CB3-C5D5FE367E83}"/>
               </a:ext>
             </a:extLst>
           </p:cNvPr>
@@ -23023,7 +23023,7 @@
           <p:cNvPr id="2" name="">
             <a:extLst xmlns:a="http://schemas.openxmlformats.org/drawingml/2006/main">
               <a:ext uri="{FF2B5EF4-FFF2-40B4-BE49-F238E27FC236}">
-                <a16:creationId xmlns:a16="http://schemas.microsoft.com/office/drawing/2014/main" id="{93E48B29-E6AA-460C-BB38-4DFA0DEEFB7B}"/>
+                <a16:creationId xmlns:a16="http://schemas.microsoft.com/office/drawing/2014/main" id="{3EFEB732-E612-48B9-9A44-7E3590116766}"/>
               </a:ext>
             </a:extLst>
           </p:cNvPr>
@@ -23091,7 +23091,7 @@
           <p:cNvPr id="3" name="">
             <a:extLst xmlns:a="http://schemas.openxmlformats.org/drawingml/2006/main">
               <a:ext uri="{FF2B5EF4-FFF2-40B4-BE49-F238E27FC236}">
-                <a16:creationId xmlns:a16="http://schemas.microsoft.com/office/drawing/2014/main" id="{70322C7B-D276-449D-96C9-27431DC78447}"/>
+                <a16:creationId xmlns:a16="http://schemas.microsoft.com/office/drawing/2014/main" id="{83BDCB21-1586-42F8-9C6E-AD737FA1618A}"/>
               </a:ext>
             </a:extLst>
           </p:cNvPr>
@@ -23725,7 +23725,7 @@
           <p:cNvPr id="4" name="">
             <a:extLst xmlns:a="http://schemas.openxmlformats.org/drawingml/2006/main">
               <a:ext uri="{FF2B5EF4-FFF2-40B4-BE49-F238E27FC236}">
-                <a16:creationId xmlns:a16="http://schemas.microsoft.com/office/drawing/2014/main" id="{AEF4A021-78FF-4047-83E1-037BD01D2513}"/>
+                <a16:creationId xmlns:a16="http://schemas.microsoft.com/office/drawing/2014/main" id="{DB47FF12-6748-4032-9ECA-3D8A9EED0C66}"/>
               </a:ext>
             </a:extLst>
           </p:cNvPr>
@@ -23791,7 +23791,7 @@
     </p:spTree>
     <p:extLst>
       <p:ext uri="{BB962C8B-B14F-4D97-AF65-F5344CB8AC3E}">
-        <p14:creationId xmlns:p14="http://schemas.microsoft.com/office/powerpoint/2010/main" val="2009096512"/>
+        <p14:creationId xmlns:p14="http://schemas.microsoft.com/office/powerpoint/2010/main" val="1843502014"/>
       </p:ext>
     </p:extLst>
   </p:cSld>
@@ -23822,7 +23822,7 @@
           <p:cNvPr id="5" name="">
             <a:extLst xmlns:a="http://schemas.openxmlformats.org/drawingml/2006/main">
               <a:ext uri="{FF2B5EF4-FFF2-40B4-BE49-F238E27FC236}">
-                <a16:creationId xmlns:a16="http://schemas.microsoft.com/office/drawing/2014/main" id="{D5860B18-0BD8-4D70-A2AF-6A0143484971}"/>
+                <a16:creationId xmlns:a16="http://schemas.microsoft.com/office/drawing/2014/main" id="{686635EE-D9B4-499A-B812-5D875443A938}"/>
               </a:ext>
             </a:extLst>
           </p:cNvPr>
@@ -23890,7 +23890,7 @@
           <p:cNvPr id="2" name="">
             <a:extLst xmlns:a="http://schemas.openxmlformats.org/drawingml/2006/main">
               <a:ext uri="{FF2B5EF4-FFF2-40B4-BE49-F238E27FC236}">
-                <a16:creationId xmlns:a16="http://schemas.microsoft.com/office/drawing/2014/main" id="{36D9DE36-2A9D-4060-B4F6-17E8EEAD0277}"/>
+                <a16:creationId xmlns:a16="http://schemas.microsoft.com/office/drawing/2014/main" id="{21708370-24B4-455B-8355-D584B87D0E33}"/>
               </a:ext>
             </a:extLst>
           </p:cNvPr>
@@ -23958,7 +23958,7 @@
           <p:cNvPr id="3" name="">
             <a:extLst xmlns:a="http://schemas.openxmlformats.org/drawingml/2006/main">
               <a:ext uri="{FF2B5EF4-FFF2-40B4-BE49-F238E27FC236}">
-                <a16:creationId xmlns:a16="http://schemas.microsoft.com/office/drawing/2014/main" id="{A3C89D07-6257-4706-8DB9-AAA1B99476A7}"/>
+                <a16:creationId xmlns:a16="http://schemas.microsoft.com/office/drawing/2014/main" id="{44C52383-2E1A-4EBF-AC8C-D7E8FF2F28E5}"/>
               </a:ext>
             </a:extLst>
           </p:cNvPr>
@@ -24938,7 +24938,7 @@
           <p:cNvPr id="4" name="">
             <a:extLst xmlns:a="http://schemas.openxmlformats.org/drawingml/2006/main">
               <a:ext uri="{FF2B5EF4-FFF2-40B4-BE49-F238E27FC236}">
-                <a16:creationId xmlns:a16="http://schemas.microsoft.com/office/drawing/2014/main" id="{3786AB83-1348-4E85-BA99-F54907ECC516}"/>
+                <a16:creationId xmlns:a16="http://schemas.microsoft.com/office/drawing/2014/main" id="{8BB346E7-ADFF-4C93-B857-73D7BE560305}"/>
               </a:ext>
             </a:extLst>
           </p:cNvPr>
@@ -25004,7 +25004,7 @@
     </p:spTree>
     <p:extLst>
       <p:ext uri="{BB962C8B-B14F-4D97-AF65-F5344CB8AC3E}">
-        <p14:creationId xmlns:p14="http://schemas.microsoft.com/office/powerpoint/2010/main" val="332118172"/>
+        <p14:creationId xmlns:p14="http://schemas.microsoft.com/office/powerpoint/2010/main" val="933048927"/>
       </p:ext>
     </p:extLst>
   </p:cSld>

</xml_diff>